<commit_message>
Add multi-seed federated robustness evidence
</commit_message>
<xml_diff>
--- a/submission/final_pitch_deck.pptx
+++ b/submission/final_pitch_deck.pptx
@@ -2,22 +2,22 @@
 <file path=ppt/presentation.xml><?xml version="1.0" encoding="utf-8"?>
 <p:presentation xmlns:p="http://schemas.openxmlformats.org/presentationml/2006/main">
   <p:sldMasterIdLst>
-    <p:sldMasterId xmlns:r="http://schemas.openxmlformats.org/officeDocument/2006/relationships" id="2147483648" r:id="Ra1fc89b0aedb494c"/>
+    <p:sldMasterId xmlns:r="http://schemas.openxmlformats.org/officeDocument/2006/relationships" id="2147483648" r:id="R0fad656aef2d4fd9"/>
   </p:sldMasterIdLst>
   <p:notesMasterIdLst>
-    <p:notesMasterId xmlns:r="http://schemas.openxmlformats.org/officeDocument/2006/relationships" r:id="R43b0831a13b644bf"/>
+    <p:notesMasterId xmlns:r="http://schemas.openxmlformats.org/officeDocument/2006/relationships" r:id="R142da48f27164bf4"/>
   </p:notesMasterIdLst>
   <p:sldIdLst>
-    <p:sldId xmlns:r="http://schemas.openxmlformats.org/officeDocument/2006/relationships" id="256" r:id="Rae3b73c74c9c45b2"/>
-    <p:sldId xmlns:r="http://schemas.openxmlformats.org/officeDocument/2006/relationships" id="257" r:id="Rcd2c230a5df348bf"/>
-    <p:sldId xmlns:r="http://schemas.openxmlformats.org/officeDocument/2006/relationships" id="258" r:id="Rd9f0c62c898240d0"/>
-    <p:sldId xmlns:r="http://schemas.openxmlformats.org/officeDocument/2006/relationships" id="259" r:id="R24933b83640246c8"/>
-    <p:sldId xmlns:r="http://schemas.openxmlformats.org/officeDocument/2006/relationships" id="260" r:id="Rfffcf9df90ea4e0f"/>
-    <p:sldId xmlns:r="http://schemas.openxmlformats.org/officeDocument/2006/relationships" id="261" r:id="Raa0d7e6b2f44413b"/>
-    <p:sldId xmlns:r="http://schemas.openxmlformats.org/officeDocument/2006/relationships" id="262" r:id="Rfba2f48945c34b69"/>
-    <p:sldId xmlns:r="http://schemas.openxmlformats.org/officeDocument/2006/relationships" id="263" r:id="R03a3a2f62a924c1d"/>
-    <p:sldId xmlns:r="http://schemas.openxmlformats.org/officeDocument/2006/relationships" id="264" r:id="R32cda3e0f9a6427c"/>
-    <p:sldId xmlns:r="http://schemas.openxmlformats.org/officeDocument/2006/relationships" id="265" r:id="Rae8dd623b13f451c"/>
+    <p:sldId xmlns:r="http://schemas.openxmlformats.org/officeDocument/2006/relationships" id="256" r:id="R1b96bfc8e46e42b5"/>
+    <p:sldId xmlns:r="http://schemas.openxmlformats.org/officeDocument/2006/relationships" id="257" r:id="Raeaf84b357c04d66"/>
+    <p:sldId xmlns:r="http://schemas.openxmlformats.org/officeDocument/2006/relationships" id="258" r:id="R6f58a3bbdbe44d77"/>
+    <p:sldId xmlns:r="http://schemas.openxmlformats.org/officeDocument/2006/relationships" id="259" r:id="Rc3f2421838fb4e4b"/>
+    <p:sldId xmlns:r="http://schemas.openxmlformats.org/officeDocument/2006/relationships" id="260" r:id="R7f03523f9bc84105"/>
+    <p:sldId xmlns:r="http://schemas.openxmlformats.org/officeDocument/2006/relationships" id="261" r:id="R60b032471da14580"/>
+    <p:sldId xmlns:r="http://schemas.openxmlformats.org/officeDocument/2006/relationships" id="262" r:id="R898dc85c344c4651"/>
+    <p:sldId xmlns:r="http://schemas.openxmlformats.org/officeDocument/2006/relationships" id="263" r:id="R4508ba75334d448c"/>
+    <p:sldId xmlns:r="http://schemas.openxmlformats.org/officeDocument/2006/relationships" id="264" r:id="R3d3d3df5144e41e5"/>
+    <p:sldId xmlns:r="http://schemas.openxmlformats.org/officeDocument/2006/relationships" id="265" r:id="Ra05555899284461e"/>
   </p:sldIdLst>
   <p:sldSz cx="12192000" cy="6858000"/>
   <p:notesSz cx="6858000" cy="9144000"/>
@@ -1204,7 +1204,7 @@
   </p:cSld>
   <p:clrMap bg1="lt1" tx1="dk1" bg2="lt2" tx2="dk2" accent1="accent1" accent2="accent2" accent3="accent3" accent4="accent4" accent5="accent5" accent6="accent6" hlink="hlink" folHlink="folHlink"/>
   <p:sldLayoutIdLst>
-    <p:sldLayoutId xmlns:r="http://schemas.openxmlformats.org/officeDocument/2006/relationships" id="2147483649" r:id="R83ae9d608f34491d"/>
+    <p:sldLayoutId xmlns:r="http://schemas.openxmlformats.org/officeDocument/2006/relationships" id="2147483649" r:id="Ra665a8608aff418d"/>
   </p:sldLayoutIdLst>
   <p:txStyles>
     <p:titleStyle>
@@ -1755,7 +1755,7 @@
           <p:cNvPr id="1" name="">
             <a:extLst xmlns:a="http://schemas.openxmlformats.org/drawingml/2006/main">
               <a:ext uri="{FF2B5EF4-FFF2-40B4-BE49-F238E27FC236}">
-                <a16:creationId xmlns:a16="http://schemas.microsoft.com/office/drawing/2014/main" id="{C6CE61C6-0616-47B5-8EE0-E7B050A22BC5}"/>
+                <a16:creationId xmlns:a16="http://schemas.microsoft.com/office/drawing/2014/main" id="{1A3C446C-805D-4A4A-A409-26566C2D26A3}"/>
               </a:ext>
             </a:extLst>
           </p:cNvPr>
@@ -1786,7 +1786,7 @@
           <p:cNvPr id="2" name="">
             <a:extLst xmlns:a="http://schemas.openxmlformats.org/drawingml/2006/main">
               <a:ext uri="{FF2B5EF4-FFF2-40B4-BE49-F238E27FC236}">
-                <a16:creationId xmlns:a16="http://schemas.microsoft.com/office/drawing/2014/main" id="{4E7CF43F-3027-4FBD-8C60-8A46E4938F92}"/>
+                <a16:creationId xmlns:a16="http://schemas.microsoft.com/office/drawing/2014/main" id="{3EB217F0-2732-42F7-ADCF-D98F192ACC1F}"/>
               </a:ext>
             </a:extLst>
           </p:cNvPr>
@@ -1836,7 +1836,7 @@
           <p:cNvPr id="3" name="">
             <a:extLst xmlns:a="http://schemas.openxmlformats.org/drawingml/2006/main">
               <a:ext uri="{FF2B5EF4-FFF2-40B4-BE49-F238E27FC236}">
-                <a16:creationId xmlns:a16="http://schemas.microsoft.com/office/drawing/2014/main" id="{DF9F839C-0246-413B-8AA1-86F575AC33A1}"/>
+                <a16:creationId xmlns:a16="http://schemas.microsoft.com/office/drawing/2014/main" id="{B4CAADFA-9034-4330-B67B-383563F6658D}"/>
               </a:ext>
             </a:extLst>
           </p:cNvPr>
@@ -1903,7 +1903,7 @@
           <p:cNvPr id="4" name="">
             <a:extLst xmlns:a="http://schemas.openxmlformats.org/drawingml/2006/main">
               <a:ext uri="{FF2B5EF4-FFF2-40B4-BE49-F238E27FC236}">
-                <a16:creationId xmlns:a16="http://schemas.microsoft.com/office/drawing/2014/main" id="{16C4FD4D-A275-480A-8A28-500B01A0A2BF}"/>
+                <a16:creationId xmlns:a16="http://schemas.microsoft.com/office/drawing/2014/main" id="{3FD728CD-909D-40EB-8759-E273D1E2E581}"/>
               </a:ext>
             </a:extLst>
           </p:cNvPr>
@@ -1953,7 +1953,7 @@
           <p:cNvPr id="5" name="">
             <a:extLst xmlns:a="http://schemas.openxmlformats.org/drawingml/2006/main">
               <a:ext uri="{FF2B5EF4-FFF2-40B4-BE49-F238E27FC236}">
-                <a16:creationId xmlns:a16="http://schemas.microsoft.com/office/drawing/2014/main" id="{52C0C681-C344-437D-B5DB-5F5FDC98890E}"/>
+                <a16:creationId xmlns:a16="http://schemas.microsoft.com/office/drawing/2014/main" id="{5D987F70-26D8-4143-A4C0-0EC7FF0CF6E4}"/>
               </a:ext>
             </a:extLst>
           </p:cNvPr>
@@ -1984,7 +1984,7 @@
           <p:cNvPr id="6" name="">
             <a:extLst xmlns:a="http://schemas.openxmlformats.org/drawingml/2006/main">
               <a:ext uri="{FF2B5EF4-FFF2-40B4-BE49-F238E27FC236}">
-                <a16:creationId xmlns:a16="http://schemas.microsoft.com/office/drawing/2014/main" id="{139E1C73-EC7D-4D54-9111-78E465CB1999}"/>
+                <a16:creationId xmlns:a16="http://schemas.microsoft.com/office/drawing/2014/main" id="{B3A95949-C2CF-4267-8FAB-A68B00427666}"/>
               </a:ext>
             </a:extLst>
           </p:cNvPr>
@@ -2051,7 +2051,7 @@
           <p:cNvPr id="7" name="">
             <a:extLst xmlns:a="http://schemas.openxmlformats.org/drawingml/2006/main">
               <a:ext uri="{FF2B5EF4-FFF2-40B4-BE49-F238E27FC236}">
-                <a16:creationId xmlns:a16="http://schemas.microsoft.com/office/drawing/2014/main" id="{CFB4FCD3-F21C-4FCC-BAE0-61FA240DD9F6}"/>
+                <a16:creationId xmlns:a16="http://schemas.microsoft.com/office/drawing/2014/main" id="{C3B0E2E1-E26F-49D9-B57C-CF6E95B438DF}"/>
               </a:ext>
             </a:extLst>
           </p:cNvPr>
@@ -2090,7 +2090,7 @@
           <p:nvPr/>
         </p:nvPicPr>
         <p:blipFill>
-          <a:blip xmlns:r="http://schemas.openxmlformats.org/officeDocument/2006/relationships" xmlns:a="http://schemas.openxmlformats.org/drawingml/2006/main" r:embed="R8081e239b5e1493e"/>
+          <a:blip xmlns:r="http://schemas.openxmlformats.org/officeDocument/2006/relationships" xmlns:a="http://schemas.openxmlformats.org/drawingml/2006/main" r:embed="R55efdd49af8e4b1d"/>
           <a:srcRect xmlns:a="http://schemas.openxmlformats.org/drawingml/2006/main" l="11597" t="0" r="11597" b="0"/>
           <a:stretch xmlns:a="http://schemas.openxmlformats.org/drawingml/2006/main">
             <a:fillRect l="0" t="0" r="0" b="0"/>
@@ -2113,7 +2113,7 @@
           <p:cNvPr id="9" name="">
             <a:extLst xmlns:a="http://schemas.openxmlformats.org/drawingml/2006/main">
               <a:ext uri="{FF2B5EF4-FFF2-40B4-BE49-F238E27FC236}">
-                <a16:creationId xmlns:a16="http://schemas.microsoft.com/office/drawing/2014/main" id="{19B96EA8-5646-4051-BD41-69AD7245DEF0}"/>
+                <a16:creationId xmlns:a16="http://schemas.microsoft.com/office/drawing/2014/main" id="{187C65A0-0F9F-4F13-9911-96A67BC08C66}"/>
               </a:ext>
             </a:extLst>
           </p:cNvPr>
@@ -2161,7 +2161,7 @@
     </p:spTree>
     <p:extLst>
       <p:ext uri="{BB962C8B-B14F-4D97-AF65-F5344CB8AC3E}">
-        <p14:creationId xmlns:p14="http://schemas.microsoft.com/office/powerpoint/2010/main" val="1296438188"/>
+        <p14:creationId xmlns:p14="http://schemas.microsoft.com/office/powerpoint/2010/main" val="164397156"/>
       </p:ext>
     </p:extLst>
   </p:cSld>
@@ -2192,7 +2192,7 @@
           <p:cNvPr id="1" name="">
             <a:extLst xmlns:a="http://schemas.openxmlformats.org/drawingml/2006/main">
               <a:ext uri="{FF2B5EF4-FFF2-40B4-BE49-F238E27FC236}">
-                <a16:creationId xmlns:a16="http://schemas.microsoft.com/office/drawing/2014/main" id="{D4CA5288-0DCC-4E8E-8BE5-1212CFBE5EDA}"/>
+                <a16:creationId xmlns:a16="http://schemas.microsoft.com/office/drawing/2014/main" id="{8BFB2717-6F2F-4ACD-A4A2-D1990543B9BF}"/>
               </a:ext>
             </a:extLst>
           </p:cNvPr>
@@ -2242,7 +2242,7 @@
           <p:cNvPr id="2" name="">
             <a:extLst xmlns:a="http://schemas.openxmlformats.org/drawingml/2006/main">
               <a:ext uri="{FF2B5EF4-FFF2-40B4-BE49-F238E27FC236}">
-                <a16:creationId xmlns:a16="http://schemas.microsoft.com/office/drawing/2014/main" id="{4E359C87-FE17-4D92-86FB-82F97143FA9E}"/>
+                <a16:creationId xmlns:a16="http://schemas.microsoft.com/office/drawing/2014/main" id="{C57328DE-D718-494A-80D4-42151ADD35AA}"/>
               </a:ext>
             </a:extLst>
           </p:cNvPr>
@@ -2309,7 +2309,7 @@
           <p:cNvPr id="3" name="">
             <a:extLst xmlns:a="http://schemas.openxmlformats.org/drawingml/2006/main">
               <a:ext uri="{FF2B5EF4-FFF2-40B4-BE49-F238E27FC236}">
-                <a16:creationId xmlns:a16="http://schemas.microsoft.com/office/drawing/2014/main" id="{9BD79156-7970-447C-A8ED-269D41468593}"/>
+                <a16:creationId xmlns:a16="http://schemas.microsoft.com/office/drawing/2014/main" id="{97BDF7EC-FAFE-4D43-9DD8-303225230351}"/>
               </a:ext>
             </a:extLst>
           </p:cNvPr>
@@ -2344,7 +2344,7 @@
           <p:cNvPr id="4" name="">
             <a:extLst xmlns:a="http://schemas.openxmlformats.org/drawingml/2006/main">
               <a:ext uri="{FF2B5EF4-FFF2-40B4-BE49-F238E27FC236}">
-                <a16:creationId xmlns:a16="http://schemas.microsoft.com/office/drawing/2014/main" id="{55395BD1-0F32-44B7-915E-E06CB914046E}"/>
+                <a16:creationId xmlns:a16="http://schemas.microsoft.com/office/drawing/2014/main" id="{B87C97A0-C86E-4223-937C-E1E249D89685}"/>
               </a:ext>
             </a:extLst>
           </p:cNvPr>
@@ -2394,7 +2394,7 @@
           <p:cNvPr id="5" name="">
             <a:extLst xmlns:a="http://schemas.openxmlformats.org/drawingml/2006/main">
               <a:ext uri="{FF2B5EF4-FFF2-40B4-BE49-F238E27FC236}">
-                <a16:creationId xmlns:a16="http://schemas.microsoft.com/office/drawing/2014/main" id="{A8BD6AC1-8FC2-4905-9754-652277AAAB60}"/>
+                <a16:creationId xmlns:a16="http://schemas.microsoft.com/office/drawing/2014/main" id="{03AEA5AB-8731-4F9D-8283-27EE080EBD11}"/>
               </a:ext>
             </a:extLst>
           </p:cNvPr>
@@ -2444,7 +2444,7 @@
           <p:cNvPr id="6" name="">
             <a:extLst xmlns:a="http://schemas.openxmlformats.org/drawingml/2006/main">
               <a:ext uri="{FF2B5EF4-FFF2-40B4-BE49-F238E27FC236}">
-                <a16:creationId xmlns:a16="http://schemas.microsoft.com/office/drawing/2014/main" id="{C891C5DE-BECA-4CFB-B521-A71AA828D8F8}"/>
+                <a16:creationId xmlns:a16="http://schemas.microsoft.com/office/drawing/2014/main" id="{77861274-FCED-473D-B3CE-AC433B87CBBF}"/>
               </a:ext>
             </a:extLst>
           </p:cNvPr>
@@ -2479,7 +2479,7 @@
           <p:cNvPr id="7" name="">
             <a:extLst xmlns:a="http://schemas.openxmlformats.org/drawingml/2006/main">
               <a:ext uri="{FF2B5EF4-FFF2-40B4-BE49-F238E27FC236}">
-                <a16:creationId xmlns:a16="http://schemas.microsoft.com/office/drawing/2014/main" id="{440D6EDD-14F6-49E2-8831-5EA16BE494C9}"/>
+                <a16:creationId xmlns:a16="http://schemas.microsoft.com/office/drawing/2014/main" id="{2EB7148E-9665-4783-A730-782286C00E83}"/>
               </a:ext>
             </a:extLst>
           </p:cNvPr>
@@ -2529,7 +2529,7 @@
           <p:cNvPr id="8" name="">
             <a:extLst xmlns:a="http://schemas.openxmlformats.org/drawingml/2006/main">
               <a:ext uri="{FF2B5EF4-FFF2-40B4-BE49-F238E27FC236}">
-                <a16:creationId xmlns:a16="http://schemas.microsoft.com/office/drawing/2014/main" id="{F53F7065-8157-4CD9-99A5-DDE632BE01A2}"/>
+                <a16:creationId xmlns:a16="http://schemas.microsoft.com/office/drawing/2014/main" id="{343D03A2-277B-464D-84AD-8C6E90E0CA23}"/>
               </a:ext>
             </a:extLst>
           </p:cNvPr>
@@ -2579,7 +2579,7 @@
           <p:cNvPr id="9" name="">
             <a:extLst xmlns:a="http://schemas.openxmlformats.org/drawingml/2006/main">
               <a:ext uri="{FF2B5EF4-FFF2-40B4-BE49-F238E27FC236}">
-                <a16:creationId xmlns:a16="http://schemas.microsoft.com/office/drawing/2014/main" id="{3E023D53-A9C8-43ED-B470-AB731CB60506}"/>
+                <a16:creationId xmlns:a16="http://schemas.microsoft.com/office/drawing/2014/main" id="{A6D382E5-5FFA-448B-87CD-3C6D69F52CDC}"/>
               </a:ext>
             </a:extLst>
           </p:cNvPr>
@@ -2614,7 +2614,7 @@
           <p:cNvPr id="10" name="">
             <a:extLst xmlns:a="http://schemas.openxmlformats.org/drawingml/2006/main">
               <a:ext uri="{FF2B5EF4-FFF2-40B4-BE49-F238E27FC236}">
-                <a16:creationId xmlns:a16="http://schemas.microsoft.com/office/drawing/2014/main" id="{3A884B2A-CB3E-45AF-B00B-BA1BF8EE3D13}"/>
+                <a16:creationId xmlns:a16="http://schemas.microsoft.com/office/drawing/2014/main" id="{E4E64EF0-9521-46C5-98B8-1EC2F68DD4CE}"/>
               </a:ext>
             </a:extLst>
           </p:cNvPr>
@@ -2664,7 +2664,7 @@
           <p:cNvPr id="11" name="">
             <a:extLst xmlns:a="http://schemas.openxmlformats.org/drawingml/2006/main">
               <a:ext uri="{FF2B5EF4-FFF2-40B4-BE49-F238E27FC236}">
-                <a16:creationId xmlns:a16="http://schemas.microsoft.com/office/drawing/2014/main" id="{86C15124-CF22-44F7-81E9-B090A5C39373}"/>
+                <a16:creationId xmlns:a16="http://schemas.microsoft.com/office/drawing/2014/main" id="{19FD4348-C76D-486E-848D-1A7FBBA85565}"/>
               </a:ext>
             </a:extLst>
           </p:cNvPr>
@@ -2714,7 +2714,7 @@
           <p:cNvPr id="12" name="">
             <a:extLst xmlns:a="http://schemas.openxmlformats.org/drawingml/2006/main">
               <a:ext uri="{FF2B5EF4-FFF2-40B4-BE49-F238E27FC236}">
-                <a16:creationId xmlns:a16="http://schemas.microsoft.com/office/drawing/2014/main" id="{4166AB1E-0BB2-4C1C-967A-960AB4386A55}"/>
+                <a16:creationId xmlns:a16="http://schemas.microsoft.com/office/drawing/2014/main" id="{25EE8B36-9FA7-4A2E-BF0B-B7F4B94E7A22}"/>
               </a:ext>
             </a:extLst>
           </p:cNvPr>
@@ -2764,7 +2764,7 @@
           <p:cNvPr id="13" name="">
             <a:extLst xmlns:a="http://schemas.openxmlformats.org/drawingml/2006/main">
               <a:ext uri="{FF2B5EF4-FFF2-40B4-BE49-F238E27FC236}">
-                <a16:creationId xmlns:a16="http://schemas.microsoft.com/office/drawing/2014/main" id="{318D664C-25C9-4C48-A432-0467B6C82585}"/>
+                <a16:creationId xmlns:a16="http://schemas.microsoft.com/office/drawing/2014/main" id="{9CA16142-4BB9-44C6-9EBE-B8F5E438F746}"/>
               </a:ext>
             </a:extLst>
           </p:cNvPr>
@@ -2814,7 +2814,7 @@
           <p:cNvPr id="14" name="">
             <a:extLst xmlns:a="http://schemas.openxmlformats.org/drawingml/2006/main">
               <a:ext uri="{FF2B5EF4-FFF2-40B4-BE49-F238E27FC236}">
-                <a16:creationId xmlns:a16="http://schemas.microsoft.com/office/drawing/2014/main" id="{D2D6F131-3AC6-4B91-BC09-DD5C79275863}"/>
+                <a16:creationId xmlns:a16="http://schemas.microsoft.com/office/drawing/2014/main" id="{7FE24E25-8A48-4545-94BA-DA66CB88B2A7}"/>
               </a:ext>
             </a:extLst>
           </p:cNvPr>
@@ -2862,7 +2862,7 @@
     </p:spTree>
     <p:extLst>
       <p:ext uri="{BB962C8B-B14F-4D97-AF65-F5344CB8AC3E}">
-        <p14:creationId xmlns:p14="http://schemas.microsoft.com/office/powerpoint/2010/main" val="1413891216"/>
+        <p14:creationId xmlns:p14="http://schemas.microsoft.com/office/powerpoint/2010/main" val="2021658369"/>
       </p:ext>
     </p:extLst>
   </p:cSld>
@@ -2893,7 +2893,7 @@
           <p:cNvPr id="1" name="">
             <a:extLst xmlns:a="http://schemas.openxmlformats.org/drawingml/2006/main">
               <a:ext uri="{FF2B5EF4-FFF2-40B4-BE49-F238E27FC236}">
-                <a16:creationId xmlns:a16="http://schemas.microsoft.com/office/drawing/2014/main" id="{9BC317FF-9AD2-41AC-B11F-CA5DD38BF010}"/>
+                <a16:creationId xmlns:a16="http://schemas.microsoft.com/office/drawing/2014/main" id="{D00CCEB7-0966-4732-86E2-95BC3E5C019B}"/>
               </a:ext>
             </a:extLst>
           </p:cNvPr>
@@ -2924,7 +2924,7 @@
           <p:cNvPr id="2" name="">
             <a:extLst xmlns:a="http://schemas.openxmlformats.org/drawingml/2006/main">
               <a:ext uri="{FF2B5EF4-FFF2-40B4-BE49-F238E27FC236}">
-                <a16:creationId xmlns:a16="http://schemas.microsoft.com/office/drawing/2014/main" id="{5B48D834-83C0-4F82-8C73-86724B9ACA52}"/>
+                <a16:creationId xmlns:a16="http://schemas.microsoft.com/office/drawing/2014/main" id="{367F4217-1E8D-4570-B641-A19E85DD3B7D}"/>
               </a:ext>
             </a:extLst>
           </p:cNvPr>
@@ -2974,7 +2974,7 @@
           <p:cNvPr id="3" name="">
             <a:extLst xmlns:a="http://schemas.openxmlformats.org/drawingml/2006/main">
               <a:ext uri="{FF2B5EF4-FFF2-40B4-BE49-F238E27FC236}">
-                <a16:creationId xmlns:a16="http://schemas.microsoft.com/office/drawing/2014/main" id="{112345CE-FF4F-4533-BC64-417350FA565E}"/>
+                <a16:creationId xmlns:a16="http://schemas.microsoft.com/office/drawing/2014/main" id="{D16D4560-6167-4FEE-A359-A86F530496D3}"/>
               </a:ext>
             </a:extLst>
           </p:cNvPr>
@@ -3024,7 +3024,7 @@
           <p:cNvPr id="4" name="">
             <a:extLst xmlns:a="http://schemas.openxmlformats.org/drawingml/2006/main">
               <a:ext uri="{FF2B5EF4-FFF2-40B4-BE49-F238E27FC236}">
-                <a16:creationId xmlns:a16="http://schemas.microsoft.com/office/drawing/2014/main" id="{C8DA5EE6-57EE-44F9-A219-8C4C91CE6578}"/>
+                <a16:creationId xmlns:a16="http://schemas.microsoft.com/office/drawing/2014/main" id="{287A8971-0E57-42D5-942F-18329B9C986B}"/>
               </a:ext>
             </a:extLst>
           </p:cNvPr>
@@ -3055,7 +3055,7 @@
           <p:cNvPr id="5" name="">
             <a:extLst xmlns:a="http://schemas.openxmlformats.org/drawingml/2006/main">
               <a:ext uri="{FF2B5EF4-FFF2-40B4-BE49-F238E27FC236}">
-                <a16:creationId xmlns:a16="http://schemas.microsoft.com/office/drawing/2014/main" id="{222AB224-3A03-452D-8E69-E7DDD7FA38A4}"/>
+                <a16:creationId xmlns:a16="http://schemas.microsoft.com/office/drawing/2014/main" id="{9991EF8F-F202-4D76-83D7-EF075D574751}"/>
               </a:ext>
             </a:extLst>
           </p:cNvPr>
@@ -3105,7 +3105,7 @@
           <p:cNvPr id="6" name="">
             <a:extLst xmlns:a="http://schemas.openxmlformats.org/drawingml/2006/main">
               <a:ext uri="{FF2B5EF4-FFF2-40B4-BE49-F238E27FC236}">
-                <a16:creationId xmlns:a16="http://schemas.microsoft.com/office/drawing/2014/main" id="{D43547B4-C8EE-4726-B30D-4916FC24CD9C}"/>
+                <a16:creationId xmlns:a16="http://schemas.microsoft.com/office/drawing/2014/main" id="{A414BE03-9F34-4867-B37C-0FBF8420A4CB}"/>
               </a:ext>
             </a:extLst>
           </p:cNvPr>
@@ -3155,7 +3155,7 @@
           <p:cNvPr id="7" name="">
             <a:extLst xmlns:a="http://schemas.openxmlformats.org/drawingml/2006/main">
               <a:ext uri="{FF2B5EF4-FFF2-40B4-BE49-F238E27FC236}">
-                <a16:creationId xmlns:a16="http://schemas.microsoft.com/office/drawing/2014/main" id="{6FD6E37C-E680-4C2E-A967-DE2D2CEA719B}"/>
+                <a16:creationId xmlns:a16="http://schemas.microsoft.com/office/drawing/2014/main" id="{804F6DF3-4A1A-435E-A73C-38F59FA8262B}"/>
               </a:ext>
             </a:extLst>
           </p:cNvPr>
@@ -3205,7 +3205,7 @@
           <p:cNvPr id="8" name="">
             <a:extLst xmlns:a="http://schemas.openxmlformats.org/drawingml/2006/main">
               <a:ext uri="{FF2B5EF4-FFF2-40B4-BE49-F238E27FC236}">
-                <a16:creationId xmlns:a16="http://schemas.microsoft.com/office/drawing/2014/main" id="{E1E5D02C-77B6-4D5C-96AE-D3D71DF25322}"/>
+                <a16:creationId xmlns:a16="http://schemas.microsoft.com/office/drawing/2014/main" id="{96C49E47-3746-4F1F-BC15-5BE925B5E8C4}"/>
               </a:ext>
             </a:extLst>
           </p:cNvPr>
@@ -3255,7 +3255,7 @@
           <p:cNvPr id="9" name="">
             <a:extLst xmlns:a="http://schemas.openxmlformats.org/drawingml/2006/main">
               <a:ext uri="{FF2B5EF4-FFF2-40B4-BE49-F238E27FC236}">
-                <a16:creationId xmlns:a16="http://schemas.microsoft.com/office/drawing/2014/main" id="{F395FE8B-F20B-429D-84A6-D582DA71AF14}"/>
+                <a16:creationId xmlns:a16="http://schemas.microsoft.com/office/drawing/2014/main" id="{42CF5F60-33CC-47CC-A098-6655D05971FC}"/>
               </a:ext>
             </a:extLst>
           </p:cNvPr>
@@ -3305,7 +3305,7 @@
           <p:cNvPr id="10" name="">
             <a:extLst xmlns:a="http://schemas.openxmlformats.org/drawingml/2006/main">
               <a:ext uri="{FF2B5EF4-FFF2-40B4-BE49-F238E27FC236}">
-                <a16:creationId xmlns:a16="http://schemas.microsoft.com/office/drawing/2014/main" id="{B5D04DFB-A889-4160-874E-D0D0CC605D12}"/>
+                <a16:creationId xmlns:a16="http://schemas.microsoft.com/office/drawing/2014/main" id="{CD62713A-1DEA-4642-BE9B-05251790E64A}"/>
               </a:ext>
             </a:extLst>
           </p:cNvPr>
@@ -3355,7 +3355,7 @@
           <p:cNvPr id="11" name="">
             <a:extLst xmlns:a="http://schemas.openxmlformats.org/drawingml/2006/main">
               <a:ext uri="{FF2B5EF4-FFF2-40B4-BE49-F238E27FC236}">
-                <a16:creationId xmlns:a16="http://schemas.microsoft.com/office/drawing/2014/main" id="{5DA16522-44FF-44D6-A383-0AF2B2E9240B}"/>
+                <a16:creationId xmlns:a16="http://schemas.microsoft.com/office/drawing/2014/main" id="{82402986-1C9F-4001-BE7D-AF2A0B94C56A}"/>
               </a:ext>
             </a:extLst>
           </p:cNvPr>
@@ -3405,7 +3405,7 @@
           <p:cNvPr id="12" name="">
             <a:extLst xmlns:a="http://schemas.openxmlformats.org/drawingml/2006/main">
               <a:ext uri="{FF2B5EF4-FFF2-40B4-BE49-F238E27FC236}">
-                <a16:creationId xmlns:a16="http://schemas.microsoft.com/office/drawing/2014/main" id="{63DC4D07-328A-4074-A9D9-FF71A8E3C211}"/>
+                <a16:creationId xmlns:a16="http://schemas.microsoft.com/office/drawing/2014/main" id="{6C96EA4C-B241-49B5-A440-1884605229B4}"/>
               </a:ext>
             </a:extLst>
           </p:cNvPr>
@@ -3455,7 +3455,7 @@
           <p:cNvPr id="13" name="">
             <a:extLst xmlns:a="http://schemas.openxmlformats.org/drawingml/2006/main">
               <a:ext uri="{FF2B5EF4-FFF2-40B4-BE49-F238E27FC236}">
-                <a16:creationId xmlns:a16="http://schemas.microsoft.com/office/drawing/2014/main" id="{B634FA9D-5ED9-4DEC-BDA7-EED462E96580}"/>
+                <a16:creationId xmlns:a16="http://schemas.microsoft.com/office/drawing/2014/main" id="{410B91FC-E5A5-465B-96F3-E572E2E7FD85}"/>
               </a:ext>
             </a:extLst>
           </p:cNvPr>
@@ -3505,7 +3505,7 @@
           <p:cNvPr id="14" name="">
             <a:extLst xmlns:a="http://schemas.openxmlformats.org/drawingml/2006/main">
               <a:ext uri="{FF2B5EF4-FFF2-40B4-BE49-F238E27FC236}">
-                <a16:creationId xmlns:a16="http://schemas.microsoft.com/office/drawing/2014/main" id="{7D2C49B5-DCB0-48FA-99E9-3C7C189D46DB}"/>
+                <a16:creationId xmlns:a16="http://schemas.microsoft.com/office/drawing/2014/main" id="{335938E6-B035-417E-91EC-4644139F122E}"/>
               </a:ext>
             </a:extLst>
           </p:cNvPr>
@@ -3555,7 +3555,7 @@
           <p:cNvPr id="15" name="">
             <a:extLst xmlns:a="http://schemas.openxmlformats.org/drawingml/2006/main">
               <a:ext uri="{FF2B5EF4-FFF2-40B4-BE49-F238E27FC236}">
-                <a16:creationId xmlns:a16="http://schemas.microsoft.com/office/drawing/2014/main" id="{38023888-195B-46B5-9992-A407CA56496D}"/>
+                <a16:creationId xmlns:a16="http://schemas.microsoft.com/office/drawing/2014/main" id="{C313EED4-68FB-4BB0-B74C-4CCC5410E313}"/>
               </a:ext>
             </a:extLst>
           </p:cNvPr>
@@ -3605,7 +3605,7 @@
           <p:cNvPr id="16" name="">
             <a:extLst xmlns:a="http://schemas.openxmlformats.org/drawingml/2006/main">
               <a:ext uri="{FF2B5EF4-FFF2-40B4-BE49-F238E27FC236}">
-                <a16:creationId xmlns:a16="http://schemas.microsoft.com/office/drawing/2014/main" id="{E5CABA18-19D9-47D8-A108-1AFD41EC58AA}"/>
+                <a16:creationId xmlns:a16="http://schemas.microsoft.com/office/drawing/2014/main" id="{7B02C9D7-8EAD-43FF-9AB2-1F5F03680F18}"/>
               </a:ext>
             </a:extLst>
           </p:cNvPr>
@@ -3640,7 +3640,7 @@
           <p:cNvPr id="17" name="">
             <a:extLst xmlns:a="http://schemas.openxmlformats.org/drawingml/2006/main">
               <a:ext uri="{FF2B5EF4-FFF2-40B4-BE49-F238E27FC236}">
-                <a16:creationId xmlns:a16="http://schemas.microsoft.com/office/drawing/2014/main" id="{E0ED7F69-BB7D-4CD8-B7B0-13B50D1F6E46}"/>
+                <a16:creationId xmlns:a16="http://schemas.microsoft.com/office/drawing/2014/main" id="{A2D7FA00-8E36-4E0A-A66A-70F4B47A8CE6}"/>
               </a:ext>
             </a:extLst>
           </p:cNvPr>
@@ -3690,7 +3690,7 @@
           <p:cNvPr id="18" name="">
             <a:extLst xmlns:a="http://schemas.openxmlformats.org/drawingml/2006/main">
               <a:ext uri="{FF2B5EF4-FFF2-40B4-BE49-F238E27FC236}">
-                <a16:creationId xmlns:a16="http://schemas.microsoft.com/office/drawing/2014/main" id="{4A422230-49A6-4392-8132-4C3FCB6119FF}"/>
+                <a16:creationId xmlns:a16="http://schemas.microsoft.com/office/drawing/2014/main" id="{7F14168D-DCDB-4A81-B737-4E8C512D6D36}"/>
               </a:ext>
             </a:extLst>
           </p:cNvPr>
@@ -3740,7 +3740,7 @@
           <p:cNvPr id="19" name="">
             <a:extLst xmlns:a="http://schemas.openxmlformats.org/drawingml/2006/main">
               <a:ext uri="{FF2B5EF4-FFF2-40B4-BE49-F238E27FC236}">
-                <a16:creationId xmlns:a16="http://schemas.microsoft.com/office/drawing/2014/main" id="{B30604F7-864D-4FC0-8834-273B9E7595EB}"/>
+                <a16:creationId xmlns:a16="http://schemas.microsoft.com/office/drawing/2014/main" id="{91E52147-086E-4B6C-9721-8EEAACDA7CA6}"/>
               </a:ext>
             </a:extLst>
           </p:cNvPr>
@@ -3790,7 +3790,7 @@
           <p:cNvPr id="20" name="">
             <a:extLst xmlns:a="http://schemas.openxmlformats.org/drawingml/2006/main">
               <a:ext uri="{FF2B5EF4-FFF2-40B4-BE49-F238E27FC236}">
-                <a16:creationId xmlns:a16="http://schemas.microsoft.com/office/drawing/2014/main" id="{BFE20634-1357-47C7-853E-F9A2543D6ED9}"/>
+                <a16:creationId xmlns:a16="http://schemas.microsoft.com/office/drawing/2014/main" id="{CDF3A346-30BC-455E-AEC8-3D02816EA9C9}"/>
               </a:ext>
             </a:extLst>
           </p:cNvPr>
@@ -3840,7 +3840,7 @@
           <p:cNvPr id="21" name="">
             <a:extLst xmlns:a="http://schemas.openxmlformats.org/drawingml/2006/main">
               <a:ext uri="{FF2B5EF4-FFF2-40B4-BE49-F238E27FC236}">
-                <a16:creationId xmlns:a16="http://schemas.microsoft.com/office/drawing/2014/main" id="{68710988-34E0-44A2-AC40-3849218361FC}"/>
+                <a16:creationId xmlns:a16="http://schemas.microsoft.com/office/drawing/2014/main" id="{B4E50639-4F0A-42F8-8605-76A6AC6BEDDB}"/>
               </a:ext>
             </a:extLst>
           </p:cNvPr>
@@ -3888,7 +3888,7 @@
     </p:spTree>
     <p:extLst>
       <p:ext uri="{BB962C8B-B14F-4D97-AF65-F5344CB8AC3E}">
-        <p14:creationId xmlns:p14="http://schemas.microsoft.com/office/powerpoint/2010/main" val="41995570"/>
+        <p14:creationId xmlns:p14="http://schemas.microsoft.com/office/powerpoint/2010/main" val="1406837493"/>
       </p:ext>
     </p:extLst>
   </p:cSld>
@@ -3919,7 +3919,7 @@
           <p:cNvPr id="1" name="">
             <a:extLst xmlns:a="http://schemas.openxmlformats.org/drawingml/2006/main">
               <a:ext uri="{FF2B5EF4-FFF2-40B4-BE49-F238E27FC236}">
-                <a16:creationId xmlns:a16="http://schemas.microsoft.com/office/drawing/2014/main" id="{03D439C3-2D2F-49AA-A39C-6D641C86C8D5}"/>
+                <a16:creationId xmlns:a16="http://schemas.microsoft.com/office/drawing/2014/main" id="{2816477F-8F01-4BC0-A65F-36901F1BE33B}"/>
               </a:ext>
             </a:extLst>
           </p:cNvPr>
@@ -3950,7 +3950,7 @@
           <p:cNvPr id="2" name="">
             <a:extLst xmlns:a="http://schemas.openxmlformats.org/drawingml/2006/main">
               <a:ext uri="{FF2B5EF4-FFF2-40B4-BE49-F238E27FC236}">
-                <a16:creationId xmlns:a16="http://schemas.microsoft.com/office/drawing/2014/main" id="{B9341181-6376-4F1A-997F-C88A4BB17409}"/>
+                <a16:creationId xmlns:a16="http://schemas.microsoft.com/office/drawing/2014/main" id="{322EFF28-ACA1-4AC8-8723-9E1F90EFCEC8}"/>
               </a:ext>
             </a:extLst>
           </p:cNvPr>
@@ -4000,7 +4000,7 @@
           <p:cNvPr id="3" name="">
             <a:extLst xmlns:a="http://schemas.openxmlformats.org/drawingml/2006/main">
               <a:ext uri="{FF2B5EF4-FFF2-40B4-BE49-F238E27FC236}">
-                <a16:creationId xmlns:a16="http://schemas.microsoft.com/office/drawing/2014/main" id="{B0A7D4F0-17EA-4037-BBD7-0807C7B18273}"/>
+                <a16:creationId xmlns:a16="http://schemas.microsoft.com/office/drawing/2014/main" id="{B86DFFAC-43E0-46B5-A2CA-73F92419B9DF}"/>
               </a:ext>
             </a:extLst>
           </p:cNvPr>
@@ -4050,7 +4050,7 @@
           <p:cNvPr id="4" name="">
             <a:extLst xmlns:a="http://schemas.openxmlformats.org/drawingml/2006/main">
               <a:ext uri="{FF2B5EF4-FFF2-40B4-BE49-F238E27FC236}">
-                <a16:creationId xmlns:a16="http://schemas.microsoft.com/office/drawing/2014/main" id="{86B869C9-7F2F-41AA-BD15-1C4370B88C21}"/>
+                <a16:creationId xmlns:a16="http://schemas.microsoft.com/office/drawing/2014/main" id="{A5816C0D-93DD-4549-9BEE-D3492E4A29AE}"/>
               </a:ext>
             </a:extLst>
           </p:cNvPr>
@@ -4081,7 +4081,7 @@
           <p:cNvPr id="5" name="">
             <a:extLst xmlns:a="http://schemas.openxmlformats.org/drawingml/2006/main">
               <a:ext uri="{FF2B5EF4-FFF2-40B4-BE49-F238E27FC236}">
-                <a16:creationId xmlns:a16="http://schemas.microsoft.com/office/drawing/2014/main" id="{C647AD5F-299D-44EF-AD7E-BCCEA43A88D5}"/>
+                <a16:creationId xmlns:a16="http://schemas.microsoft.com/office/drawing/2014/main" id="{BC82C1E6-F61E-4492-A2CF-4278EA872288}"/>
               </a:ext>
             </a:extLst>
           </p:cNvPr>
@@ -4131,7 +4131,7 @@
           <p:cNvPr id="6" name="">
             <a:extLst xmlns:a="http://schemas.openxmlformats.org/drawingml/2006/main">
               <a:ext uri="{FF2B5EF4-FFF2-40B4-BE49-F238E27FC236}">
-                <a16:creationId xmlns:a16="http://schemas.microsoft.com/office/drawing/2014/main" id="{8F0E92A4-FF93-4F84-BC01-F9A184692838}"/>
+                <a16:creationId xmlns:a16="http://schemas.microsoft.com/office/drawing/2014/main" id="{C6723594-80FB-4A54-9CDC-83BFBB1FC9D7}"/>
               </a:ext>
             </a:extLst>
           </p:cNvPr>
@@ -4185,7 +4185,7 @@
           <p:nvPr/>
         </p:nvPicPr>
         <p:blipFill>
-          <a:blip xmlns:r="http://schemas.openxmlformats.org/officeDocument/2006/relationships" xmlns:a="http://schemas.openxmlformats.org/drawingml/2006/main" r:embed="R0d5ffedb5bfc4bda"/>
+          <a:blip xmlns:r="http://schemas.openxmlformats.org/officeDocument/2006/relationships" xmlns:a="http://schemas.openxmlformats.org/drawingml/2006/main" r:embed="R351393c3b74c48dd"/>
           <a:stretch xmlns:a="http://schemas.openxmlformats.org/drawingml/2006/main"/>
         </p:blipFill>
         <p:spPr>
@@ -4205,7 +4205,7 @@
           <p:cNvPr id="8" name="">
             <a:extLst xmlns:a="http://schemas.openxmlformats.org/drawingml/2006/main">
               <a:ext uri="{FF2B5EF4-FFF2-40B4-BE49-F238E27FC236}">
-                <a16:creationId xmlns:a16="http://schemas.microsoft.com/office/drawing/2014/main" id="{4DAE15AB-2AC6-4EFA-9028-9BD1EFEE6E50}"/>
+                <a16:creationId xmlns:a16="http://schemas.microsoft.com/office/drawing/2014/main" id="{013052F4-C332-48CC-A866-D5BA9A18B594}"/>
               </a:ext>
             </a:extLst>
           </p:cNvPr>
@@ -4255,7 +4255,7 @@
           <p:cNvPr id="9" name="">
             <a:extLst xmlns:a="http://schemas.openxmlformats.org/drawingml/2006/main">
               <a:ext uri="{FF2B5EF4-FFF2-40B4-BE49-F238E27FC236}">
-                <a16:creationId xmlns:a16="http://schemas.microsoft.com/office/drawing/2014/main" id="{382E3C9B-E2AB-47F1-8CF0-FF5481BEBE5A}"/>
+                <a16:creationId xmlns:a16="http://schemas.microsoft.com/office/drawing/2014/main" id="{9FC80B5B-D21E-4F29-8B87-2458EE9FEABE}"/>
               </a:ext>
             </a:extLst>
           </p:cNvPr>
@@ -4305,7 +4305,7 @@
           <p:cNvPr id="10" name="">
             <a:extLst xmlns:a="http://schemas.openxmlformats.org/drawingml/2006/main">
               <a:ext uri="{FF2B5EF4-FFF2-40B4-BE49-F238E27FC236}">
-                <a16:creationId xmlns:a16="http://schemas.microsoft.com/office/drawing/2014/main" id="{9CBD0CD0-C6BA-4D84-9763-A961B6349A08}"/>
+                <a16:creationId xmlns:a16="http://schemas.microsoft.com/office/drawing/2014/main" id="{FF2C4C90-83B1-4890-8AF1-2722BCDC9F4B}"/>
               </a:ext>
             </a:extLst>
           </p:cNvPr>
@@ -4340,7 +4340,7 @@
           <p:cNvPr id="11" name="">
             <a:extLst xmlns:a="http://schemas.openxmlformats.org/drawingml/2006/main">
               <a:ext uri="{FF2B5EF4-FFF2-40B4-BE49-F238E27FC236}">
-                <a16:creationId xmlns:a16="http://schemas.microsoft.com/office/drawing/2014/main" id="{BA32FB10-7C18-4E33-9522-13C27C9559C2}"/>
+                <a16:creationId xmlns:a16="http://schemas.microsoft.com/office/drawing/2014/main" id="{C6F4E737-B674-41E7-AE55-11E82FFE912E}"/>
               </a:ext>
             </a:extLst>
           </p:cNvPr>
@@ -4390,7 +4390,7 @@
           <p:cNvPr id="12" name="">
             <a:extLst xmlns:a="http://schemas.openxmlformats.org/drawingml/2006/main">
               <a:ext uri="{FF2B5EF4-FFF2-40B4-BE49-F238E27FC236}">
-                <a16:creationId xmlns:a16="http://schemas.microsoft.com/office/drawing/2014/main" id="{0B1E5510-0265-4614-AAFB-3A5F15B9167B}"/>
+                <a16:creationId xmlns:a16="http://schemas.microsoft.com/office/drawing/2014/main" id="{94F06AC2-59CA-4A99-8110-06A1ABDFED91}"/>
               </a:ext>
             </a:extLst>
           </p:cNvPr>
@@ -4474,7 +4474,7 @@
           <p:cNvPr id="13" name="">
             <a:extLst xmlns:a="http://schemas.openxmlformats.org/drawingml/2006/main">
               <a:ext uri="{FF2B5EF4-FFF2-40B4-BE49-F238E27FC236}">
-                <a16:creationId xmlns:a16="http://schemas.microsoft.com/office/drawing/2014/main" id="{44534F1F-D024-4C8F-BF9C-28E165E0D1C2}"/>
+                <a16:creationId xmlns:a16="http://schemas.microsoft.com/office/drawing/2014/main" id="{9EDEECFC-6163-4B27-AFE1-430B0B41A70B}"/>
               </a:ext>
             </a:extLst>
           </p:cNvPr>
@@ -4528,7 +4528,7 @@
           <p:nvPr/>
         </p:nvPicPr>
         <p:blipFill>
-          <a:blip xmlns:r="http://schemas.openxmlformats.org/officeDocument/2006/relationships" xmlns:a="http://schemas.openxmlformats.org/drawingml/2006/main" r:embed="Ra41b39008ffb42a2"/>
+          <a:blip xmlns:r="http://schemas.openxmlformats.org/officeDocument/2006/relationships" xmlns:a="http://schemas.openxmlformats.org/drawingml/2006/main" r:embed="Rfb3855a572274eb2"/>
           <a:stretch xmlns:a="http://schemas.openxmlformats.org/drawingml/2006/main"/>
         </p:blipFill>
         <p:spPr>
@@ -4548,7 +4548,7 @@
           <p:cNvPr id="15" name="">
             <a:extLst xmlns:a="http://schemas.openxmlformats.org/drawingml/2006/main">
               <a:ext uri="{FF2B5EF4-FFF2-40B4-BE49-F238E27FC236}">
-                <a16:creationId xmlns:a16="http://schemas.microsoft.com/office/drawing/2014/main" id="{7FDAC06B-1AF0-4FB4-8D84-DBBF131E8C82}"/>
+                <a16:creationId xmlns:a16="http://schemas.microsoft.com/office/drawing/2014/main" id="{E2130F6A-853D-4F2D-88F7-A1AC233482F0}"/>
               </a:ext>
             </a:extLst>
           </p:cNvPr>
@@ -4596,7 +4596,7 @@
     </p:spTree>
     <p:extLst>
       <p:ext uri="{BB962C8B-B14F-4D97-AF65-F5344CB8AC3E}">
-        <p14:creationId xmlns:p14="http://schemas.microsoft.com/office/powerpoint/2010/main" val="1868086080"/>
+        <p14:creationId xmlns:p14="http://schemas.microsoft.com/office/powerpoint/2010/main" val="1837907310"/>
       </p:ext>
     </p:extLst>
   </p:cSld>
@@ -4627,7 +4627,7 @@
           <p:cNvPr id="1" name="">
             <a:extLst xmlns:a="http://schemas.openxmlformats.org/drawingml/2006/main">
               <a:ext uri="{FF2B5EF4-FFF2-40B4-BE49-F238E27FC236}">
-                <a16:creationId xmlns:a16="http://schemas.microsoft.com/office/drawing/2014/main" id="{50F7BA36-AF2F-483D-82C7-B11093C2B81F}"/>
+                <a16:creationId xmlns:a16="http://schemas.microsoft.com/office/drawing/2014/main" id="{170F2924-6CF8-4F61-9467-559FD73CCEDD}"/>
               </a:ext>
             </a:extLst>
           </p:cNvPr>
@@ -4658,7 +4658,7 @@
           <p:cNvPr id="2" name="">
             <a:extLst xmlns:a="http://schemas.openxmlformats.org/drawingml/2006/main">
               <a:ext uri="{FF2B5EF4-FFF2-40B4-BE49-F238E27FC236}">
-                <a16:creationId xmlns:a16="http://schemas.microsoft.com/office/drawing/2014/main" id="{F7FB0745-6091-47F5-A26D-A3D4271B7647}"/>
+                <a16:creationId xmlns:a16="http://schemas.microsoft.com/office/drawing/2014/main" id="{9F05573C-8EA6-43BE-9F27-1B93C50B23AF}"/>
               </a:ext>
             </a:extLst>
           </p:cNvPr>
@@ -4708,7 +4708,7 @@
           <p:cNvPr id="3" name="">
             <a:extLst xmlns:a="http://schemas.openxmlformats.org/drawingml/2006/main">
               <a:ext uri="{FF2B5EF4-FFF2-40B4-BE49-F238E27FC236}">
-                <a16:creationId xmlns:a16="http://schemas.microsoft.com/office/drawing/2014/main" id="{CF72525D-C0C3-49EC-BCB4-C57571D2715F}"/>
+                <a16:creationId xmlns:a16="http://schemas.microsoft.com/office/drawing/2014/main" id="{6625205E-5CC8-4C4C-B071-2F38B4732349}"/>
               </a:ext>
             </a:extLst>
           </p:cNvPr>
@@ -4758,7 +4758,7 @@
           <p:cNvPr id="4" name="">
             <a:extLst xmlns:a="http://schemas.openxmlformats.org/drawingml/2006/main">
               <a:ext uri="{FF2B5EF4-FFF2-40B4-BE49-F238E27FC236}">
-                <a16:creationId xmlns:a16="http://schemas.microsoft.com/office/drawing/2014/main" id="{76DA2D51-55E5-4D42-841A-D693545F2054}"/>
+                <a16:creationId xmlns:a16="http://schemas.microsoft.com/office/drawing/2014/main" id="{C65F77D1-97AC-44F9-A54D-890FE522BADD}"/>
               </a:ext>
             </a:extLst>
           </p:cNvPr>
@@ -4789,7 +4789,7 @@
           <p:cNvPr id="5" name="">
             <a:extLst xmlns:a="http://schemas.openxmlformats.org/drawingml/2006/main">
               <a:ext uri="{FF2B5EF4-FFF2-40B4-BE49-F238E27FC236}">
-                <a16:creationId xmlns:a16="http://schemas.microsoft.com/office/drawing/2014/main" id="{89617367-D309-44AB-B266-DE0D61A3B339}"/>
+                <a16:creationId xmlns:a16="http://schemas.microsoft.com/office/drawing/2014/main" id="{F4291083-5302-4D37-BA11-A62F942482C1}"/>
               </a:ext>
             </a:extLst>
           </p:cNvPr>
@@ -4839,7 +4839,7 @@
           <p:cNvPr id="6" name="">
             <a:extLst xmlns:a="http://schemas.openxmlformats.org/drawingml/2006/main">
               <a:ext uri="{FF2B5EF4-FFF2-40B4-BE49-F238E27FC236}">
-                <a16:creationId xmlns:a16="http://schemas.microsoft.com/office/drawing/2014/main" id="{D152092C-E562-46F7-A7EB-324684BE7EA1}"/>
+                <a16:creationId xmlns:a16="http://schemas.microsoft.com/office/drawing/2014/main" id="{4187B4D2-D1B1-4B5F-8A37-B6C856CE5C2D}"/>
               </a:ext>
             </a:extLst>
           </p:cNvPr>
@@ -4889,7 +4889,7 @@
           <p:cNvPr id="7" name="">
             <a:extLst xmlns:a="http://schemas.openxmlformats.org/drawingml/2006/main">
               <a:ext uri="{FF2B5EF4-FFF2-40B4-BE49-F238E27FC236}">
-                <a16:creationId xmlns:a16="http://schemas.microsoft.com/office/drawing/2014/main" id="{2A848D9F-5036-416A-9318-818797D13695}"/>
+                <a16:creationId xmlns:a16="http://schemas.microsoft.com/office/drawing/2014/main" id="{07111E5B-F6AF-4349-B79B-A1BA4F991330}"/>
               </a:ext>
             </a:extLst>
           </p:cNvPr>
@@ -4943,7 +4943,7 @@
           <p:nvPr/>
         </p:nvPicPr>
         <p:blipFill>
-          <a:blip xmlns:r="http://schemas.openxmlformats.org/officeDocument/2006/relationships" xmlns:a="http://schemas.openxmlformats.org/drawingml/2006/main" r:embed="R07d5471a8f5f42a5"/>
+          <a:blip xmlns:r="http://schemas.openxmlformats.org/officeDocument/2006/relationships" xmlns:a="http://schemas.openxmlformats.org/drawingml/2006/main" r:embed="Re19f02857b1d4ff2"/>
           <a:stretch xmlns:a="http://schemas.openxmlformats.org/drawingml/2006/main"/>
         </p:blipFill>
         <p:spPr>
@@ -4961,7 +4961,7 @@
     </p:spTree>
     <p:extLst>
       <p:ext uri="{BB962C8B-B14F-4D97-AF65-F5344CB8AC3E}">
-        <p14:creationId xmlns:p14="http://schemas.microsoft.com/office/powerpoint/2010/main" val="601168539"/>
+        <p14:creationId xmlns:p14="http://schemas.microsoft.com/office/powerpoint/2010/main" val="888009237"/>
       </p:ext>
     </p:extLst>
   </p:cSld>
@@ -4992,7 +4992,7 @@
           <p:cNvPr id="1" name="">
             <a:extLst xmlns:a="http://schemas.openxmlformats.org/drawingml/2006/main">
               <a:ext uri="{FF2B5EF4-FFF2-40B4-BE49-F238E27FC236}">
-                <a16:creationId xmlns:a16="http://schemas.microsoft.com/office/drawing/2014/main" id="{4CED78D4-65E7-44AB-9BEE-8C29A848F04E}"/>
+                <a16:creationId xmlns:a16="http://schemas.microsoft.com/office/drawing/2014/main" id="{815188EE-725A-4A85-A1E1-9C65A42695A5}"/>
               </a:ext>
             </a:extLst>
           </p:cNvPr>
@@ -5023,7 +5023,7 @@
           <p:cNvPr id="2" name="">
             <a:extLst xmlns:a="http://schemas.openxmlformats.org/drawingml/2006/main">
               <a:ext uri="{FF2B5EF4-FFF2-40B4-BE49-F238E27FC236}">
-                <a16:creationId xmlns:a16="http://schemas.microsoft.com/office/drawing/2014/main" id="{2A374516-DE54-4645-8957-73A94E70281A}"/>
+                <a16:creationId xmlns:a16="http://schemas.microsoft.com/office/drawing/2014/main" id="{AC14B9E6-E279-4C0E-9E2E-0D1A95B427B0}"/>
               </a:ext>
             </a:extLst>
           </p:cNvPr>
@@ -5073,7 +5073,7 @@
           <p:cNvPr id="3" name="">
             <a:extLst xmlns:a="http://schemas.openxmlformats.org/drawingml/2006/main">
               <a:ext uri="{FF2B5EF4-FFF2-40B4-BE49-F238E27FC236}">
-                <a16:creationId xmlns:a16="http://schemas.microsoft.com/office/drawing/2014/main" id="{6816C50E-6BED-497C-BAE5-F21A7C249D0D}"/>
+                <a16:creationId xmlns:a16="http://schemas.microsoft.com/office/drawing/2014/main" id="{C88C8644-6504-4D1F-A3F1-BF6EA26D22C8}"/>
               </a:ext>
             </a:extLst>
           </p:cNvPr>
@@ -5123,7 +5123,7 @@
           <p:cNvPr id="4" name="">
             <a:extLst xmlns:a="http://schemas.openxmlformats.org/drawingml/2006/main">
               <a:ext uri="{FF2B5EF4-FFF2-40B4-BE49-F238E27FC236}">
-                <a16:creationId xmlns:a16="http://schemas.microsoft.com/office/drawing/2014/main" id="{C48BD2B6-BA70-426F-9FB8-32CAF905B9DD}"/>
+                <a16:creationId xmlns:a16="http://schemas.microsoft.com/office/drawing/2014/main" id="{F3D4359D-00F9-4903-AF20-094340000BCA}"/>
               </a:ext>
             </a:extLst>
           </p:cNvPr>
@@ -5154,7 +5154,7 @@
           <p:cNvPr id="5" name="">
             <a:extLst xmlns:a="http://schemas.openxmlformats.org/drawingml/2006/main">
               <a:ext uri="{FF2B5EF4-FFF2-40B4-BE49-F238E27FC236}">
-                <a16:creationId xmlns:a16="http://schemas.microsoft.com/office/drawing/2014/main" id="{1A7F3EE9-A21E-43EC-9DCE-073200330074}"/>
+                <a16:creationId xmlns:a16="http://schemas.microsoft.com/office/drawing/2014/main" id="{D1904092-8941-4A21-A256-86B30D2A6E7C}"/>
               </a:ext>
             </a:extLst>
           </p:cNvPr>
@@ -5204,7 +5204,7 @@
           <p:cNvPr id="6" name="">
             <a:extLst xmlns:a="http://schemas.openxmlformats.org/drawingml/2006/main">
               <a:ext uri="{FF2B5EF4-FFF2-40B4-BE49-F238E27FC236}">
-                <a16:creationId xmlns:a16="http://schemas.microsoft.com/office/drawing/2014/main" id="{ACA5086A-8E28-4689-9E40-C7B105B611CC}"/>
+                <a16:creationId xmlns:a16="http://schemas.microsoft.com/office/drawing/2014/main" id="{89FD0D82-9272-4C08-B276-4617DFDBCD99}"/>
               </a:ext>
             </a:extLst>
           </p:cNvPr>
@@ -5244,7 +5244,7 @@
                   <a:srgbClr val="18242E"/>
                 </a:solidFill>
               </a:rPr>
-              <a:t>Federation adds one cross-site mapping without moving reports</a:t>
+              <a:t>Five seeds reproduce the cross-site gain without moving reports</a:t>
             </a:r>
           </a:p>
         </p:txBody>
@@ -5254,7 +5254,7 @@
           <p:cNvPr id="7" name="">
             <a:extLst xmlns:a="http://schemas.openxmlformats.org/drawingml/2006/main">
               <a:ext uri="{FF2B5EF4-FFF2-40B4-BE49-F238E27FC236}">
-                <a16:creationId xmlns:a16="http://schemas.microsoft.com/office/drawing/2014/main" id="{C40F7A4F-69D7-4513-8724-A441581E9575}"/>
+                <a16:creationId xmlns:a16="http://schemas.microsoft.com/office/drawing/2014/main" id="{7BB3D9AD-9881-446B-8689-B9E0BFD63C86}"/>
               </a:ext>
             </a:extLst>
           </p:cNvPr>
@@ -5266,7 +5266,7 @@
         <p:spPr>
           <a:xfrm xmlns:a="http://schemas.openxmlformats.org/drawingml/2006/main">
             <a:off x="647700" y="1695450"/>
-            <a:ext cx="2095500" cy="552450"/>
+            <a:ext cx="2571750" cy="552450"/>
           </a:xfrm>
           <a:prstGeom xmlns:a="http://schemas.openxmlformats.org/drawingml/2006/main" prst="rect">
             <a:avLst/>
@@ -5304,7 +5304,7 @@
           <p:cNvPr id="8" name="">
             <a:extLst xmlns:a="http://schemas.openxmlformats.org/drawingml/2006/main">
               <a:ext uri="{FF2B5EF4-FFF2-40B4-BE49-F238E27FC236}">
-                <a16:creationId xmlns:a16="http://schemas.microsoft.com/office/drawing/2014/main" id="{98C14A36-CFC6-471D-A44B-E15A2EA8EB3B}"/>
+                <a16:creationId xmlns:a16="http://schemas.microsoft.com/office/drawing/2014/main" id="{C352864C-F872-4E41-AAC6-03504F055AF4}"/>
               </a:ext>
             </a:extLst>
           </p:cNvPr>
@@ -5316,7 +5316,7 @@
         <p:spPr>
           <a:xfrm xmlns:a="http://schemas.openxmlformats.org/drawingml/2006/main">
             <a:off x="647700" y="2247900"/>
-            <a:ext cx="2095500" cy="419100"/>
+            <a:ext cx="2571750" cy="419100"/>
           </a:xfrm>
           <a:prstGeom xmlns:a="http://schemas.openxmlformats.org/drawingml/2006/main" prst="rect">
             <a:avLst/>
@@ -5344,7 +5344,7 @@
                   <a:srgbClr val="607283"/>
                 </a:solidFill>
               </a:rPr>
-              <a:t>federated transfer</a:t>
+              <a:t>federated transfer at all 5 seeds</a:t>
             </a:r>
           </a:p>
         </p:txBody>
@@ -5354,7 +5354,7 @@
           <p:cNvPr id="9" name="">
             <a:extLst xmlns:a="http://schemas.openxmlformats.org/drawingml/2006/main">
               <a:ext uri="{FF2B5EF4-FFF2-40B4-BE49-F238E27FC236}">
-                <a16:creationId xmlns:a16="http://schemas.microsoft.com/office/drawing/2014/main" id="{7DD54C8F-B722-4D5D-9A59-12E6164BA419}"/>
+                <a16:creationId xmlns:a16="http://schemas.microsoft.com/office/drawing/2014/main" id="{B4701F09-7323-4595-84C9-83CBA9E3AD2B}"/>
               </a:ext>
             </a:extLst>
           </p:cNvPr>
@@ -5366,7 +5366,7 @@
         <p:spPr>
           <a:xfrm xmlns:a="http://schemas.openxmlformats.org/drawingml/2006/main">
             <a:off x="647700" y="2876550"/>
-            <a:ext cx="2095500" cy="552450"/>
+            <a:ext cx="2571750" cy="552450"/>
           </a:xfrm>
           <a:prstGeom xmlns:a="http://schemas.openxmlformats.org/drawingml/2006/main" prst="rect">
             <a:avLst/>
@@ -5404,7 +5404,7 @@
           <p:cNvPr id="10" name="">
             <a:extLst xmlns:a="http://schemas.openxmlformats.org/drawingml/2006/main">
               <a:ext uri="{FF2B5EF4-FFF2-40B4-BE49-F238E27FC236}">
-                <a16:creationId xmlns:a16="http://schemas.microsoft.com/office/drawing/2014/main" id="{C7639404-C28E-46E0-B89C-4B480FE1377C}"/>
+                <a16:creationId xmlns:a16="http://schemas.microsoft.com/office/drawing/2014/main" id="{53698262-1093-48BD-8E5E-C06C55A1E557}"/>
               </a:ext>
             </a:extLst>
           </p:cNvPr>
@@ -5416,7 +5416,7 @@
         <p:spPr>
           <a:xfrm xmlns:a="http://schemas.openxmlformats.org/drawingml/2006/main">
             <a:off x="647700" y="3429000"/>
-            <a:ext cx="2095500" cy="419100"/>
+            <a:ext cx="2571750" cy="419100"/>
           </a:xfrm>
           <a:prstGeom xmlns:a="http://schemas.openxmlformats.org/drawingml/2006/main" prst="rect">
             <a:avLst/>
@@ -5444,7 +5444,7 @@
                   <a:srgbClr val="607283"/>
                 </a:solidFill>
               </a:rPr>
-              <a:t>local-only transfer</a:t>
+              <a:t>local-only transfer at all 5 seeds</a:t>
             </a:r>
           </a:p>
         </p:txBody>
@@ -5454,7 +5454,7 @@
           <p:cNvPr id="11" name="">
             <a:extLst xmlns:a="http://schemas.openxmlformats.org/drawingml/2006/main">
               <a:ext uri="{FF2B5EF4-FFF2-40B4-BE49-F238E27FC236}">
-                <a16:creationId xmlns:a16="http://schemas.microsoft.com/office/drawing/2014/main" id="{832885CC-3B17-4336-B11B-2DBCC4B5D488}"/>
+                <a16:creationId xmlns:a16="http://schemas.microsoft.com/office/drawing/2014/main" id="{C8DB630B-D774-4E46-850F-A39FF47B4848}"/>
               </a:ext>
             </a:extLst>
           </p:cNvPr>
@@ -5466,7 +5466,7 @@
         <p:spPr>
           <a:xfrm xmlns:a="http://schemas.openxmlformats.org/drawingml/2006/main">
             <a:off x="647700" y="4057650"/>
-            <a:ext cx="2095500" cy="552450"/>
+            <a:ext cx="2571750" cy="552450"/>
           </a:xfrm>
           <a:prstGeom xmlns:a="http://schemas.openxmlformats.org/drawingml/2006/main" prst="rect">
             <a:avLst/>
@@ -5504,7 +5504,7 @@
           <p:cNvPr id="12" name="">
             <a:extLst xmlns:a="http://schemas.openxmlformats.org/drawingml/2006/main">
               <a:ext uri="{FF2B5EF4-FFF2-40B4-BE49-F238E27FC236}">
-                <a16:creationId xmlns:a16="http://schemas.microsoft.com/office/drawing/2014/main" id="{CE0C966F-CB1B-46F0-86E7-B5C57C7E58A9}"/>
+                <a16:creationId xmlns:a16="http://schemas.microsoft.com/office/drawing/2014/main" id="{920C624A-BACD-4328-AC16-A131EC362C5B}"/>
               </a:ext>
             </a:extLst>
           </p:cNvPr>
@@ -5516,7 +5516,7 @@
         <p:spPr>
           <a:xfrm xmlns:a="http://schemas.openxmlformats.org/drawingml/2006/main">
             <a:off x="647700" y="4610100"/>
-            <a:ext cx="2095500" cy="419100"/>
+            <a:ext cx="2571750" cy="419100"/>
           </a:xfrm>
           <a:prstGeom xmlns:a="http://schemas.openxmlformats.org/drawingml/2006/main" prst="rect">
             <a:avLst/>
@@ -5544,7 +5544,7 @@
                   <a:srgbClr val="607283"/>
                 </a:solidFill>
               </a:rPr>
-              <a:t>measured transfer gain</a:t>
+              <a:t>measured gain per seed</a:t>
             </a:r>
           </a:p>
         </p:txBody>
@@ -5554,7 +5554,7 @@
           <p:cNvPr id="13" name="">
             <a:extLst xmlns:a="http://schemas.openxmlformats.org/drawingml/2006/main">
               <a:ext uri="{FF2B5EF4-FFF2-40B4-BE49-F238E27FC236}">
-                <a16:creationId xmlns:a16="http://schemas.microsoft.com/office/drawing/2014/main" id="{C0FDFAAE-D413-492E-9B83-FB67225F02C8}"/>
+                <a16:creationId xmlns:a16="http://schemas.microsoft.com/office/drawing/2014/main" id="{5C29353E-36D1-4883-BC6F-0BC30F1581D8}"/>
               </a:ext>
             </a:extLst>
           </p:cNvPr>
@@ -5566,35 +5566,35 @@
         <p:spPr>
           <a:xfrm xmlns:a="http://schemas.openxmlformats.org/drawingml/2006/main">
             <a:off x="647700" y="5257800"/>
-            <a:ext cx="3143250" cy="323850"/>
-          </a:xfrm>
-          <a:prstGeom xmlns:a="http://schemas.openxmlformats.org/drawingml/2006/main" prst="rect">
-            <a:avLst/>
-          </a:prstGeom>
-          <a:noFill xmlns:a="http://schemas.openxmlformats.org/drawingml/2006/main"/>
-          <a:ln xmlns:a="http://schemas.openxmlformats.org/drawingml/2006/main" w="0">
-            <a:noFill/>
-            <a:prstDash val="solid"/>
-          </a:ln>
-        </p:spPr>
-        <p:txBody>
-          <a:bodyPr xmlns:a="http://schemas.openxmlformats.org/drawingml/2006/main"/>
-          <a:lstStyle xmlns:a="http://schemas.openxmlformats.org/drawingml/2006/main"/>
-          <a:p xmlns:a="http://schemas.openxmlformats.org/drawingml/2006/main">
-            <a:pPr algn="l">
-              <a:defRPr sz="1350" b="1">
+            <a:ext cx="3238500" cy="400050"/>
+          </a:xfrm>
+          <a:prstGeom xmlns:a="http://schemas.openxmlformats.org/drawingml/2006/main" prst="rect">
+            <a:avLst/>
+          </a:prstGeom>
+          <a:noFill xmlns:a="http://schemas.openxmlformats.org/drawingml/2006/main"/>
+          <a:ln xmlns:a="http://schemas.openxmlformats.org/drawingml/2006/main" w="0">
+            <a:noFill/>
+            <a:prstDash val="solid"/>
+          </a:ln>
+        </p:spPr>
+        <p:txBody>
+          <a:bodyPr xmlns:a="http://schemas.openxmlformats.org/drawingml/2006/main"/>
+          <a:lstStyle xmlns:a="http://schemas.openxmlformats.org/drawingml/2006/main"/>
+          <a:p xmlns:a="http://schemas.openxmlformats.org/drawingml/2006/main">
+            <a:pPr algn="l">
+              <a:defRPr sz="1200" b="1">
                 <a:solidFill>
                   <a:srgbClr val="18242E"/>
                 </a:solidFill>
               </a:defRPr>
             </a:pPr>
             <a:r>
-              <a:rPr sz="1350" b="1">
+              <a:rPr sz="1200" b="1">
                 <a:solidFill>
                   <a:srgbClr val="18242E"/>
                 </a:solidFill>
               </a:rPr>
-              <a:t>4/4 receiver sites did not regress</a:t>
+              <a:t>20/20 receiver-seed checks were non-regressive</a:t>
             </a:r>
           </a:p>
         </p:txBody>
@@ -5604,47 +5604,47 @@
           <p:cNvPr id="14" name="">
             <a:extLst xmlns:a="http://schemas.openxmlformats.org/drawingml/2006/main">
               <a:ext uri="{FF2B5EF4-FFF2-40B4-BE49-F238E27FC236}">
-                <a16:creationId xmlns:a16="http://schemas.microsoft.com/office/drawing/2014/main" id="{B0957268-93E7-48DC-B918-63495EF89B61}"/>
-              </a:ext>
-            </a:extLst>
-          </p:cNvPr>
-          <p:cNvSpPr>
-            <a:spLocks xmlns:a="http://schemas.openxmlformats.org/drawingml/2006/main" noGrp="1"/>
-          </p:cNvSpPr>
-          <p:nvPr/>
-        </p:nvSpPr>
-        <p:spPr>
-          <a:xfrm xmlns:a="http://schemas.openxmlformats.org/drawingml/2006/main">
-            <a:off x="647700" y="5715000"/>
-            <a:ext cx="3429000" cy="361950"/>
-          </a:xfrm>
-          <a:prstGeom xmlns:a="http://schemas.openxmlformats.org/drawingml/2006/main" prst="rect">
-            <a:avLst/>
-          </a:prstGeom>
-          <a:noFill xmlns:a="http://schemas.openxmlformats.org/drawingml/2006/main"/>
-          <a:ln xmlns:a="http://schemas.openxmlformats.org/drawingml/2006/main" w="0">
-            <a:noFill/>
-            <a:prstDash val="solid"/>
-          </a:ln>
-        </p:spPr>
-        <p:txBody>
-          <a:bodyPr xmlns:a="http://schemas.openxmlformats.org/drawingml/2006/main"/>
-          <a:lstStyle xmlns:a="http://schemas.openxmlformats.org/drawingml/2006/main"/>
-          <a:p xmlns:a="http://schemas.openxmlformats.org/drawingml/2006/main">
-            <a:pPr algn="l">
-              <a:defRPr sz="1050" b="1">
+                <a16:creationId xmlns:a16="http://schemas.microsoft.com/office/drawing/2014/main" id="{69B286C0-9C99-4B9B-AC74-A5B641208773}"/>
+              </a:ext>
+            </a:extLst>
+          </p:cNvPr>
+          <p:cNvSpPr>
+            <a:spLocks xmlns:a="http://schemas.openxmlformats.org/drawingml/2006/main" noGrp="1"/>
+          </p:cNvSpPr>
+          <p:nvPr/>
+        </p:nvSpPr>
+        <p:spPr>
+          <a:xfrm xmlns:a="http://schemas.openxmlformats.org/drawingml/2006/main">
+            <a:off x="647700" y="5753100"/>
+            <a:ext cx="3333750" cy="457200"/>
+          </a:xfrm>
+          <a:prstGeom xmlns:a="http://schemas.openxmlformats.org/drawingml/2006/main" prst="rect">
+            <a:avLst/>
+          </a:prstGeom>
+          <a:noFill xmlns:a="http://schemas.openxmlformats.org/drawingml/2006/main"/>
+          <a:ln xmlns:a="http://schemas.openxmlformats.org/drawingml/2006/main" w="0">
+            <a:noFill/>
+            <a:prstDash val="solid"/>
+          </a:ln>
+        </p:spPr>
+        <p:txBody>
+          <a:bodyPr xmlns:a="http://schemas.openxmlformats.org/drawingml/2006/main"/>
+          <a:lstStyle xmlns:a="http://schemas.openxmlformats.org/drawingml/2006/main"/>
+          <a:p xmlns:a="http://schemas.openxmlformats.org/drawingml/2006/main">
+            <a:pPr algn="l">
+              <a:defRPr sz="975" b="1">
                 <a:solidFill>
                   <a:srgbClr val="B66B00"/>
                 </a:solidFill>
               </a:defRPr>
             </a:pPr>
             <a:r>
-              <a:rPr sz="1050" b="1">
+              <a:rPr sz="975" b="1">
                 <a:solidFill>
                   <a:srgbClr val="B66B00"/>
                 </a:solidFill>
               </a:rPr>
-              <a:t>Single-seed synthetic benchmark; not clinical accuracy.</a:t>
+              <a:t>1.88 MiB five-round tensor traffic. Synthetic study; not clinical accuracy.</a:t>
             </a:r>
           </a:p>
         </p:txBody>
@@ -5654,7 +5654,7 @@
           <p:cNvPr id="15" name="">
             <a:extLst xmlns:a="http://schemas.openxmlformats.org/drawingml/2006/main">
               <a:ext uri="{FF2B5EF4-FFF2-40B4-BE49-F238E27FC236}">
-                <a16:creationId xmlns:a16="http://schemas.microsoft.com/office/drawing/2014/main" id="{0755C14B-9843-408A-BD95-2F8868C82F1F}"/>
+                <a16:creationId xmlns:a16="http://schemas.microsoft.com/office/drawing/2014/main" id="{0CCD2249-24D6-4E26-87F6-556D8FA29158}"/>
               </a:ext>
             </a:extLst>
           </p:cNvPr>
@@ -5693,13 +5693,13 @@
           <p:nvPr/>
         </p:nvPicPr>
         <p:blipFill>
-          <a:blip xmlns:r="http://schemas.openxmlformats.org/officeDocument/2006/relationships" xmlns:a="http://schemas.openxmlformats.org/drawingml/2006/main" r:embed="Rbae4d001929f4e57"/>
+          <a:blip xmlns:r="http://schemas.openxmlformats.org/officeDocument/2006/relationships" xmlns:a="http://schemas.openxmlformats.org/drawingml/2006/main" r:embed="Ra291db3d90914cb0"/>
           <a:stretch xmlns:a="http://schemas.openxmlformats.org/drawingml/2006/main"/>
         </p:blipFill>
         <p:spPr>
           <a:xfrm xmlns:a="http://schemas.openxmlformats.org/drawingml/2006/main">
-            <a:off x="4171950" y="1919552"/>
-            <a:ext cx="7181850" cy="3790421"/>
+            <a:off x="6073004" y="1619250"/>
+            <a:ext cx="3379743" cy="4391025"/>
           </a:xfrm>
           <a:prstGeom xmlns:a="http://schemas.openxmlformats.org/drawingml/2006/main" prst="roundRect">
             <a:avLst>
@@ -5711,7 +5711,7 @@
     </p:spTree>
     <p:extLst>
       <p:ext uri="{BB962C8B-B14F-4D97-AF65-F5344CB8AC3E}">
-        <p14:creationId xmlns:p14="http://schemas.microsoft.com/office/powerpoint/2010/main" val="1553979423"/>
+        <p14:creationId xmlns:p14="http://schemas.microsoft.com/office/powerpoint/2010/main" val="1166347321"/>
       </p:ext>
     </p:extLst>
   </p:cSld>
@@ -5742,7 +5742,7 @@
           <p:cNvPr id="1" name="">
             <a:extLst xmlns:a="http://schemas.openxmlformats.org/drawingml/2006/main">
               <a:ext uri="{FF2B5EF4-FFF2-40B4-BE49-F238E27FC236}">
-                <a16:creationId xmlns:a16="http://schemas.microsoft.com/office/drawing/2014/main" id="{6F4451DE-3246-46C4-8AF3-CE13797A1C54}"/>
+                <a16:creationId xmlns:a16="http://schemas.microsoft.com/office/drawing/2014/main" id="{30F9F8CE-E24A-4C33-A5AB-D04BC8C777AF}"/>
               </a:ext>
             </a:extLst>
           </p:cNvPr>
@@ -5773,7 +5773,7 @@
           <p:cNvPr id="2" name="">
             <a:extLst xmlns:a="http://schemas.openxmlformats.org/drawingml/2006/main">
               <a:ext uri="{FF2B5EF4-FFF2-40B4-BE49-F238E27FC236}">
-                <a16:creationId xmlns:a16="http://schemas.microsoft.com/office/drawing/2014/main" id="{409F6CA6-9834-4F88-A7AA-705FBF3B94E6}"/>
+                <a16:creationId xmlns:a16="http://schemas.microsoft.com/office/drawing/2014/main" id="{AFC70ABD-8106-4465-B46C-7594DFD01E30}"/>
               </a:ext>
             </a:extLst>
           </p:cNvPr>
@@ -5823,7 +5823,7 @@
           <p:cNvPr id="3" name="">
             <a:extLst xmlns:a="http://schemas.openxmlformats.org/drawingml/2006/main">
               <a:ext uri="{FF2B5EF4-FFF2-40B4-BE49-F238E27FC236}">
-                <a16:creationId xmlns:a16="http://schemas.microsoft.com/office/drawing/2014/main" id="{C8B3F1B4-A630-4F6D-B20B-29558D3DE7F8}"/>
+                <a16:creationId xmlns:a16="http://schemas.microsoft.com/office/drawing/2014/main" id="{A2951B9F-D421-4216-B149-5741FCB2C8EB}"/>
               </a:ext>
             </a:extLst>
           </p:cNvPr>
@@ -5873,7 +5873,7 @@
           <p:cNvPr id="4" name="">
             <a:extLst xmlns:a="http://schemas.openxmlformats.org/drawingml/2006/main">
               <a:ext uri="{FF2B5EF4-FFF2-40B4-BE49-F238E27FC236}">
-                <a16:creationId xmlns:a16="http://schemas.microsoft.com/office/drawing/2014/main" id="{9C5D0AA5-663D-4DFF-88D0-F6B6B7617EE3}"/>
+                <a16:creationId xmlns:a16="http://schemas.microsoft.com/office/drawing/2014/main" id="{6C6278C6-16A1-42D1-B5EE-5E4D3E129481}"/>
               </a:ext>
             </a:extLst>
           </p:cNvPr>
@@ -5904,7 +5904,7 @@
           <p:cNvPr id="5" name="">
             <a:extLst xmlns:a="http://schemas.openxmlformats.org/drawingml/2006/main">
               <a:ext uri="{FF2B5EF4-FFF2-40B4-BE49-F238E27FC236}">
-                <a16:creationId xmlns:a16="http://schemas.microsoft.com/office/drawing/2014/main" id="{D328C54F-AE8E-414F-B02E-4E5002C94B82}"/>
+                <a16:creationId xmlns:a16="http://schemas.microsoft.com/office/drawing/2014/main" id="{E05014C0-D560-44F2-A200-E355EA7E5C1E}"/>
               </a:ext>
             </a:extLst>
           </p:cNvPr>
@@ -5954,7 +5954,7 @@
           <p:cNvPr id="6" name="">
             <a:extLst xmlns:a="http://schemas.openxmlformats.org/drawingml/2006/main">
               <a:ext uri="{FF2B5EF4-FFF2-40B4-BE49-F238E27FC236}">
-                <a16:creationId xmlns:a16="http://schemas.microsoft.com/office/drawing/2014/main" id="{AD792BF9-0D5A-4AF5-80A8-9F5595606626}"/>
+                <a16:creationId xmlns:a16="http://schemas.microsoft.com/office/drawing/2014/main" id="{0B03F9CD-4106-4BB0-900E-F68E77B5302D}"/>
               </a:ext>
             </a:extLst>
           </p:cNvPr>
@@ -6004,7 +6004,7 @@
           <p:cNvPr id="7" name="">
             <a:extLst xmlns:a="http://schemas.openxmlformats.org/drawingml/2006/main">
               <a:ext uri="{FF2B5EF4-FFF2-40B4-BE49-F238E27FC236}">
-                <a16:creationId xmlns:a16="http://schemas.microsoft.com/office/drawing/2014/main" id="{F3747BE0-6A21-4094-8760-B2197843C5D0}"/>
+                <a16:creationId xmlns:a16="http://schemas.microsoft.com/office/drawing/2014/main" id="{20F071B3-C00F-4CB5-A533-50F491465D2E}"/>
               </a:ext>
             </a:extLst>
           </p:cNvPr>
@@ -6043,7 +6043,7 @@
           <p:nvPr/>
         </p:nvPicPr>
         <p:blipFill>
-          <a:blip xmlns:r="http://schemas.openxmlformats.org/officeDocument/2006/relationships" xmlns:a="http://schemas.openxmlformats.org/drawingml/2006/main" r:embed="R0bc4e07379974330"/>
+          <a:blip xmlns:r="http://schemas.openxmlformats.org/officeDocument/2006/relationships" xmlns:a="http://schemas.openxmlformats.org/drawingml/2006/main" r:embed="Rf8be720f030146c8"/>
           <a:stretch xmlns:a="http://schemas.openxmlformats.org/drawingml/2006/main"/>
         </p:blipFill>
         <p:spPr>
@@ -6063,7 +6063,7 @@
           <p:cNvPr id="9" name="">
             <a:extLst xmlns:a="http://schemas.openxmlformats.org/drawingml/2006/main">
               <a:ext uri="{FF2B5EF4-FFF2-40B4-BE49-F238E27FC236}">
-                <a16:creationId xmlns:a16="http://schemas.microsoft.com/office/drawing/2014/main" id="{0A9507E0-0ABE-4F2C-8AD3-494E1B88B33B}"/>
+                <a16:creationId xmlns:a16="http://schemas.microsoft.com/office/drawing/2014/main" id="{15D21C4D-7ACA-46DC-89FD-B46824C8DA73}"/>
               </a:ext>
             </a:extLst>
           </p:cNvPr>
@@ -6113,7 +6113,7 @@
           <p:cNvPr id="10" name="">
             <a:extLst xmlns:a="http://schemas.openxmlformats.org/drawingml/2006/main">
               <a:ext uri="{FF2B5EF4-FFF2-40B4-BE49-F238E27FC236}">
-                <a16:creationId xmlns:a16="http://schemas.microsoft.com/office/drawing/2014/main" id="{FAA7E55F-2747-41E3-AD8F-58DF24052D2D}"/>
+                <a16:creationId xmlns:a16="http://schemas.microsoft.com/office/drawing/2014/main" id="{702CC90A-BB8D-4546-B2D9-A319DE479F51}"/>
               </a:ext>
             </a:extLst>
           </p:cNvPr>
@@ -6163,7 +6163,7 @@
           <p:cNvPr id="11" name="">
             <a:extLst xmlns:a="http://schemas.openxmlformats.org/drawingml/2006/main">
               <a:ext uri="{FF2B5EF4-FFF2-40B4-BE49-F238E27FC236}">
-                <a16:creationId xmlns:a16="http://schemas.microsoft.com/office/drawing/2014/main" id="{5D673C49-B674-4C27-9175-363CB2AAFB9F}"/>
+                <a16:creationId xmlns:a16="http://schemas.microsoft.com/office/drawing/2014/main" id="{504AC125-FC2C-4134-8773-EDAAEB0B076F}"/>
               </a:ext>
             </a:extLst>
           </p:cNvPr>
@@ -6213,7 +6213,7 @@
           <p:cNvPr id="12" name="">
             <a:extLst xmlns:a="http://schemas.openxmlformats.org/drawingml/2006/main">
               <a:ext uri="{FF2B5EF4-FFF2-40B4-BE49-F238E27FC236}">
-                <a16:creationId xmlns:a16="http://schemas.microsoft.com/office/drawing/2014/main" id="{9A199B7C-D063-4A79-B160-26E8229137BB}"/>
+                <a16:creationId xmlns:a16="http://schemas.microsoft.com/office/drawing/2014/main" id="{3117E657-8E27-4F9E-ADC1-3DDC226C8B7E}"/>
               </a:ext>
             </a:extLst>
           </p:cNvPr>
@@ -6263,7 +6263,7 @@
           <p:cNvPr id="13" name="">
             <a:extLst xmlns:a="http://schemas.openxmlformats.org/drawingml/2006/main">
               <a:ext uri="{FF2B5EF4-FFF2-40B4-BE49-F238E27FC236}">
-                <a16:creationId xmlns:a16="http://schemas.microsoft.com/office/drawing/2014/main" id="{B0CE986C-243A-4FCA-BF91-D64DD3BE025D}"/>
+                <a16:creationId xmlns:a16="http://schemas.microsoft.com/office/drawing/2014/main" id="{9C34D3B3-F6A0-470D-BDDC-D77ACC386BBA}"/>
               </a:ext>
             </a:extLst>
           </p:cNvPr>
@@ -6313,7 +6313,7 @@
           <p:cNvPr id="14" name="">
             <a:extLst xmlns:a="http://schemas.openxmlformats.org/drawingml/2006/main">
               <a:ext uri="{FF2B5EF4-FFF2-40B4-BE49-F238E27FC236}">
-                <a16:creationId xmlns:a16="http://schemas.microsoft.com/office/drawing/2014/main" id="{E1F4619E-F3CC-4D85-8D62-839D8C9D20BA}"/>
+                <a16:creationId xmlns:a16="http://schemas.microsoft.com/office/drawing/2014/main" id="{F23945FA-6B73-4FD2-A11D-1F4A2CC90B70}"/>
               </a:ext>
             </a:extLst>
           </p:cNvPr>
@@ -6363,7 +6363,7 @@
           <p:cNvPr id="15" name="">
             <a:extLst xmlns:a="http://schemas.openxmlformats.org/drawingml/2006/main">
               <a:ext uri="{FF2B5EF4-FFF2-40B4-BE49-F238E27FC236}">
-                <a16:creationId xmlns:a16="http://schemas.microsoft.com/office/drawing/2014/main" id="{3B135C23-9742-4D80-82E2-C979DC2347A1}"/>
+                <a16:creationId xmlns:a16="http://schemas.microsoft.com/office/drawing/2014/main" id="{45DB2DFB-EE5A-4485-AC91-0B3833EDF967}"/>
               </a:ext>
             </a:extLst>
           </p:cNvPr>
@@ -6413,7 +6413,7 @@
           <p:cNvPr id="16" name="">
             <a:extLst xmlns:a="http://schemas.openxmlformats.org/drawingml/2006/main">
               <a:ext uri="{FF2B5EF4-FFF2-40B4-BE49-F238E27FC236}">
-                <a16:creationId xmlns:a16="http://schemas.microsoft.com/office/drawing/2014/main" id="{ACA35566-805A-449E-B7D8-0FDB96B24028}"/>
+                <a16:creationId xmlns:a16="http://schemas.microsoft.com/office/drawing/2014/main" id="{A3F7A36D-2191-4938-8046-766196AB0184}"/>
               </a:ext>
             </a:extLst>
           </p:cNvPr>
@@ -6463,7 +6463,7 @@
           <p:cNvPr id="17" name="">
             <a:extLst xmlns:a="http://schemas.openxmlformats.org/drawingml/2006/main">
               <a:ext uri="{FF2B5EF4-FFF2-40B4-BE49-F238E27FC236}">
-                <a16:creationId xmlns:a16="http://schemas.microsoft.com/office/drawing/2014/main" id="{49524270-33D4-488C-ACA8-2A715D3149D1}"/>
+                <a16:creationId xmlns:a16="http://schemas.microsoft.com/office/drawing/2014/main" id="{DE8F1D2D-DE8F-487F-BE33-564E655C5154}"/>
               </a:ext>
             </a:extLst>
           </p:cNvPr>
@@ -6513,7 +6513,7 @@
           <p:cNvPr id="18" name="">
             <a:extLst xmlns:a="http://schemas.openxmlformats.org/drawingml/2006/main">
               <a:ext uri="{FF2B5EF4-FFF2-40B4-BE49-F238E27FC236}">
-                <a16:creationId xmlns:a16="http://schemas.microsoft.com/office/drawing/2014/main" id="{1203F41D-BE18-4219-829A-D5D910055D81}"/>
+                <a16:creationId xmlns:a16="http://schemas.microsoft.com/office/drawing/2014/main" id="{1A9EDD3B-3D0D-44B3-95A7-AC3B8BD7F171}"/>
               </a:ext>
             </a:extLst>
           </p:cNvPr>
@@ -6563,7 +6563,7 @@
           <p:cNvPr id="19" name="">
             <a:extLst xmlns:a="http://schemas.openxmlformats.org/drawingml/2006/main">
               <a:ext uri="{FF2B5EF4-FFF2-40B4-BE49-F238E27FC236}">
-                <a16:creationId xmlns:a16="http://schemas.microsoft.com/office/drawing/2014/main" id="{81164887-3C52-44DE-9A09-1CEDD62CC36B}"/>
+                <a16:creationId xmlns:a16="http://schemas.microsoft.com/office/drawing/2014/main" id="{54466CFB-E9C6-4B9B-99E5-0CDC3C01BB08}"/>
               </a:ext>
             </a:extLst>
           </p:cNvPr>
@@ -6613,7 +6613,7 @@
           <p:cNvPr id="20" name="">
             <a:extLst xmlns:a="http://schemas.openxmlformats.org/drawingml/2006/main">
               <a:ext uri="{FF2B5EF4-FFF2-40B4-BE49-F238E27FC236}">
-                <a16:creationId xmlns:a16="http://schemas.microsoft.com/office/drawing/2014/main" id="{CD107394-02C4-4D56-8683-E87CF5C81F58}"/>
+                <a16:creationId xmlns:a16="http://schemas.microsoft.com/office/drawing/2014/main" id="{2EEFD8DB-0A56-4A42-BD71-BBEA4CDE8DCB}"/>
               </a:ext>
             </a:extLst>
           </p:cNvPr>
@@ -6663,7 +6663,7 @@
           <p:cNvPr id="21" name="">
             <a:extLst xmlns:a="http://schemas.openxmlformats.org/drawingml/2006/main">
               <a:ext uri="{FF2B5EF4-FFF2-40B4-BE49-F238E27FC236}">
-                <a16:creationId xmlns:a16="http://schemas.microsoft.com/office/drawing/2014/main" id="{268CD488-3DD4-4B0F-8BBC-934B0C7A3132}"/>
+                <a16:creationId xmlns:a16="http://schemas.microsoft.com/office/drawing/2014/main" id="{62034A06-526A-49A4-B8E0-5C3102FFCA9A}"/>
               </a:ext>
             </a:extLst>
           </p:cNvPr>
@@ -6711,7 +6711,7 @@
     </p:spTree>
     <p:extLst>
       <p:ext uri="{BB962C8B-B14F-4D97-AF65-F5344CB8AC3E}">
-        <p14:creationId xmlns:p14="http://schemas.microsoft.com/office/powerpoint/2010/main" val="1661845559"/>
+        <p14:creationId xmlns:p14="http://schemas.microsoft.com/office/powerpoint/2010/main" val="1635104799"/>
       </p:ext>
     </p:extLst>
   </p:cSld>
@@ -6742,7 +6742,7 @@
           <p:cNvPr id="1" name="">
             <a:extLst xmlns:a="http://schemas.openxmlformats.org/drawingml/2006/main">
               <a:ext uri="{FF2B5EF4-FFF2-40B4-BE49-F238E27FC236}">
-                <a16:creationId xmlns:a16="http://schemas.microsoft.com/office/drawing/2014/main" id="{DDBD4FBE-9FD8-4C92-B48B-FEF5A6C26FDA}"/>
+                <a16:creationId xmlns:a16="http://schemas.microsoft.com/office/drawing/2014/main" id="{A6AA347A-FBC1-41B7-9348-10D9EDF567DA}"/>
               </a:ext>
             </a:extLst>
           </p:cNvPr>
@@ -6773,7 +6773,7 @@
           <p:cNvPr id="2" name="">
             <a:extLst xmlns:a="http://schemas.openxmlformats.org/drawingml/2006/main">
               <a:ext uri="{FF2B5EF4-FFF2-40B4-BE49-F238E27FC236}">
-                <a16:creationId xmlns:a16="http://schemas.microsoft.com/office/drawing/2014/main" id="{637051F8-A480-42AF-BDEB-2A9180EBE88F}"/>
+                <a16:creationId xmlns:a16="http://schemas.microsoft.com/office/drawing/2014/main" id="{00DD3931-F9F1-4665-B023-967B06A9CFE2}"/>
               </a:ext>
             </a:extLst>
           </p:cNvPr>
@@ -6823,7 +6823,7 @@
           <p:cNvPr id="3" name="">
             <a:extLst xmlns:a="http://schemas.openxmlformats.org/drawingml/2006/main">
               <a:ext uri="{FF2B5EF4-FFF2-40B4-BE49-F238E27FC236}">
-                <a16:creationId xmlns:a16="http://schemas.microsoft.com/office/drawing/2014/main" id="{877EF2C3-512E-479E-AAE6-E19F1B8AF910}"/>
+                <a16:creationId xmlns:a16="http://schemas.microsoft.com/office/drawing/2014/main" id="{7D20CA40-D7E3-45B3-9BC7-192B18970CCA}"/>
               </a:ext>
             </a:extLst>
           </p:cNvPr>
@@ -6873,7 +6873,7 @@
           <p:cNvPr id="4" name="">
             <a:extLst xmlns:a="http://schemas.openxmlformats.org/drawingml/2006/main">
               <a:ext uri="{FF2B5EF4-FFF2-40B4-BE49-F238E27FC236}">
-                <a16:creationId xmlns:a16="http://schemas.microsoft.com/office/drawing/2014/main" id="{14A06D0F-4F79-4911-9922-A0EEC85FFBB0}"/>
+                <a16:creationId xmlns:a16="http://schemas.microsoft.com/office/drawing/2014/main" id="{11690F04-3710-48CD-B488-6097A73C8DB4}"/>
               </a:ext>
             </a:extLst>
           </p:cNvPr>
@@ -6904,7 +6904,7 @@
           <p:cNvPr id="5" name="">
             <a:extLst xmlns:a="http://schemas.openxmlformats.org/drawingml/2006/main">
               <a:ext uri="{FF2B5EF4-FFF2-40B4-BE49-F238E27FC236}">
-                <a16:creationId xmlns:a16="http://schemas.microsoft.com/office/drawing/2014/main" id="{42FBDE60-8B01-4CF1-BFC2-2CCC2B53F4FE}"/>
+                <a16:creationId xmlns:a16="http://schemas.microsoft.com/office/drawing/2014/main" id="{2336C3B6-CFA1-4B43-8953-AF426F7330D9}"/>
               </a:ext>
             </a:extLst>
           </p:cNvPr>
@@ -6954,7 +6954,7 @@
           <p:cNvPr id="6" name="">
             <a:extLst xmlns:a="http://schemas.openxmlformats.org/drawingml/2006/main">
               <a:ext uri="{FF2B5EF4-FFF2-40B4-BE49-F238E27FC236}">
-                <a16:creationId xmlns:a16="http://schemas.microsoft.com/office/drawing/2014/main" id="{83AA2EB7-99C2-43E2-8E2C-32E4948A1BDA}"/>
+                <a16:creationId xmlns:a16="http://schemas.microsoft.com/office/drawing/2014/main" id="{7F3A685E-72A6-4CFC-8B88-D4F2350EEEEB}"/>
               </a:ext>
             </a:extLst>
           </p:cNvPr>
@@ -7004,7 +7004,7 @@
           <p:cNvPr id="7" name="">
             <a:extLst xmlns:a="http://schemas.openxmlformats.org/drawingml/2006/main">
               <a:ext uri="{FF2B5EF4-FFF2-40B4-BE49-F238E27FC236}">
-                <a16:creationId xmlns:a16="http://schemas.microsoft.com/office/drawing/2014/main" id="{FC41EBE2-65A4-4ED7-BD08-8E083D8CA6DC}"/>
+                <a16:creationId xmlns:a16="http://schemas.microsoft.com/office/drawing/2014/main" id="{ADD3CF1A-BC30-4C18-8D31-3601A1394E66}"/>
               </a:ext>
             </a:extLst>
           </p:cNvPr>
@@ -7054,7 +7054,7 @@
           <p:cNvPr id="8" name="">
             <a:extLst xmlns:a="http://schemas.openxmlformats.org/drawingml/2006/main">
               <a:ext uri="{FF2B5EF4-FFF2-40B4-BE49-F238E27FC236}">
-                <a16:creationId xmlns:a16="http://schemas.microsoft.com/office/drawing/2014/main" id="{E67D8CD0-1CFA-4E90-9D35-EBEF2E7C4CA7}"/>
+                <a16:creationId xmlns:a16="http://schemas.microsoft.com/office/drawing/2014/main" id="{D7AC36BD-8807-49D2-AA35-4A99550E4880}"/>
               </a:ext>
             </a:extLst>
           </p:cNvPr>
@@ -7104,7 +7104,7 @@
           <p:cNvPr id="9" name="">
             <a:extLst xmlns:a="http://schemas.openxmlformats.org/drawingml/2006/main">
               <a:ext uri="{FF2B5EF4-FFF2-40B4-BE49-F238E27FC236}">
-                <a16:creationId xmlns:a16="http://schemas.microsoft.com/office/drawing/2014/main" id="{47F56773-2172-4C3F-8763-BB9C16CD9CCE}"/>
+                <a16:creationId xmlns:a16="http://schemas.microsoft.com/office/drawing/2014/main" id="{C0F8D04C-7F76-44E1-8136-679FAB8ED3A5}"/>
               </a:ext>
             </a:extLst>
           </p:cNvPr>
@@ -7154,7 +7154,7 @@
           <p:cNvPr id="10" name="">
             <a:extLst xmlns:a="http://schemas.openxmlformats.org/drawingml/2006/main">
               <a:ext uri="{FF2B5EF4-FFF2-40B4-BE49-F238E27FC236}">
-                <a16:creationId xmlns:a16="http://schemas.microsoft.com/office/drawing/2014/main" id="{AA866D81-E29A-48AD-8F8A-FBDC7866B263}"/>
+                <a16:creationId xmlns:a16="http://schemas.microsoft.com/office/drawing/2014/main" id="{7880EFD1-90E9-4B45-8184-66E8D2C3A992}"/>
               </a:ext>
             </a:extLst>
           </p:cNvPr>
@@ -7204,7 +7204,7 @@
           <p:cNvPr id="11" name="">
             <a:extLst xmlns:a="http://schemas.openxmlformats.org/drawingml/2006/main">
               <a:ext uri="{FF2B5EF4-FFF2-40B4-BE49-F238E27FC236}">
-                <a16:creationId xmlns:a16="http://schemas.microsoft.com/office/drawing/2014/main" id="{7056D467-050B-4894-B03D-A5D6685ADF39}"/>
+                <a16:creationId xmlns:a16="http://schemas.microsoft.com/office/drawing/2014/main" id="{4C257644-7E0D-46AF-ADA8-2B8C0D7BA095}"/>
               </a:ext>
             </a:extLst>
           </p:cNvPr>
@@ -7254,7 +7254,7 @@
           <p:cNvPr id="12" name="">
             <a:extLst xmlns:a="http://schemas.openxmlformats.org/drawingml/2006/main">
               <a:ext uri="{FF2B5EF4-FFF2-40B4-BE49-F238E27FC236}">
-                <a16:creationId xmlns:a16="http://schemas.microsoft.com/office/drawing/2014/main" id="{4FDED132-6FEC-4A5E-A222-D44627F7A714}"/>
+                <a16:creationId xmlns:a16="http://schemas.microsoft.com/office/drawing/2014/main" id="{5767BEF2-3CCC-416A-9757-93E2C7B2320B}"/>
               </a:ext>
             </a:extLst>
           </p:cNvPr>
@@ -7304,7 +7304,7 @@
           <p:cNvPr id="13" name="">
             <a:extLst xmlns:a="http://schemas.openxmlformats.org/drawingml/2006/main">
               <a:ext uri="{FF2B5EF4-FFF2-40B4-BE49-F238E27FC236}">
-                <a16:creationId xmlns:a16="http://schemas.microsoft.com/office/drawing/2014/main" id="{F1FCA2CE-3DC8-4DE1-A2AB-B956DCAA1614}"/>
+                <a16:creationId xmlns:a16="http://schemas.microsoft.com/office/drawing/2014/main" id="{862892D2-BD50-42F4-A1FC-83DB9BC3D0C8}"/>
               </a:ext>
             </a:extLst>
           </p:cNvPr>
@@ -7354,7 +7354,7 @@
           <p:cNvPr id="14" name="">
             <a:extLst xmlns:a="http://schemas.openxmlformats.org/drawingml/2006/main">
               <a:ext uri="{FF2B5EF4-FFF2-40B4-BE49-F238E27FC236}">
-                <a16:creationId xmlns:a16="http://schemas.microsoft.com/office/drawing/2014/main" id="{91616157-8D61-4448-98EC-3BD4FA74334A}"/>
+                <a16:creationId xmlns:a16="http://schemas.microsoft.com/office/drawing/2014/main" id="{9E36B759-EC10-4B6B-8F45-E726B50D42C9}"/>
               </a:ext>
             </a:extLst>
           </p:cNvPr>
@@ -7404,7 +7404,7 @@
           <p:cNvPr id="15" name="">
             <a:extLst xmlns:a="http://schemas.openxmlformats.org/drawingml/2006/main">
               <a:ext uri="{FF2B5EF4-FFF2-40B4-BE49-F238E27FC236}">
-                <a16:creationId xmlns:a16="http://schemas.microsoft.com/office/drawing/2014/main" id="{45F5872B-76D5-4FC3-A7F4-93AA58C247C8}"/>
+                <a16:creationId xmlns:a16="http://schemas.microsoft.com/office/drawing/2014/main" id="{2377F403-BABB-40A0-859A-81FFD703C7B5}"/>
               </a:ext>
             </a:extLst>
           </p:cNvPr>
@@ -7443,7 +7443,7 @@
           <p:nvPr/>
         </p:nvPicPr>
         <p:blipFill>
-          <a:blip xmlns:r="http://schemas.openxmlformats.org/officeDocument/2006/relationships" xmlns:a="http://schemas.openxmlformats.org/drawingml/2006/main" r:embed="R1f2d6e2b08634ff0"/>
+          <a:blip xmlns:r="http://schemas.openxmlformats.org/officeDocument/2006/relationships" xmlns:a="http://schemas.openxmlformats.org/drawingml/2006/main" r:embed="Ra4318a5d63bd4c85"/>
           <a:stretch xmlns:a="http://schemas.openxmlformats.org/drawingml/2006/main"/>
         </p:blipFill>
         <p:spPr>
@@ -7463,7 +7463,7 @@
           <p:cNvPr id="17" name="">
             <a:extLst xmlns:a="http://schemas.openxmlformats.org/drawingml/2006/main">
               <a:ext uri="{FF2B5EF4-FFF2-40B4-BE49-F238E27FC236}">
-                <a16:creationId xmlns:a16="http://schemas.microsoft.com/office/drawing/2014/main" id="{D8EF6432-41DC-4DAB-8170-ACFF546E7BA5}"/>
+                <a16:creationId xmlns:a16="http://schemas.microsoft.com/office/drawing/2014/main" id="{C5F739A0-4509-4009-9A8A-70751AC356E0}"/>
               </a:ext>
             </a:extLst>
           </p:cNvPr>
@@ -7511,7 +7511,7 @@
     </p:spTree>
     <p:extLst>
       <p:ext uri="{BB962C8B-B14F-4D97-AF65-F5344CB8AC3E}">
-        <p14:creationId xmlns:p14="http://schemas.microsoft.com/office/powerpoint/2010/main" val="923496208"/>
+        <p14:creationId xmlns:p14="http://schemas.microsoft.com/office/powerpoint/2010/main" val="239124053"/>
       </p:ext>
     </p:extLst>
   </p:cSld>
@@ -7542,7 +7542,7 @@
           <p:cNvPr id="1" name="">
             <a:extLst xmlns:a="http://schemas.openxmlformats.org/drawingml/2006/main">
               <a:ext uri="{FF2B5EF4-FFF2-40B4-BE49-F238E27FC236}">
-                <a16:creationId xmlns:a16="http://schemas.microsoft.com/office/drawing/2014/main" id="{73467805-0F5B-4EE5-8918-88687CA88C20}"/>
+                <a16:creationId xmlns:a16="http://schemas.microsoft.com/office/drawing/2014/main" id="{026D46DD-0D01-46E8-B5C4-7B23DFC33551}"/>
               </a:ext>
             </a:extLst>
           </p:cNvPr>
@@ -7573,7 +7573,7 @@
           <p:cNvPr id="2" name="">
             <a:extLst xmlns:a="http://schemas.openxmlformats.org/drawingml/2006/main">
               <a:ext uri="{FF2B5EF4-FFF2-40B4-BE49-F238E27FC236}">
-                <a16:creationId xmlns:a16="http://schemas.microsoft.com/office/drawing/2014/main" id="{A3D773D7-A033-46CF-A5F0-AE229E0A9647}"/>
+                <a16:creationId xmlns:a16="http://schemas.microsoft.com/office/drawing/2014/main" id="{29F13E8D-19EA-4795-AE05-2BE38B66E8EA}"/>
               </a:ext>
             </a:extLst>
           </p:cNvPr>
@@ -7623,7 +7623,7 @@
           <p:cNvPr id="3" name="">
             <a:extLst xmlns:a="http://schemas.openxmlformats.org/drawingml/2006/main">
               <a:ext uri="{FF2B5EF4-FFF2-40B4-BE49-F238E27FC236}">
-                <a16:creationId xmlns:a16="http://schemas.microsoft.com/office/drawing/2014/main" id="{9BACCACB-0C18-4EFD-998A-FA0DA59D5E88}"/>
+                <a16:creationId xmlns:a16="http://schemas.microsoft.com/office/drawing/2014/main" id="{BE788E69-2DB4-406E-B487-00F96A53A5EB}"/>
               </a:ext>
             </a:extLst>
           </p:cNvPr>
@@ -7673,7 +7673,7 @@
           <p:cNvPr id="4" name="">
             <a:extLst xmlns:a="http://schemas.openxmlformats.org/drawingml/2006/main">
               <a:ext uri="{FF2B5EF4-FFF2-40B4-BE49-F238E27FC236}">
-                <a16:creationId xmlns:a16="http://schemas.microsoft.com/office/drawing/2014/main" id="{9820BCDE-5F1B-49B7-9C54-3527BBB2E988}"/>
+                <a16:creationId xmlns:a16="http://schemas.microsoft.com/office/drawing/2014/main" id="{CA15E57B-9179-4AB8-8C88-9FBB2436E840}"/>
               </a:ext>
             </a:extLst>
           </p:cNvPr>
@@ -7704,7 +7704,7 @@
           <p:cNvPr id="5" name="">
             <a:extLst xmlns:a="http://schemas.openxmlformats.org/drawingml/2006/main">
               <a:ext uri="{FF2B5EF4-FFF2-40B4-BE49-F238E27FC236}">
-                <a16:creationId xmlns:a16="http://schemas.microsoft.com/office/drawing/2014/main" id="{F81339B7-B4BC-4F8A-96D0-A93A45C5F600}"/>
+                <a16:creationId xmlns:a16="http://schemas.microsoft.com/office/drawing/2014/main" id="{2D9F6794-E406-4725-8A49-39219474F08C}"/>
               </a:ext>
             </a:extLst>
           </p:cNvPr>
@@ -7754,7 +7754,7 @@
           <p:cNvPr id="6" name="">
             <a:extLst xmlns:a="http://schemas.openxmlformats.org/drawingml/2006/main">
               <a:ext uri="{FF2B5EF4-FFF2-40B4-BE49-F238E27FC236}">
-                <a16:creationId xmlns:a16="http://schemas.microsoft.com/office/drawing/2014/main" id="{3513ECEE-F1C1-4ACD-A4D9-EED0D4395D8E}"/>
+                <a16:creationId xmlns:a16="http://schemas.microsoft.com/office/drawing/2014/main" id="{3B49C7BA-E81F-43AB-9B03-F7242AEBF679}"/>
               </a:ext>
             </a:extLst>
           </p:cNvPr>
@@ -7804,7 +7804,7 @@
           <p:cNvPr id="7" name="">
             <a:extLst xmlns:a="http://schemas.openxmlformats.org/drawingml/2006/main">
               <a:ext uri="{FF2B5EF4-FFF2-40B4-BE49-F238E27FC236}">
-                <a16:creationId xmlns:a16="http://schemas.microsoft.com/office/drawing/2014/main" id="{46D9519E-9AA7-4BA3-A406-2950932E8D34}"/>
+                <a16:creationId xmlns:a16="http://schemas.microsoft.com/office/drawing/2014/main" id="{F9D54D8E-9E08-4AB2-ACBD-3FD17AAA47EB}"/>
               </a:ext>
             </a:extLst>
           </p:cNvPr>
@@ -7858,7 +7858,7 @@
           <p:nvPr/>
         </p:nvPicPr>
         <p:blipFill>
-          <a:blip xmlns:r="http://schemas.openxmlformats.org/officeDocument/2006/relationships" xmlns:a="http://schemas.openxmlformats.org/drawingml/2006/main" r:embed="R5e377f3cee4e4b9e"/>
+          <a:blip xmlns:r="http://schemas.openxmlformats.org/officeDocument/2006/relationships" xmlns:a="http://schemas.openxmlformats.org/drawingml/2006/main" r:embed="R54c5c16395ef4d49"/>
           <a:stretch xmlns:a="http://schemas.openxmlformats.org/drawingml/2006/main"/>
         </p:blipFill>
         <p:spPr>
@@ -7878,7 +7878,7 @@
           <p:cNvPr id="9" name="">
             <a:extLst xmlns:a="http://schemas.openxmlformats.org/drawingml/2006/main">
               <a:ext uri="{FF2B5EF4-FFF2-40B4-BE49-F238E27FC236}">
-                <a16:creationId xmlns:a16="http://schemas.microsoft.com/office/drawing/2014/main" id="{FB15E3BD-D18F-4C3D-8A6B-996609EC074B}"/>
+                <a16:creationId xmlns:a16="http://schemas.microsoft.com/office/drawing/2014/main" id="{0A001E9F-9E69-4315-B504-3FF507301097}"/>
               </a:ext>
             </a:extLst>
           </p:cNvPr>
@@ -7926,7 +7926,7 @@
     </p:spTree>
     <p:extLst>
       <p:ext uri="{BB962C8B-B14F-4D97-AF65-F5344CB8AC3E}">
-        <p14:creationId xmlns:p14="http://schemas.microsoft.com/office/powerpoint/2010/main" val="642741476"/>
+        <p14:creationId xmlns:p14="http://schemas.microsoft.com/office/powerpoint/2010/main" val="881195958"/>
       </p:ext>
     </p:extLst>
   </p:cSld>
@@ -7957,7 +7957,7 @@
           <p:cNvPr id="1" name="">
             <a:extLst xmlns:a="http://schemas.openxmlformats.org/drawingml/2006/main">
               <a:ext uri="{FF2B5EF4-FFF2-40B4-BE49-F238E27FC236}">
-                <a16:creationId xmlns:a16="http://schemas.microsoft.com/office/drawing/2014/main" id="{49CE9798-3C53-4101-8AAC-1E99931A7E34}"/>
+                <a16:creationId xmlns:a16="http://schemas.microsoft.com/office/drawing/2014/main" id="{49A82FD8-0540-4033-A070-950EC4807AE9}"/>
               </a:ext>
             </a:extLst>
           </p:cNvPr>
@@ -7988,7 +7988,7 @@
           <p:cNvPr id="2" name="">
             <a:extLst xmlns:a="http://schemas.openxmlformats.org/drawingml/2006/main">
               <a:ext uri="{FF2B5EF4-FFF2-40B4-BE49-F238E27FC236}">
-                <a16:creationId xmlns:a16="http://schemas.microsoft.com/office/drawing/2014/main" id="{57D50948-464D-42E9-ADFE-F8225736BC04}"/>
+                <a16:creationId xmlns:a16="http://schemas.microsoft.com/office/drawing/2014/main" id="{905192A6-02AE-4F50-BCB1-C672959782CE}"/>
               </a:ext>
             </a:extLst>
           </p:cNvPr>
@@ -8038,7 +8038,7 @@
           <p:cNvPr id="3" name="">
             <a:extLst xmlns:a="http://schemas.openxmlformats.org/drawingml/2006/main">
               <a:ext uri="{FF2B5EF4-FFF2-40B4-BE49-F238E27FC236}">
-                <a16:creationId xmlns:a16="http://schemas.microsoft.com/office/drawing/2014/main" id="{0A169A1B-2F51-4C8D-B08D-4BA7C387A046}"/>
+                <a16:creationId xmlns:a16="http://schemas.microsoft.com/office/drawing/2014/main" id="{F3B4F65E-9E07-4083-AF68-B62802772E76}"/>
               </a:ext>
             </a:extLst>
           </p:cNvPr>
@@ -8088,7 +8088,7 @@
           <p:cNvPr id="4" name="">
             <a:extLst xmlns:a="http://schemas.openxmlformats.org/drawingml/2006/main">
               <a:ext uri="{FF2B5EF4-FFF2-40B4-BE49-F238E27FC236}">
-                <a16:creationId xmlns:a16="http://schemas.microsoft.com/office/drawing/2014/main" id="{2E61CCBE-2BAD-419D-A598-B4319921D28B}"/>
+                <a16:creationId xmlns:a16="http://schemas.microsoft.com/office/drawing/2014/main" id="{6B49DCDA-2048-4CFE-9151-CF3B1139343B}"/>
               </a:ext>
             </a:extLst>
           </p:cNvPr>
@@ -8119,7 +8119,7 @@
           <p:cNvPr id="5" name="">
             <a:extLst xmlns:a="http://schemas.openxmlformats.org/drawingml/2006/main">
               <a:ext uri="{FF2B5EF4-FFF2-40B4-BE49-F238E27FC236}">
-                <a16:creationId xmlns:a16="http://schemas.microsoft.com/office/drawing/2014/main" id="{AE108842-36E0-4088-8FC1-FA0058BE5A27}"/>
+                <a16:creationId xmlns:a16="http://schemas.microsoft.com/office/drawing/2014/main" id="{F9B1662E-F4C8-4489-8B43-6688332342B8}"/>
               </a:ext>
             </a:extLst>
           </p:cNvPr>
@@ -8169,7 +8169,7 @@
           <p:cNvPr id="6" name="">
             <a:extLst xmlns:a="http://schemas.openxmlformats.org/drawingml/2006/main">
               <a:ext uri="{FF2B5EF4-FFF2-40B4-BE49-F238E27FC236}">
-                <a16:creationId xmlns:a16="http://schemas.microsoft.com/office/drawing/2014/main" id="{011A4D77-B924-4480-9783-6C812B66EF13}"/>
+                <a16:creationId xmlns:a16="http://schemas.microsoft.com/office/drawing/2014/main" id="{09B27E55-8357-41B2-BB91-E1424BF5DFCF}"/>
               </a:ext>
             </a:extLst>
           </p:cNvPr>
@@ -8219,7 +8219,7 @@
           <p:cNvPr id="7" name="">
             <a:extLst xmlns:a="http://schemas.openxmlformats.org/drawingml/2006/main">
               <a:ext uri="{FF2B5EF4-FFF2-40B4-BE49-F238E27FC236}">
-                <a16:creationId xmlns:a16="http://schemas.microsoft.com/office/drawing/2014/main" id="{6265EAA7-4FAD-4782-84E5-2E5CE99444ED}"/>
+                <a16:creationId xmlns:a16="http://schemas.microsoft.com/office/drawing/2014/main" id="{B0F8612B-BC77-443B-A5F3-4394DED706FF}"/>
               </a:ext>
             </a:extLst>
           </p:cNvPr>
@@ -8269,7 +8269,7 @@
           <p:cNvPr id="8" name="">
             <a:extLst xmlns:a="http://schemas.openxmlformats.org/drawingml/2006/main">
               <a:ext uri="{FF2B5EF4-FFF2-40B4-BE49-F238E27FC236}">
-                <a16:creationId xmlns:a16="http://schemas.microsoft.com/office/drawing/2014/main" id="{63699453-FCF0-42F8-84A0-1BD57079AAA9}"/>
+                <a16:creationId xmlns:a16="http://schemas.microsoft.com/office/drawing/2014/main" id="{ECC17618-19C5-4161-8619-3D01D882DCD0}"/>
               </a:ext>
             </a:extLst>
           </p:cNvPr>
@@ -8319,7 +8319,7 @@
           <p:cNvPr id="9" name="">
             <a:extLst xmlns:a="http://schemas.openxmlformats.org/drawingml/2006/main">
               <a:ext uri="{FF2B5EF4-FFF2-40B4-BE49-F238E27FC236}">
-                <a16:creationId xmlns:a16="http://schemas.microsoft.com/office/drawing/2014/main" id="{4BE35AFE-0546-4A9F-A067-B22FD646E432}"/>
+                <a16:creationId xmlns:a16="http://schemas.microsoft.com/office/drawing/2014/main" id="{5313CCDA-8A32-468D-B253-DDCC89671C82}"/>
               </a:ext>
             </a:extLst>
           </p:cNvPr>
@@ -8359,7 +8359,7 @@
                   <a:srgbClr val="27865C"/>
                 </a:solidFill>
               </a:rPr>
-              <a:t>11/11</a:t>
+              <a:t>13/13</a:t>
             </a:r>
           </a:p>
         </p:txBody>
@@ -8369,7 +8369,7 @@
           <p:cNvPr id="10" name="">
             <a:extLst xmlns:a="http://schemas.openxmlformats.org/drawingml/2006/main">
               <a:ext uri="{FF2B5EF4-FFF2-40B4-BE49-F238E27FC236}">
-                <a16:creationId xmlns:a16="http://schemas.microsoft.com/office/drawing/2014/main" id="{F576727D-EAE6-4CE5-8F7B-4B9F2A8F0AC2}"/>
+                <a16:creationId xmlns:a16="http://schemas.microsoft.com/office/drawing/2014/main" id="{C00625AF-FFBB-447B-832C-BF28099748F8}"/>
               </a:ext>
             </a:extLst>
           </p:cNvPr>
@@ -8419,7 +8419,7 @@
           <p:cNvPr id="11" name="">
             <a:extLst xmlns:a="http://schemas.openxmlformats.org/drawingml/2006/main">
               <a:ext uri="{FF2B5EF4-FFF2-40B4-BE49-F238E27FC236}">
-                <a16:creationId xmlns:a16="http://schemas.microsoft.com/office/drawing/2014/main" id="{E81A98BA-A573-4537-B295-C8707B39A70E}"/>
+                <a16:creationId xmlns:a16="http://schemas.microsoft.com/office/drawing/2014/main" id="{74E0ED53-ACA7-4E38-899D-78BE6BF756C4}"/>
               </a:ext>
             </a:extLst>
           </p:cNvPr>
@@ -8469,7 +8469,7 @@
           <p:cNvPr id="12" name="">
             <a:extLst xmlns:a="http://schemas.openxmlformats.org/drawingml/2006/main">
               <a:ext uri="{FF2B5EF4-FFF2-40B4-BE49-F238E27FC236}">
-                <a16:creationId xmlns:a16="http://schemas.microsoft.com/office/drawing/2014/main" id="{046A0BF4-E5A3-486F-868B-A606AC71739A}"/>
+                <a16:creationId xmlns:a16="http://schemas.microsoft.com/office/drawing/2014/main" id="{8EDEA068-E3E3-4E21-9AA9-3800E8586265}"/>
               </a:ext>
             </a:extLst>
           </p:cNvPr>
@@ -8519,7 +8519,7 @@
           <p:cNvPr id="13" name="">
             <a:extLst xmlns:a="http://schemas.openxmlformats.org/drawingml/2006/main">
               <a:ext uri="{FF2B5EF4-FFF2-40B4-BE49-F238E27FC236}">
-                <a16:creationId xmlns:a16="http://schemas.microsoft.com/office/drawing/2014/main" id="{6F302522-D21B-4637-9A8B-B2CAA54335ED}"/>
+                <a16:creationId xmlns:a16="http://schemas.microsoft.com/office/drawing/2014/main" id="{51B5ECD5-8EC5-4976-9252-0EED461661E2}"/>
               </a:ext>
             </a:extLst>
           </p:cNvPr>
@@ -8554,7 +8554,7 @@
           <p:cNvPr id="14" name="">
             <a:extLst xmlns:a="http://schemas.openxmlformats.org/drawingml/2006/main">
               <a:ext uri="{FF2B5EF4-FFF2-40B4-BE49-F238E27FC236}">
-                <a16:creationId xmlns:a16="http://schemas.microsoft.com/office/drawing/2014/main" id="{30F45803-68F9-4D86-BB0F-82D68837FFDE}"/>
+                <a16:creationId xmlns:a16="http://schemas.microsoft.com/office/drawing/2014/main" id="{3F97D87B-AA4A-497F-98CF-46EBE61528B0}"/>
               </a:ext>
             </a:extLst>
           </p:cNvPr>
@@ -8650,7 +8650,7 @@
                   <a:srgbClr val="DDF7EC"/>
                 </a:solidFill>
               </a:rPr>
-              <a:t>✓ 11 tests passed</a:t>
+              <a:t>✓ 13 tests passed</a:t>
             </a:r>
           </a:p>
           <a:p xmlns:a="http://schemas.openxmlformats.org/drawingml/2006/main">
@@ -8699,7 +8699,7 @@
           <p:cNvPr id="15" name="">
             <a:extLst xmlns:a="http://schemas.openxmlformats.org/drawingml/2006/main">
               <a:ext uri="{FF2B5EF4-FFF2-40B4-BE49-F238E27FC236}">
-                <a16:creationId xmlns:a16="http://schemas.microsoft.com/office/drawing/2014/main" id="{B7F21E88-8FC8-44CB-A102-F849575138AF}"/>
+                <a16:creationId xmlns:a16="http://schemas.microsoft.com/office/drawing/2014/main" id="{BF29268C-B87E-4E71-8C3E-057EDE74B8A9}"/>
               </a:ext>
             </a:extLst>
           </p:cNvPr>
@@ -8747,7 +8747,7 @@
     </p:spTree>
     <p:extLst>
       <p:ext uri="{BB962C8B-B14F-4D97-AF65-F5344CB8AC3E}">
-        <p14:creationId xmlns:p14="http://schemas.microsoft.com/office/powerpoint/2010/main" val="981685079"/>
+        <p14:creationId xmlns:p14="http://schemas.microsoft.com/office/powerpoint/2010/main" val="1295120111"/>
       </p:ext>
     </p:extLst>
   </p:cSld>

</xml_diff>

<commit_message>
Add external terminology and clinical review evidence
</commit_message>
<xml_diff>
--- a/submission/final_pitch_deck.pptx
+++ b/submission/final_pitch_deck.pptx
@@ -2,22 +2,22 @@
 <file path=ppt/presentation.xml><?xml version="1.0" encoding="utf-8"?>
 <p:presentation xmlns:p="http://schemas.openxmlformats.org/presentationml/2006/main">
   <p:sldMasterIdLst>
-    <p:sldMasterId xmlns:r="http://schemas.openxmlformats.org/officeDocument/2006/relationships" id="2147483648" r:id="R0fad656aef2d4fd9"/>
+    <p:sldMasterId xmlns:r="http://schemas.openxmlformats.org/officeDocument/2006/relationships" id="2147483648" r:id="R7813e4d0b8964d4e"/>
   </p:sldMasterIdLst>
   <p:notesMasterIdLst>
-    <p:notesMasterId xmlns:r="http://schemas.openxmlformats.org/officeDocument/2006/relationships" r:id="R142da48f27164bf4"/>
+    <p:notesMasterId xmlns:r="http://schemas.openxmlformats.org/officeDocument/2006/relationships" r:id="Raad9519514554aad"/>
   </p:notesMasterIdLst>
   <p:sldIdLst>
-    <p:sldId xmlns:r="http://schemas.openxmlformats.org/officeDocument/2006/relationships" id="256" r:id="R1b96bfc8e46e42b5"/>
-    <p:sldId xmlns:r="http://schemas.openxmlformats.org/officeDocument/2006/relationships" id="257" r:id="Raeaf84b357c04d66"/>
-    <p:sldId xmlns:r="http://schemas.openxmlformats.org/officeDocument/2006/relationships" id="258" r:id="R6f58a3bbdbe44d77"/>
-    <p:sldId xmlns:r="http://schemas.openxmlformats.org/officeDocument/2006/relationships" id="259" r:id="Rc3f2421838fb4e4b"/>
-    <p:sldId xmlns:r="http://schemas.openxmlformats.org/officeDocument/2006/relationships" id="260" r:id="R7f03523f9bc84105"/>
-    <p:sldId xmlns:r="http://schemas.openxmlformats.org/officeDocument/2006/relationships" id="261" r:id="R60b032471da14580"/>
-    <p:sldId xmlns:r="http://schemas.openxmlformats.org/officeDocument/2006/relationships" id="262" r:id="R898dc85c344c4651"/>
-    <p:sldId xmlns:r="http://schemas.openxmlformats.org/officeDocument/2006/relationships" id="263" r:id="R4508ba75334d448c"/>
-    <p:sldId xmlns:r="http://schemas.openxmlformats.org/officeDocument/2006/relationships" id="264" r:id="R3d3d3df5144e41e5"/>
-    <p:sldId xmlns:r="http://schemas.openxmlformats.org/officeDocument/2006/relationships" id="265" r:id="Ra05555899284461e"/>
+    <p:sldId xmlns:r="http://schemas.openxmlformats.org/officeDocument/2006/relationships" id="256" r:id="Rfa8e9dbca56e4e62"/>
+    <p:sldId xmlns:r="http://schemas.openxmlformats.org/officeDocument/2006/relationships" id="257" r:id="Ra5d40fa1a29e4969"/>
+    <p:sldId xmlns:r="http://schemas.openxmlformats.org/officeDocument/2006/relationships" id="258" r:id="Rbe4a7d31dc014b87"/>
+    <p:sldId xmlns:r="http://schemas.openxmlformats.org/officeDocument/2006/relationships" id="259" r:id="R932162d7f49a4eef"/>
+    <p:sldId xmlns:r="http://schemas.openxmlformats.org/officeDocument/2006/relationships" id="260" r:id="R5936f193d9df4911"/>
+    <p:sldId xmlns:r="http://schemas.openxmlformats.org/officeDocument/2006/relationships" id="261" r:id="R108aa61e648f46ed"/>
+    <p:sldId xmlns:r="http://schemas.openxmlformats.org/officeDocument/2006/relationships" id="262" r:id="R653e87133b414684"/>
+    <p:sldId xmlns:r="http://schemas.openxmlformats.org/officeDocument/2006/relationships" id="263" r:id="Ra24fe814fe244c92"/>
+    <p:sldId xmlns:r="http://schemas.openxmlformats.org/officeDocument/2006/relationships" id="264" r:id="R1d31ff63b09545ec"/>
+    <p:sldId xmlns:r="http://schemas.openxmlformats.org/officeDocument/2006/relationships" id="265" r:id="R6cbb4fdfacb44262"/>
   </p:sldIdLst>
   <p:sldSz cx="12192000" cy="6858000"/>
   <p:notesSz cx="6858000" cy="9144000"/>
@@ -1204,7 +1204,7 @@
   </p:cSld>
   <p:clrMap bg1="lt1" tx1="dk1" bg2="lt2" tx2="dk2" accent1="accent1" accent2="accent2" accent3="accent3" accent4="accent4" accent5="accent5" accent6="accent6" hlink="hlink" folHlink="folHlink"/>
   <p:sldLayoutIdLst>
-    <p:sldLayoutId xmlns:r="http://schemas.openxmlformats.org/officeDocument/2006/relationships" id="2147483649" r:id="Ra665a8608aff418d"/>
+    <p:sldLayoutId xmlns:r="http://schemas.openxmlformats.org/officeDocument/2006/relationships" id="2147483649" r:id="R666e3d29e2b0492e"/>
   </p:sldLayoutIdLst>
   <p:txStyles>
     <p:titleStyle>
@@ -1755,7 +1755,7 @@
           <p:cNvPr id="1" name="">
             <a:extLst xmlns:a="http://schemas.openxmlformats.org/drawingml/2006/main">
               <a:ext uri="{FF2B5EF4-FFF2-40B4-BE49-F238E27FC236}">
-                <a16:creationId xmlns:a16="http://schemas.microsoft.com/office/drawing/2014/main" id="{1A3C446C-805D-4A4A-A409-26566C2D26A3}"/>
+                <a16:creationId xmlns:a16="http://schemas.microsoft.com/office/drawing/2014/main" id="{9AD64134-ACE1-475E-9D60-19DFCEA60D92}"/>
               </a:ext>
             </a:extLst>
           </p:cNvPr>
@@ -1786,7 +1786,7 @@
           <p:cNvPr id="2" name="">
             <a:extLst xmlns:a="http://schemas.openxmlformats.org/drawingml/2006/main">
               <a:ext uri="{FF2B5EF4-FFF2-40B4-BE49-F238E27FC236}">
-                <a16:creationId xmlns:a16="http://schemas.microsoft.com/office/drawing/2014/main" id="{3EB217F0-2732-42F7-ADCF-D98F192ACC1F}"/>
+                <a16:creationId xmlns:a16="http://schemas.microsoft.com/office/drawing/2014/main" id="{EA2A6CB6-5826-4DF5-92AE-CD0FEEAD47C1}"/>
               </a:ext>
             </a:extLst>
           </p:cNvPr>
@@ -1836,7 +1836,7 @@
           <p:cNvPr id="3" name="">
             <a:extLst xmlns:a="http://schemas.openxmlformats.org/drawingml/2006/main">
               <a:ext uri="{FF2B5EF4-FFF2-40B4-BE49-F238E27FC236}">
-                <a16:creationId xmlns:a16="http://schemas.microsoft.com/office/drawing/2014/main" id="{B4CAADFA-9034-4330-B67B-383563F6658D}"/>
+                <a16:creationId xmlns:a16="http://schemas.microsoft.com/office/drawing/2014/main" id="{BE0FD02D-E784-4A38-8116-001682964F82}"/>
               </a:ext>
             </a:extLst>
           </p:cNvPr>
@@ -1903,7 +1903,7 @@
           <p:cNvPr id="4" name="">
             <a:extLst xmlns:a="http://schemas.openxmlformats.org/drawingml/2006/main">
               <a:ext uri="{FF2B5EF4-FFF2-40B4-BE49-F238E27FC236}">
-                <a16:creationId xmlns:a16="http://schemas.microsoft.com/office/drawing/2014/main" id="{3FD728CD-909D-40EB-8759-E273D1E2E581}"/>
+                <a16:creationId xmlns:a16="http://schemas.microsoft.com/office/drawing/2014/main" id="{297DD1B8-57B0-4F9E-AE74-4B4966E05FC4}"/>
               </a:ext>
             </a:extLst>
           </p:cNvPr>
@@ -1953,7 +1953,7 @@
           <p:cNvPr id="5" name="">
             <a:extLst xmlns:a="http://schemas.openxmlformats.org/drawingml/2006/main">
               <a:ext uri="{FF2B5EF4-FFF2-40B4-BE49-F238E27FC236}">
-                <a16:creationId xmlns:a16="http://schemas.microsoft.com/office/drawing/2014/main" id="{5D987F70-26D8-4143-A4C0-0EC7FF0CF6E4}"/>
+                <a16:creationId xmlns:a16="http://schemas.microsoft.com/office/drawing/2014/main" id="{95B57B60-CF1A-4B37-A227-90875D448497}"/>
               </a:ext>
             </a:extLst>
           </p:cNvPr>
@@ -1984,7 +1984,7 @@
           <p:cNvPr id="6" name="">
             <a:extLst xmlns:a="http://schemas.openxmlformats.org/drawingml/2006/main">
               <a:ext uri="{FF2B5EF4-FFF2-40B4-BE49-F238E27FC236}">
-                <a16:creationId xmlns:a16="http://schemas.microsoft.com/office/drawing/2014/main" id="{B3A95949-C2CF-4267-8FAB-A68B00427666}"/>
+                <a16:creationId xmlns:a16="http://schemas.microsoft.com/office/drawing/2014/main" id="{B02B1BAF-62B1-4189-9CC8-6330A2478E5F}"/>
               </a:ext>
             </a:extLst>
           </p:cNvPr>
@@ -2051,7 +2051,7 @@
           <p:cNvPr id="7" name="">
             <a:extLst xmlns:a="http://schemas.openxmlformats.org/drawingml/2006/main">
               <a:ext uri="{FF2B5EF4-FFF2-40B4-BE49-F238E27FC236}">
-                <a16:creationId xmlns:a16="http://schemas.microsoft.com/office/drawing/2014/main" id="{C3B0E2E1-E26F-49D9-B57C-CF6E95B438DF}"/>
+                <a16:creationId xmlns:a16="http://schemas.microsoft.com/office/drawing/2014/main" id="{69DF72B2-9280-4201-B8F3-AC1DC69C0D9E}"/>
               </a:ext>
             </a:extLst>
           </p:cNvPr>
@@ -2090,7 +2090,7 @@
           <p:nvPr/>
         </p:nvPicPr>
         <p:blipFill>
-          <a:blip xmlns:r="http://schemas.openxmlformats.org/officeDocument/2006/relationships" xmlns:a="http://schemas.openxmlformats.org/drawingml/2006/main" r:embed="R55efdd49af8e4b1d"/>
+          <a:blip xmlns:r="http://schemas.openxmlformats.org/officeDocument/2006/relationships" xmlns:a="http://schemas.openxmlformats.org/drawingml/2006/main" r:embed="R25e4c75df29e4caf"/>
           <a:srcRect xmlns:a="http://schemas.openxmlformats.org/drawingml/2006/main" l="11597" t="0" r="11597" b="0"/>
           <a:stretch xmlns:a="http://schemas.openxmlformats.org/drawingml/2006/main">
             <a:fillRect l="0" t="0" r="0" b="0"/>
@@ -2113,7 +2113,7 @@
           <p:cNvPr id="9" name="">
             <a:extLst xmlns:a="http://schemas.openxmlformats.org/drawingml/2006/main">
               <a:ext uri="{FF2B5EF4-FFF2-40B4-BE49-F238E27FC236}">
-                <a16:creationId xmlns:a16="http://schemas.microsoft.com/office/drawing/2014/main" id="{187C65A0-0F9F-4F13-9911-96A67BC08C66}"/>
+                <a16:creationId xmlns:a16="http://schemas.microsoft.com/office/drawing/2014/main" id="{D892FE1B-3FB9-4B11-8755-0D943FBB8A9A}"/>
               </a:ext>
             </a:extLst>
           </p:cNvPr>
@@ -2161,7 +2161,7 @@
     </p:spTree>
     <p:extLst>
       <p:ext uri="{BB962C8B-B14F-4D97-AF65-F5344CB8AC3E}">
-        <p14:creationId xmlns:p14="http://schemas.microsoft.com/office/powerpoint/2010/main" val="164397156"/>
+        <p14:creationId xmlns:p14="http://schemas.microsoft.com/office/powerpoint/2010/main" val="150256572"/>
       </p:ext>
     </p:extLst>
   </p:cSld>
@@ -2192,7 +2192,7 @@
           <p:cNvPr id="1" name="">
             <a:extLst xmlns:a="http://schemas.openxmlformats.org/drawingml/2006/main">
               <a:ext uri="{FF2B5EF4-FFF2-40B4-BE49-F238E27FC236}">
-                <a16:creationId xmlns:a16="http://schemas.microsoft.com/office/drawing/2014/main" id="{8BFB2717-6F2F-4ACD-A4A2-D1990543B9BF}"/>
+                <a16:creationId xmlns:a16="http://schemas.microsoft.com/office/drawing/2014/main" id="{661D3DBB-0F68-4865-8CD8-A5094C8EA918}"/>
               </a:ext>
             </a:extLst>
           </p:cNvPr>
@@ -2242,7 +2242,7 @@
           <p:cNvPr id="2" name="">
             <a:extLst xmlns:a="http://schemas.openxmlformats.org/drawingml/2006/main">
               <a:ext uri="{FF2B5EF4-FFF2-40B4-BE49-F238E27FC236}">
-                <a16:creationId xmlns:a16="http://schemas.microsoft.com/office/drawing/2014/main" id="{C57328DE-D718-494A-80D4-42151ADD35AA}"/>
+                <a16:creationId xmlns:a16="http://schemas.microsoft.com/office/drawing/2014/main" id="{6A81F84C-C66C-4527-8642-BD8CBE84BEE0}"/>
               </a:ext>
             </a:extLst>
           </p:cNvPr>
@@ -2309,7 +2309,7 @@
           <p:cNvPr id="3" name="">
             <a:extLst xmlns:a="http://schemas.openxmlformats.org/drawingml/2006/main">
               <a:ext uri="{FF2B5EF4-FFF2-40B4-BE49-F238E27FC236}">
-                <a16:creationId xmlns:a16="http://schemas.microsoft.com/office/drawing/2014/main" id="{97BDF7EC-FAFE-4D43-9DD8-303225230351}"/>
+                <a16:creationId xmlns:a16="http://schemas.microsoft.com/office/drawing/2014/main" id="{062AE7B8-2206-420B-A191-C90CE1643C67}"/>
               </a:ext>
             </a:extLst>
           </p:cNvPr>
@@ -2344,7 +2344,7 @@
           <p:cNvPr id="4" name="">
             <a:extLst xmlns:a="http://schemas.openxmlformats.org/drawingml/2006/main">
               <a:ext uri="{FF2B5EF4-FFF2-40B4-BE49-F238E27FC236}">
-                <a16:creationId xmlns:a16="http://schemas.microsoft.com/office/drawing/2014/main" id="{B87C97A0-C86E-4223-937C-E1E249D89685}"/>
+                <a16:creationId xmlns:a16="http://schemas.microsoft.com/office/drawing/2014/main" id="{8A6F1C21-E835-4CE6-AEF7-C51BC3D9402A}"/>
               </a:ext>
             </a:extLst>
           </p:cNvPr>
@@ -2394,7 +2394,7 @@
           <p:cNvPr id="5" name="">
             <a:extLst xmlns:a="http://schemas.openxmlformats.org/drawingml/2006/main">
               <a:ext uri="{FF2B5EF4-FFF2-40B4-BE49-F238E27FC236}">
-                <a16:creationId xmlns:a16="http://schemas.microsoft.com/office/drawing/2014/main" id="{03AEA5AB-8731-4F9D-8283-27EE080EBD11}"/>
+                <a16:creationId xmlns:a16="http://schemas.microsoft.com/office/drawing/2014/main" id="{B68F8005-35AB-498F-93A2-27AA79A7A98E}"/>
               </a:ext>
             </a:extLst>
           </p:cNvPr>
@@ -2444,7 +2444,7 @@
           <p:cNvPr id="6" name="">
             <a:extLst xmlns:a="http://schemas.openxmlformats.org/drawingml/2006/main">
               <a:ext uri="{FF2B5EF4-FFF2-40B4-BE49-F238E27FC236}">
-                <a16:creationId xmlns:a16="http://schemas.microsoft.com/office/drawing/2014/main" id="{77861274-FCED-473D-B3CE-AC433B87CBBF}"/>
+                <a16:creationId xmlns:a16="http://schemas.microsoft.com/office/drawing/2014/main" id="{A3BF62B0-AAC1-424E-9462-D3457BEFC46A}"/>
               </a:ext>
             </a:extLst>
           </p:cNvPr>
@@ -2479,7 +2479,7 @@
           <p:cNvPr id="7" name="">
             <a:extLst xmlns:a="http://schemas.openxmlformats.org/drawingml/2006/main">
               <a:ext uri="{FF2B5EF4-FFF2-40B4-BE49-F238E27FC236}">
-                <a16:creationId xmlns:a16="http://schemas.microsoft.com/office/drawing/2014/main" id="{2EB7148E-9665-4783-A730-782286C00E83}"/>
+                <a16:creationId xmlns:a16="http://schemas.microsoft.com/office/drawing/2014/main" id="{62F0157B-17DC-413B-9C55-EB44EED692F2}"/>
               </a:ext>
             </a:extLst>
           </p:cNvPr>
@@ -2529,7 +2529,7 @@
           <p:cNvPr id="8" name="">
             <a:extLst xmlns:a="http://schemas.openxmlformats.org/drawingml/2006/main">
               <a:ext uri="{FF2B5EF4-FFF2-40B4-BE49-F238E27FC236}">
-                <a16:creationId xmlns:a16="http://schemas.microsoft.com/office/drawing/2014/main" id="{343D03A2-277B-464D-84AD-8C6E90E0CA23}"/>
+                <a16:creationId xmlns:a16="http://schemas.microsoft.com/office/drawing/2014/main" id="{26E282D9-A2C5-4890-AC11-5DA95E4ADC1F}"/>
               </a:ext>
             </a:extLst>
           </p:cNvPr>
@@ -2579,7 +2579,7 @@
           <p:cNvPr id="9" name="">
             <a:extLst xmlns:a="http://schemas.openxmlformats.org/drawingml/2006/main">
               <a:ext uri="{FF2B5EF4-FFF2-40B4-BE49-F238E27FC236}">
-                <a16:creationId xmlns:a16="http://schemas.microsoft.com/office/drawing/2014/main" id="{A6D382E5-5FFA-448B-87CD-3C6D69F52CDC}"/>
+                <a16:creationId xmlns:a16="http://schemas.microsoft.com/office/drawing/2014/main" id="{2DE4FA82-E3F9-4B8E-B1D1-A4B2F0B62324}"/>
               </a:ext>
             </a:extLst>
           </p:cNvPr>
@@ -2614,7 +2614,7 @@
           <p:cNvPr id="10" name="">
             <a:extLst xmlns:a="http://schemas.openxmlformats.org/drawingml/2006/main">
               <a:ext uri="{FF2B5EF4-FFF2-40B4-BE49-F238E27FC236}">
-                <a16:creationId xmlns:a16="http://schemas.microsoft.com/office/drawing/2014/main" id="{E4E64EF0-9521-46C5-98B8-1EC2F68DD4CE}"/>
+                <a16:creationId xmlns:a16="http://schemas.microsoft.com/office/drawing/2014/main" id="{1BDBC2C8-8732-4D48-A0B9-CC1D60EFE76F}"/>
               </a:ext>
             </a:extLst>
           </p:cNvPr>
@@ -2664,7 +2664,7 @@
           <p:cNvPr id="11" name="">
             <a:extLst xmlns:a="http://schemas.openxmlformats.org/drawingml/2006/main">
               <a:ext uri="{FF2B5EF4-FFF2-40B4-BE49-F238E27FC236}">
-                <a16:creationId xmlns:a16="http://schemas.microsoft.com/office/drawing/2014/main" id="{19FD4348-C76D-486E-848D-1A7FBBA85565}"/>
+                <a16:creationId xmlns:a16="http://schemas.microsoft.com/office/drawing/2014/main" id="{13CB49CB-1D6C-4659-BCD9-2FD42ECD9C0B}"/>
               </a:ext>
             </a:extLst>
           </p:cNvPr>
@@ -2714,7 +2714,7 @@
           <p:cNvPr id="12" name="">
             <a:extLst xmlns:a="http://schemas.openxmlformats.org/drawingml/2006/main">
               <a:ext uri="{FF2B5EF4-FFF2-40B4-BE49-F238E27FC236}">
-                <a16:creationId xmlns:a16="http://schemas.microsoft.com/office/drawing/2014/main" id="{25EE8B36-9FA7-4A2E-BF0B-B7F4B94E7A22}"/>
+                <a16:creationId xmlns:a16="http://schemas.microsoft.com/office/drawing/2014/main" id="{AA5B6FA1-9987-483D-8076-4F60FB25D136}"/>
               </a:ext>
             </a:extLst>
           </p:cNvPr>
@@ -2764,7 +2764,7 @@
           <p:cNvPr id="13" name="">
             <a:extLst xmlns:a="http://schemas.openxmlformats.org/drawingml/2006/main">
               <a:ext uri="{FF2B5EF4-FFF2-40B4-BE49-F238E27FC236}">
-                <a16:creationId xmlns:a16="http://schemas.microsoft.com/office/drawing/2014/main" id="{9CA16142-4BB9-44C6-9EBE-B8F5E438F746}"/>
+                <a16:creationId xmlns:a16="http://schemas.microsoft.com/office/drawing/2014/main" id="{49C55863-51C6-433F-8C26-563947B2E101}"/>
               </a:ext>
             </a:extLst>
           </p:cNvPr>
@@ -2814,7 +2814,7 @@
           <p:cNvPr id="14" name="">
             <a:extLst xmlns:a="http://schemas.openxmlformats.org/drawingml/2006/main">
               <a:ext uri="{FF2B5EF4-FFF2-40B4-BE49-F238E27FC236}">
-                <a16:creationId xmlns:a16="http://schemas.microsoft.com/office/drawing/2014/main" id="{7FE24E25-8A48-4545-94BA-DA66CB88B2A7}"/>
+                <a16:creationId xmlns:a16="http://schemas.microsoft.com/office/drawing/2014/main" id="{5C5FDD30-3B44-46A6-A802-8DBFC27220E5}"/>
               </a:ext>
             </a:extLst>
           </p:cNvPr>
@@ -2862,7 +2862,7 @@
     </p:spTree>
     <p:extLst>
       <p:ext uri="{BB962C8B-B14F-4D97-AF65-F5344CB8AC3E}">
-        <p14:creationId xmlns:p14="http://schemas.microsoft.com/office/powerpoint/2010/main" val="2021658369"/>
+        <p14:creationId xmlns:p14="http://schemas.microsoft.com/office/powerpoint/2010/main" val="1628691504"/>
       </p:ext>
     </p:extLst>
   </p:cSld>
@@ -2893,7 +2893,7 @@
           <p:cNvPr id="1" name="">
             <a:extLst xmlns:a="http://schemas.openxmlformats.org/drawingml/2006/main">
               <a:ext uri="{FF2B5EF4-FFF2-40B4-BE49-F238E27FC236}">
-                <a16:creationId xmlns:a16="http://schemas.microsoft.com/office/drawing/2014/main" id="{D00CCEB7-0966-4732-86E2-95BC3E5C019B}"/>
+                <a16:creationId xmlns:a16="http://schemas.microsoft.com/office/drawing/2014/main" id="{E0F00F5F-4C88-478D-BE70-D1017151C905}"/>
               </a:ext>
             </a:extLst>
           </p:cNvPr>
@@ -2924,7 +2924,7 @@
           <p:cNvPr id="2" name="">
             <a:extLst xmlns:a="http://schemas.openxmlformats.org/drawingml/2006/main">
               <a:ext uri="{FF2B5EF4-FFF2-40B4-BE49-F238E27FC236}">
-                <a16:creationId xmlns:a16="http://schemas.microsoft.com/office/drawing/2014/main" id="{367F4217-1E8D-4570-B641-A19E85DD3B7D}"/>
+                <a16:creationId xmlns:a16="http://schemas.microsoft.com/office/drawing/2014/main" id="{FFE764E8-11BB-4B0F-96F7-7D0AE8FC5144}"/>
               </a:ext>
             </a:extLst>
           </p:cNvPr>
@@ -2974,7 +2974,7 @@
           <p:cNvPr id="3" name="">
             <a:extLst xmlns:a="http://schemas.openxmlformats.org/drawingml/2006/main">
               <a:ext uri="{FF2B5EF4-FFF2-40B4-BE49-F238E27FC236}">
-                <a16:creationId xmlns:a16="http://schemas.microsoft.com/office/drawing/2014/main" id="{D16D4560-6167-4FEE-A359-A86F530496D3}"/>
+                <a16:creationId xmlns:a16="http://schemas.microsoft.com/office/drawing/2014/main" id="{DB1D47AB-BCDB-4FD2-89B1-D6F6C2D1BBF2}"/>
               </a:ext>
             </a:extLst>
           </p:cNvPr>
@@ -3024,7 +3024,7 @@
           <p:cNvPr id="4" name="">
             <a:extLst xmlns:a="http://schemas.openxmlformats.org/drawingml/2006/main">
               <a:ext uri="{FF2B5EF4-FFF2-40B4-BE49-F238E27FC236}">
-                <a16:creationId xmlns:a16="http://schemas.microsoft.com/office/drawing/2014/main" id="{287A8971-0E57-42D5-942F-18329B9C986B}"/>
+                <a16:creationId xmlns:a16="http://schemas.microsoft.com/office/drawing/2014/main" id="{57633A94-60CA-4836-8A85-BD804B5ED1C3}"/>
               </a:ext>
             </a:extLst>
           </p:cNvPr>
@@ -3055,7 +3055,7 @@
           <p:cNvPr id="5" name="">
             <a:extLst xmlns:a="http://schemas.openxmlformats.org/drawingml/2006/main">
               <a:ext uri="{FF2B5EF4-FFF2-40B4-BE49-F238E27FC236}">
-                <a16:creationId xmlns:a16="http://schemas.microsoft.com/office/drawing/2014/main" id="{9991EF8F-F202-4D76-83D7-EF075D574751}"/>
+                <a16:creationId xmlns:a16="http://schemas.microsoft.com/office/drawing/2014/main" id="{4EC1611C-00F5-4FCA-9699-7E7C6C900F6A}"/>
               </a:ext>
             </a:extLst>
           </p:cNvPr>
@@ -3105,7 +3105,7 @@
           <p:cNvPr id="6" name="">
             <a:extLst xmlns:a="http://schemas.openxmlformats.org/drawingml/2006/main">
               <a:ext uri="{FF2B5EF4-FFF2-40B4-BE49-F238E27FC236}">
-                <a16:creationId xmlns:a16="http://schemas.microsoft.com/office/drawing/2014/main" id="{A414BE03-9F34-4867-B37C-0FBF8420A4CB}"/>
+                <a16:creationId xmlns:a16="http://schemas.microsoft.com/office/drawing/2014/main" id="{C6FACF24-4354-4658-9523-F326894383D7}"/>
               </a:ext>
             </a:extLst>
           </p:cNvPr>
@@ -3155,7 +3155,7 @@
           <p:cNvPr id="7" name="">
             <a:extLst xmlns:a="http://schemas.openxmlformats.org/drawingml/2006/main">
               <a:ext uri="{FF2B5EF4-FFF2-40B4-BE49-F238E27FC236}">
-                <a16:creationId xmlns:a16="http://schemas.microsoft.com/office/drawing/2014/main" id="{804F6DF3-4A1A-435E-A73C-38F59FA8262B}"/>
+                <a16:creationId xmlns:a16="http://schemas.microsoft.com/office/drawing/2014/main" id="{BF39C192-7ADA-4671-A410-FA0BC1026FD4}"/>
               </a:ext>
             </a:extLst>
           </p:cNvPr>
@@ -3205,7 +3205,7 @@
           <p:cNvPr id="8" name="">
             <a:extLst xmlns:a="http://schemas.openxmlformats.org/drawingml/2006/main">
               <a:ext uri="{FF2B5EF4-FFF2-40B4-BE49-F238E27FC236}">
-                <a16:creationId xmlns:a16="http://schemas.microsoft.com/office/drawing/2014/main" id="{96C49E47-3746-4F1F-BC15-5BE925B5E8C4}"/>
+                <a16:creationId xmlns:a16="http://schemas.microsoft.com/office/drawing/2014/main" id="{4A2EC8BF-6043-4714-9BDF-705FA53C2267}"/>
               </a:ext>
             </a:extLst>
           </p:cNvPr>
@@ -3255,7 +3255,7 @@
           <p:cNvPr id="9" name="">
             <a:extLst xmlns:a="http://schemas.openxmlformats.org/drawingml/2006/main">
               <a:ext uri="{FF2B5EF4-FFF2-40B4-BE49-F238E27FC236}">
-                <a16:creationId xmlns:a16="http://schemas.microsoft.com/office/drawing/2014/main" id="{42CF5F60-33CC-47CC-A098-6655D05971FC}"/>
+                <a16:creationId xmlns:a16="http://schemas.microsoft.com/office/drawing/2014/main" id="{5909B331-639A-46C7-BFBC-A659B10009AA}"/>
               </a:ext>
             </a:extLst>
           </p:cNvPr>
@@ -3305,7 +3305,7 @@
           <p:cNvPr id="10" name="">
             <a:extLst xmlns:a="http://schemas.openxmlformats.org/drawingml/2006/main">
               <a:ext uri="{FF2B5EF4-FFF2-40B4-BE49-F238E27FC236}">
-                <a16:creationId xmlns:a16="http://schemas.microsoft.com/office/drawing/2014/main" id="{CD62713A-1DEA-4642-BE9B-05251790E64A}"/>
+                <a16:creationId xmlns:a16="http://schemas.microsoft.com/office/drawing/2014/main" id="{8927A0A5-8BAC-4A15-A8B8-8E082E5A7C07}"/>
               </a:ext>
             </a:extLst>
           </p:cNvPr>
@@ -3355,7 +3355,7 @@
           <p:cNvPr id="11" name="">
             <a:extLst xmlns:a="http://schemas.openxmlformats.org/drawingml/2006/main">
               <a:ext uri="{FF2B5EF4-FFF2-40B4-BE49-F238E27FC236}">
-                <a16:creationId xmlns:a16="http://schemas.microsoft.com/office/drawing/2014/main" id="{82402986-1C9F-4001-BE7D-AF2A0B94C56A}"/>
+                <a16:creationId xmlns:a16="http://schemas.microsoft.com/office/drawing/2014/main" id="{E8C3DBE5-6127-474E-ADAF-9F1A65442D63}"/>
               </a:ext>
             </a:extLst>
           </p:cNvPr>
@@ -3405,7 +3405,7 @@
           <p:cNvPr id="12" name="">
             <a:extLst xmlns:a="http://schemas.openxmlformats.org/drawingml/2006/main">
               <a:ext uri="{FF2B5EF4-FFF2-40B4-BE49-F238E27FC236}">
-                <a16:creationId xmlns:a16="http://schemas.microsoft.com/office/drawing/2014/main" id="{6C96EA4C-B241-49B5-A440-1884605229B4}"/>
+                <a16:creationId xmlns:a16="http://schemas.microsoft.com/office/drawing/2014/main" id="{D7DDF3F8-BE38-4FD8-8034-57C805510E76}"/>
               </a:ext>
             </a:extLst>
           </p:cNvPr>
@@ -3455,7 +3455,7 @@
           <p:cNvPr id="13" name="">
             <a:extLst xmlns:a="http://schemas.openxmlformats.org/drawingml/2006/main">
               <a:ext uri="{FF2B5EF4-FFF2-40B4-BE49-F238E27FC236}">
-                <a16:creationId xmlns:a16="http://schemas.microsoft.com/office/drawing/2014/main" id="{410B91FC-E5A5-465B-96F3-E572E2E7FD85}"/>
+                <a16:creationId xmlns:a16="http://schemas.microsoft.com/office/drawing/2014/main" id="{5170722D-FCA7-4D8E-ACD3-B159E45AE2E0}"/>
               </a:ext>
             </a:extLst>
           </p:cNvPr>
@@ -3505,7 +3505,7 @@
           <p:cNvPr id="14" name="">
             <a:extLst xmlns:a="http://schemas.openxmlformats.org/drawingml/2006/main">
               <a:ext uri="{FF2B5EF4-FFF2-40B4-BE49-F238E27FC236}">
-                <a16:creationId xmlns:a16="http://schemas.microsoft.com/office/drawing/2014/main" id="{335938E6-B035-417E-91EC-4644139F122E}"/>
+                <a16:creationId xmlns:a16="http://schemas.microsoft.com/office/drawing/2014/main" id="{F2EF459C-4307-4BFF-8590-475AA7C3C0EB}"/>
               </a:ext>
             </a:extLst>
           </p:cNvPr>
@@ -3555,7 +3555,7 @@
           <p:cNvPr id="15" name="">
             <a:extLst xmlns:a="http://schemas.openxmlformats.org/drawingml/2006/main">
               <a:ext uri="{FF2B5EF4-FFF2-40B4-BE49-F238E27FC236}">
-                <a16:creationId xmlns:a16="http://schemas.microsoft.com/office/drawing/2014/main" id="{C313EED4-68FB-4BB0-B74C-4CCC5410E313}"/>
+                <a16:creationId xmlns:a16="http://schemas.microsoft.com/office/drawing/2014/main" id="{5500B83D-2ED5-41C0-91CE-50F115ECD0BC}"/>
               </a:ext>
             </a:extLst>
           </p:cNvPr>
@@ -3605,7 +3605,7 @@
           <p:cNvPr id="16" name="">
             <a:extLst xmlns:a="http://schemas.openxmlformats.org/drawingml/2006/main">
               <a:ext uri="{FF2B5EF4-FFF2-40B4-BE49-F238E27FC236}">
-                <a16:creationId xmlns:a16="http://schemas.microsoft.com/office/drawing/2014/main" id="{7B02C9D7-8EAD-43FF-9AB2-1F5F03680F18}"/>
+                <a16:creationId xmlns:a16="http://schemas.microsoft.com/office/drawing/2014/main" id="{4BBBD3E4-74DF-4FEC-996E-2735CF34BE32}"/>
               </a:ext>
             </a:extLst>
           </p:cNvPr>
@@ -3640,7 +3640,7 @@
           <p:cNvPr id="17" name="">
             <a:extLst xmlns:a="http://schemas.openxmlformats.org/drawingml/2006/main">
               <a:ext uri="{FF2B5EF4-FFF2-40B4-BE49-F238E27FC236}">
-                <a16:creationId xmlns:a16="http://schemas.microsoft.com/office/drawing/2014/main" id="{A2D7FA00-8E36-4E0A-A66A-70F4B47A8CE6}"/>
+                <a16:creationId xmlns:a16="http://schemas.microsoft.com/office/drawing/2014/main" id="{6C720600-C29B-4B92-885E-DBDD5553F5A6}"/>
               </a:ext>
             </a:extLst>
           </p:cNvPr>
@@ -3690,7 +3690,7 @@
           <p:cNvPr id="18" name="">
             <a:extLst xmlns:a="http://schemas.openxmlformats.org/drawingml/2006/main">
               <a:ext uri="{FF2B5EF4-FFF2-40B4-BE49-F238E27FC236}">
-                <a16:creationId xmlns:a16="http://schemas.microsoft.com/office/drawing/2014/main" id="{7F14168D-DCDB-4A81-B737-4E8C512D6D36}"/>
+                <a16:creationId xmlns:a16="http://schemas.microsoft.com/office/drawing/2014/main" id="{ACDB48C7-4128-4906-B0FB-6E481B08500D}"/>
               </a:ext>
             </a:extLst>
           </p:cNvPr>
@@ -3740,7 +3740,7 @@
           <p:cNvPr id="19" name="">
             <a:extLst xmlns:a="http://schemas.openxmlformats.org/drawingml/2006/main">
               <a:ext uri="{FF2B5EF4-FFF2-40B4-BE49-F238E27FC236}">
-                <a16:creationId xmlns:a16="http://schemas.microsoft.com/office/drawing/2014/main" id="{91E52147-086E-4B6C-9721-8EEAACDA7CA6}"/>
+                <a16:creationId xmlns:a16="http://schemas.microsoft.com/office/drawing/2014/main" id="{CF83E48B-7730-4EE1-B6A8-A84E23D5D641}"/>
               </a:ext>
             </a:extLst>
           </p:cNvPr>
@@ -3790,7 +3790,7 @@
           <p:cNvPr id="20" name="">
             <a:extLst xmlns:a="http://schemas.openxmlformats.org/drawingml/2006/main">
               <a:ext uri="{FF2B5EF4-FFF2-40B4-BE49-F238E27FC236}">
-                <a16:creationId xmlns:a16="http://schemas.microsoft.com/office/drawing/2014/main" id="{CDF3A346-30BC-455E-AEC8-3D02816EA9C9}"/>
+                <a16:creationId xmlns:a16="http://schemas.microsoft.com/office/drawing/2014/main" id="{C2830609-07A5-42E5-856E-EACA387A63D2}"/>
               </a:ext>
             </a:extLst>
           </p:cNvPr>
@@ -3840,7 +3840,7 @@
           <p:cNvPr id="21" name="">
             <a:extLst xmlns:a="http://schemas.openxmlformats.org/drawingml/2006/main">
               <a:ext uri="{FF2B5EF4-FFF2-40B4-BE49-F238E27FC236}">
-                <a16:creationId xmlns:a16="http://schemas.microsoft.com/office/drawing/2014/main" id="{B4E50639-4F0A-42F8-8605-76A6AC6BEDDB}"/>
+                <a16:creationId xmlns:a16="http://schemas.microsoft.com/office/drawing/2014/main" id="{176D1AF9-4D02-4DE4-8FEF-E0ABE13A560E}"/>
               </a:ext>
             </a:extLst>
           </p:cNvPr>
@@ -3888,7 +3888,7 @@
     </p:spTree>
     <p:extLst>
       <p:ext uri="{BB962C8B-B14F-4D97-AF65-F5344CB8AC3E}">
-        <p14:creationId xmlns:p14="http://schemas.microsoft.com/office/powerpoint/2010/main" val="1406837493"/>
+        <p14:creationId xmlns:p14="http://schemas.microsoft.com/office/powerpoint/2010/main" val="1644796935"/>
       </p:ext>
     </p:extLst>
   </p:cSld>
@@ -3919,7 +3919,7 @@
           <p:cNvPr id="1" name="">
             <a:extLst xmlns:a="http://schemas.openxmlformats.org/drawingml/2006/main">
               <a:ext uri="{FF2B5EF4-FFF2-40B4-BE49-F238E27FC236}">
-                <a16:creationId xmlns:a16="http://schemas.microsoft.com/office/drawing/2014/main" id="{2816477F-8F01-4BC0-A65F-36901F1BE33B}"/>
+                <a16:creationId xmlns:a16="http://schemas.microsoft.com/office/drawing/2014/main" id="{ED174183-5CA7-4EAB-BA99-02FAB5F8FF5E}"/>
               </a:ext>
             </a:extLst>
           </p:cNvPr>
@@ -3950,7 +3950,7 @@
           <p:cNvPr id="2" name="">
             <a:extLst xmlns:a="http://schemas.openxmlformats.org/drawingml/2006/main">
               <a:ext uri="{FF2B5EF4-FFF2-40B4-BE49-F238E27FC236}">
-                <a16:creationId xmlns:a16="http://schemas.microsoft.com/office/drawing/2014/main" id="{322EFF28-ACA1-4AC8-8723-9E1F90EFCEC8}"/>
+                <a16:creationId xmlns:a16="http://schemas.microsoft.com/office/drawing/2014/main" id="{DB97CA54-434C-4EC9-91FC-F6A28EEED2A1}"/>
               </a:ext>
             </a:extLst>
           </p:cNvPr>
@@ -4000,7 +4000,7 @@
           <p:cNvPr id="3" name="">
             <a:extLst xmlns:a="http://schemas.openxmlformats.org/drawingml/2006/main">
               <a:ext uri="{FF2B5EF4-FFF2-40B4-BE49-F238E27FC236}">
-                <a16:creationId xmlns:a16="http://schemas.microsoft.com/office/drawing/2014/main" id="{B86DFFAC-43E0-46B5-A2CA-73F92419B9DF}"/>
+                <a16:creationId xmlns:a16="http://schemas.microsoft.com/office/drawing/2014/main" id="{F14D7CA0-2073-4DA9-9D30-A78D5A93E0B7}"/>
               </a:ext>
             </a:extLst>
           </p:cNvPr>
@@ -4050,7 +4050,7 @@
           <p:cNvPr id="4" name="">
             <a:extLst xmlns:a="http://schemas.openxmlformats.org/drawingml/2006/main">
               <a:ext uri="{FF2B5EF4-FFF2-40B4-BE49-F238E27FC236}">
-                <a16:creationId xmlns:a16="http://schemas.microsoft.com/office/drawing/2014/main" id="{A5816C0D-93DD-4549-9BEE-D3492E4A29AE}"/>
+                <a16:creationId xmlns:a16="http://schemas.microsoft.com/office/drawing/2014/main" id="{FFB7C73E-3374-4E11-A7C5-FE555904E666}"/>
               </a:ext>
             </a:extLst>
           </p:cNvPr>
@@ -4081,7 +4081,7 @@
           <p:cNvPr id="5" name="">
             <a:extLst xmlns:a="http://schemas.openxmlformats.org/drawingml/2006/main">
               <a:ext uri="{FF2B5EF4-FFF2-40B4-BE49-F238E27FC236}">
-                <a16:creationId xmlns:a16="http://schemas.microsoft.com/office/drawing/2014/main" id="{BC82C1E6-F61E-4492-A2CF-4278EA872288}"/>
+                <a16:creationId xmlns:a16="http://schemas.microsoft.com/office/drawing/2014/main" id="{8FC49C97-D1E6-42A7-BD59-5518ECA09A2C}"/>
               </a:ext>
             </a:extLst>
           </p:cNvPr>
@@ -4131,7 +4131,7 @@
           <p:cNvPr id="6" name="">
             <a:extLst xmlns:a="http://schemas.openxmlformats.org/drawingml/2006/main">
               <a:ext uri="{FF2B5EF4-FFF2-40B4-BE49-F238E27FC236}">
-                <a16:creationId xmlns:a16="http://schemas.microsoft.com/office/drawing/2014/main" id="{C6723594-80FB-4A54-9CDC-83BFBB1FC9D7}"/>
+                <a16:creationId xmlns:a16="http://schemas.microsoft.com/office/drawing/2014/main" id="{8E12684C-06A9-4C2F-A16E-0791AF0231BE}"/>
               </a:ext>
             </a:extLst>
           </p:cNvPr>
@@ -4185,7 +4185,7 @@
           <p:nvPr/>
         </p:nvPicPr>
         <p:blipFill>
-          <a:blip xmlns:r="http://schemas.openxmlformats.org/officeDocument/2006/relationships" xmlns:a="http://schemas.openxmlformats.org/drawingml/2006/main" r:embed="R351393c3b74c48dd"/>
+          <a:blip xmlns:r="http://schemas.openxmlformats.org/officeDocument/2006/relationships" xmlns:a="http://schemas.openxmlformats.org/drawingml/2006/main" r:embed="Rba6f5ec1b6a24ff5"/>
           <a:stretch xmlns:a="http://schemas.openxmlformats.org/drawingml/2006/main"/>
         </p:blipFill>
         <p:spPr>
@@ -4205,7 +4205,7 @@
           <p:cNvPr id="8" name="">
             <a:extLst xmlns:a="http://schemas.openxmlformats.org/drawingml/2006/main">
               <a:ext uri="{FF2B5EF4-FFF2-40B4-BE49-F238E27FC236}">
-                <a16:creationId xmlns:a16="http://schemas.microsoft.com/office/drawing/2014/main" id="{013052F4-C332-48CC-A866-D5BA9A18B594}"/>
+                <a16:creationId xmlns:a16="http://schemas.microsoft.com/office/drawing/2014/main" id="{82F13737-08B1-4FDA-9C8A-0F3FAEB9744D}"/>
               </a:ext>
             </a:extLst>
           </p:cNvPr>
@@ -4255,7 +4255,7 @@
           <p:cNvPr id="9" name="">
             <a:extLst xmlns:a="http://schemas.openxmlformats.org/drawingml/2006/main">
               <a:ext uri="{FF2B5EF4-FFF2-40B4-BE49-F238E27FC236}">
-                <a16:creationId xmlns:a16="http://schemas.microsoft.com/office/drawing/2014/main" id="{9FC80B5B-D21E-4F29-8B87-2458EE9FEABE}"/>
+                <a16:creationId xmlns:a16="http://schemas.microsoft.com/office/drawing/2014/main" id="{5A6D1BEB-B1BD-40E3-AAB3-DB1E2913C250}"/>
               </a:ext>
             </a:extLst>
           </p:cNvPr>
@@ -4305,7 +4305,7 @@
           <p:cNvPr id="10" name="">
             <a:extLst xmlns:a="http://schemas.openxmlformats.org/drawingml/2006/main">
               <a:ext uri="{FF2B5EF4-FFF2-40B4-BE49-F238E27FC236}">
-                <a16:creationId xmlns:a16="http://schemas.microsoft.com/office/drawing/2014/main" id="{FF2C4C90-83B1-4890-8AF1-2722BCDC9F4B}"/>
+                <a16:creationId xmlns:a16="http://schemas.microsoft.com/office/drawing/2014/main" id="{91953583-5AA2-45BB-9E87-86298E9F4302}"/>
               </a:ext>
             </a:extLst>
           </p:cNvPr>
@@ -4340,7 +4340,7 @@
           <p:cNvPr id="11" name="">
             <a:extLst xmlns:a="http://schemas.openxmlformats.org/drawingml/2006/main">
               <a:ext uri="{FF2B5EF4-FFF2-40B4-BE49-F238E27FC236}">
-                <a16:creationId xmlns:a16="http://schemas.microsoft.com/office/drawing/2014/main" id="{C6F4E737-B674-41E7-AE55-11E82FFE912E}"/>
+                <a16:creationId xmlns:a16="http://schemas.microsoft.com/office/drawing/2014/main" id="{45584E6D-66D2-48A1-AA04-DFC8659D1F99}"/>
               </a:ext>
             </a:extLst>
           </p:cNvPr>
@@ -4390,7 +4390,7 @@
           <p:cNvPr id="12" name="">
             <a:extLst xmlns:a="http://schemas.openxmlformats.org/drawingml/2006/main">
               <a:ext uri="{FF2B5EF4-FFF2-40B4-BE49-F238E27FC236}">
-                <a16:creationId xmlns:a16="http://schemas.microsoft.com/office/drawing/2014/main" id="{94F06AC2-59CA-4A99-8110-06A1ABDFED91}"/>
+                <a16:creationId xmlns:a16="http://schemas.microsoft.com/office/drawing/2014/main" id="{7B65F277-C8CD-45AB-BBB1-AA79B7200B11}"/>
               </a:ext>
             </a:extLst>
           </p:cNvPr>
@@ -4474,7 +4474,7 @@
           <p:cNvPr id="13" name="">
             <a:extLst xmlns:a="http://schemas.openxmlformats.org/drawingml/2006/main">
               <a:ext uri="{FF2B5EF4-FFF2-40B4-BE49-F238E27FC236}">
-                <a16:creationId xmlns:a16="http://schemas.microsoft.com/office/drawing/2014/main" id="{9EDEECFC-6163-4B27-AFE1-430B0B41A70B}"/>
+                <a16:creationId xmlns:a16="http://schemas.microsoft.com/office/drawing/2014/main" id="{AE2AA0D0-334A-4302-A174-00411AB544C3}"/>
               </a:ext>
             </a:extLst>
           </p:cNvPr>
@@ -4528,7 +4528,7 @@
           <p:nvPr/>
         </p:nvPicPr>
         <p:blipFill>
-          <a:blip xmlns:r="http://schemas.openxmlformats.org/officeDocument/2006/relationships" xmlns:a="http://schemas.openxmlformats.org/drawingml/2006/main" r:embed="Rfb3855a572274eb2"/>
+          <a:blip xmlns:r="http://schemas.openxmlformats.org/officeDocument/2006/relationships" xmlns:a="http://schemas.openxmlformats.org/drawingml/2006/main" r:embed="Rd726dae2efd047bd"/>
           <a:stretch xmlns:a="http://schemas.openxmlformats.org/drawingml/2006/main"/>
         </p:blipFill>
         <p:spPr>
@@ -4548,7 +4548,7 @@
           <p:cNvPr id="15" name="">
             <a:extLst xmlns:a="http://schemas.openxmlformats.org/drawingml/2006/main">
               <a:ext uri="{FF2B5EF4-FFF2-40B4-BE49-F238E27FC236}">
-                <a16:creationId xmlns:a16="http://schemas.microsoft.com/office/drawing/2014/main" id="{E2130F6A-853D-4F2D-88F7-A1AC233482F0}"/>
+                <a16:creationId xmlns:a16="http://schemas.microsoft.com/office/drawing/2014/main" id="{BF804A2D-DEC6-4685-9F5F-7E3964F8645B}"/>
               </a:ext>
             </a:extLst>
           </p:cNvPr>
@@ -4596,7 +4596,7 @@
     </p:spTree>
     <p:extLst>
       <p:ext uri="{BB962C8B-B14F-4D97-AF65-F5344CB8AC3E}">
-        <p14:creationId xmlns:p14="http://schemas.microsoft.com/office/powerpoint/2010/main" val="1837907310"/>
+        <p14:creationId xmlns:p14="http://schemas.microsoft.com/office/powerpoint/2010/main" val="1209123141"/>
       </p:ext>
     </p:extLst>
   </p:cSld>
@@ -4627,7 +4627,7 @@
           <p:cNvPr id="1" name="">
             <a:extLst xmlns:a="http://schemas.openxmlformats.org/drawingml/2006/main">
               <a:ext uri="{FF2B5EF4-FFF2-40B4-BE49-F238E27FC236}">
-                <a16:creationId xmlns:a16="http://schemas.microsoft.com/office/drawing/2014/main" id="{170F2924-6CF8-4F61-9467-559FD73CCEDD}"/>
+                <a16:creationId xmlns:a16="http://schemas.microsoft.com/office/drawing/2014/main" id="{14527913-D583-4766-B8FD-A13D86A5E086}"/>
               </a:ext>
             </a:extLst>
           </p:cNvPr>
@@ -4658,7 +4658,7 @@
           <p:cNvPr id="2" name="">
             <a:extLst xmlns:a="http://schemas.openxmlformats.org/drawingml/2006/main">
               <a:ext uri="{FF2B5EF4-FFF2-40B4-BE49-F238E27FC236}">
-                <a16:creationId xmlns:a16="http://schemas.microsoft.com/office/drawing/2014/main" id="{9F05573C-8EA6-43BE-9F27-1B93C50B23AF}"/>
+                <a16:creationId xmlns:a16="http://schemas.microsoft.com/office/drawing/2014/main" id="{418A2DE2-8F91-43FD-A6AA-18479156337A}"/>
               </a:ext>
             </a:extLst>
           </p:cNvPr>
@@ -4708,7 +4708,7 @@
           <p:cNvPr id="3" name="">
             <a:extLst xmlns:a="http://schemas.openxmlformats.org/drawingml/2006/main">
               <a:ext uri="{FF2B5EF4-FFF2-40B4-BE49-F238E27FC236}">
-                <a16:creationId xmlns:a16="http://schemas.microsoft.com/office/drawing/2014/main" id="{6625205E-5CC8-4C4C-B071-2F38B4732349}"/>
+                <a16:creationId xmlns:a16="http://schemas.microsoft.com/office/drawing/2014/main" id="{72EE78FB-356E-4398-8959-8A20B0AE1360}"/>
               </a:ext>
             </a:extLst>
           </p:cNvPr>
@@ -4758,7 +4758,7 @@
           <p:cNvPr id="4" name="">
             <a:extLst xmlns:a="http://schemas.openxmlformats.org/drawingml/2006/main">
               <a:ext uri="{FF2B5EF4-FFF2-40B4-BE49-F238E27FC236}">
-                <a16:creationId xmlns:a16="http://schemas.microsoft.com/office/drawing/2014/main" id="{C65F77D1-97AC-44F9-A54D-890FE522BADD}"/>
+                <a16:creationId xmlns:a16="http://schemas.microsoft.com/office/drawing/2014/main" id="{F5D0058D-8571-42F6-9BF0-703C76D93948}"/>
               </a:ext>
             </a:extLst>
           </p:cNvPr>
@@ -4789,7 +4789,7 @@
           <p:cNvPr id="5" name="">
             <a:extLst xmlns:a="http://schemas.openxmlformats.org/drawingml/2006/main">
               <a:ext uri="{FF2B5EF4-FFF2-40B4-BE49-F238E27FC236}">
-                <a16:creationId xmlns:a16="http://schemas.microsoft.com/office/drawing/2014/main" id="{F4291083-5302-4D37-BA11-A62F942482C1}"/>
+                <a16:creationId xmlns:a16="http://schemas.microsoft.com/office/drawing/2014/main" id="{C1A26E23-4773-4DE3-950E-986D50C5222D}"/>
               </a:ext>
             </a:extLst>
           </p:cNvPr>
@@ -4839,7 +4839,7 @@
           <p:cNvPr id="6" name="">
             <a:extLst xmlns:a="http://schemas.openxmlformats.org/drawingml/2006/main">
               <a:ext uri="{FF2B5EF4-FFF2-40B4-BE49-F238E27FC236}">
-                <a16:creationId xmlns:a16="http://schemas.microsoft.com/office/drawing/2014/main" id="{4187B4D2-D1B1-4B5F-8A37-B6C856CE5C2D}"/>
+                <a16:creationId xmlns:a16="http://schemas.microsoft.com/office/drawing/2014/main" id="{F4FBE3C5-F2D5-4825-A3B5-95FA6DC60E1C}"/>
               </a:ext>
             </a:extLst>
           </p:cNvPr>
@@ -4889,7 +4889,7 @@
           <p:cNvPr id="7" name="">
             <a:extLst xmlns:a="http://schemas.openxmlformats.org/drawingml/2006/main">
               <a:ext uri="{FF2B5EF4-FFF2-40B4-BE49-F238E27FC236}">
-                <a16:creationId xmlns:a16="http://schemas.microsoft.com/office/drawing/2014/main" id="{07111E5B-F6AF-4349-B79B-A1BA4F991330}"/>
+                <a16:creationId xmlns:a16="http://schemas.microsoft.com/office/drawing/2014/main" id="{AF0F3A31-2F84-4212-8741-755F697C7892}"/>
               </a:ext>
             </a:extLst>
           </p:cNvPr>
@@ -4943,7 +4943,7 @@
           <p:nvPr/>
         </p:nvPicPr>
         <p:blipFill>
-          <a:blip xmlns:r="http://schemas.openxmlformats.org/officeDocument/2006/relationships" xmlns:a="http://schemas.openxmlformats.org/drawingml/2006/main" r:embed="Re19f02857b1d4ff2"/>
+          <a:blip xmlns:r="http://schemas.openxmlformats.org/officeDocument/2006/relationships" xmlns:a="http://schemas.openxmlformats.org/drawingml/2006/main" r:embed="R00fcc73925a74ce9"/>
           <a:stretch xmlns:a="http://schemas.openxmlformats.org/drawingml/2006/main"/>
         </p:blipFill>
         <p:spPr>
@@ -4961,7 +4961,7 @@
     </p:spTree>
     <p:extLst>
       <p:ext uri="{BB962C8B-B14F-4D97-AF65-F5344CB8AC3E}">
-        <p14:creationId xmlns:p14="http://schemas.microsoft.com/office/powerpoint/2010/main" val="888009237"/>
+        <p14:creationId xmlns:p14="http://schemas.microsoft.com/office/powerpoint/2010/main" val="795337994"/>
       </p:ext>
     </p:extLst>
   </p:cSld>
@@ -4992,7 +4992,7 @@
           <p:cNvPr id="1" name="">
             <a:extLst xmlns:a="http://schemas.openxmlformats.org/drawingml/2006/main">
               <a:ext uri="{FF2B5EF4-FFF2-40B4-BE49-F238E27FC236}">
-                <a16:creationId xmlns:a16="http://schemas.microsoft.com/office/drawing/2014/main" id="{815188EE-725A-4A85-A1E1-9C65A42695A5}"/>
+                <a16:creationId xmlns:a16="http://schemas.microsoft.com/office/drawing/2014/main" id="{BE91F038-991B-4838-BB59-6ABE862C8B46}"/>
               </a:ext>
             </a:extLst>
           </p:cNvPr>
@@ -5023,7 +5023,7 @@
           <p:cNvPr id="2" name="">
             <a:extLst xmlns:a="http://schemas.openxmlformats.org/drawingml/2006/main">
               <a:ext uri="{FF2B5EF4-FFF2-40B4-BE49-F238E27FC236}">
-                <a16:creationId xmlns:a16="http://schemas.microsoft.com/office/drawing/2014/main" id="{AC14B9E6-E279-4C0E-9E2E-0D1A95B427B0}"/>
+                <a16:creationId xmlns:a16="http://schemas.microsoft.com/office/drawing/2014/main" id="{58778D49-870D-4CC0-8C3A-80C663065174}"/>
               </a:ext>
             </a:extLst>
           </p:cNvPr>
@@ -5073,7 +5073,7 @@
           <p:cNvPr id="3" name="">
             <a:extLst xmlns:a="http://schemas.openxmlformats.org/drawingml/2006/main">
               <a:ext uri="{FF2B5EF4-FFF2-40B4-BE49-F238E27FC236}">
-                <a16:creationId xmlns:a16="http://schemas.microsoft.com/office/drawing/2014/main" id="{C88C8644-6504-4D1F-A3F1-BF6EA26D22C8}"/>
+                <a16:creationId xmlns:a16="http://schemas.microsoft.com/office/drawing/2014/main" id="{12CF5B33-E2A7-4801-BA90-2AB9F8F66257}"/>
               </a:ext>
             </a:extLst>
           </p:cNvPr>
@@ -5123,7 +5123,7 @@
           <p:cNvPr id="4" name="">
             <a:extLst xmlns:a="http://schemas.openxmlformats.org/drawingml/2006/main">
               <a:ext uri="{FF2B5EF4-FFF2-40B4-BE49-F238E27FC236}">
-                <a16:creationId xmlns:a16="http://schemas.microsoft.com/office/drawing/2014/main" id="{F3D4359D-00F9-4903-AF20-094340000BCA}"/>
+                <a16:creationId xmlns:a16="http://schemas.microsoft.com/office/drawing/2014/main" id="{E224E5F1-6ED6-40B3-81D7-73694FF0862C}"/>
               </a:ext>
             </a:extLst>
           </p:cNvPr>
@@ -5154,7 +5154,7 @@
           <p:cNvPr id="5" name="">
             <a:extLst xmlns:a="http://schemas.openxmlformats.org/drawingml/2006/main">
               <a:ext uri="{FF2B5EF4-FFF2-40B4-BE49-F238E27FC236}">
-                <a16:creationId xmlns:a16="http://schemas.microsoft.com/office/drawing/2014/main" id="{D1904092-8941-4A21-A256-86B30D2A6E7C}"/>
+                <a16:creationId xmlns:a16="http://schemas.microsoft.com/office/drawing/2014/main" id="{27B635B7-4159-4842-B67F-070D605FE12D}"/>
               </a:ext>
             </a:extLst>
           </p:cNvPr>
@@ -5204,7 +5204,7 @@
           <p:cNvPr id="6" name="">
             <a:extLst xmlns:a="http://schemas.openxmlformats.org/drawingml/2006/main">
               <a:ext uri="{FF2B5EF4-FFF2-40B4-BE49-F238E27FC236}">
-                <a16:creationId xmlns:a16="http://schemas.microsoft.com/office/drawing/2014/main" id="{89FD0D82-9272-4C08-B276-4617DFDBCD99}"/>
+                <a16:creationId xmlns:a16="http://schemas.microsoft.com/office/drawing/2014/main" id="{73BA1791-F694-45FB-A545-7A6167183D67}"/>
               </a:ext>
             </a:extLst>
           </p:cNvPr>
@@ -5254,7 +5254,7 @@
           <p:cNvPr id="7" name="">
             <a:extLst xmlns:a="http://schemas.openxmlformats.org/drawingml/2006/main">
               <a:ext uri="{FF2B5EF4-FFF2-40B4-BE49-F238E27FC236}">
-                <a16:creationId xmlns:a16="http://schemas.microsoft.com/office/drawing/2014/main" id="{7BB3D9AD-9881-446B-8689-B9E0BFD63C86}"/>
+                <a16:creationId xmlns:a16="http://schemas.microsoft.com/office/drawing/2014/main" id="{9E4BE909-5911-4C6D-8B8A-9B754AAED74B}"/>
               </a:ext>
             </a:extLst>
           </p:cNvPr>
@@ -5304,7 +5304,7 @@
           <p:cNvPr id="8" name="">
             <a:extLst xmlns:a="http://schemas.openxmlformats.org/drawingml/2006/main">
               <a:ext uri="{FF2B5EF4-FFF2-40B4-BE49-F238E27FC236}">
-                <a16:creationId xmlns:a16="http://schemas.microsoft.com/office/drawing/2014/main" id="{C352864C-F872-4E41-AAC6-03504F055AF4}"/>
+                <a16:creationId xmlns:a16="http://schemas.microsoft.com/office/drawing/2014/main" id="{13396E68-0654-4BEC-A879-4E87969AD296}"/>
               </a:ext>
             </a:extLst>
           </p:cNvPr>
@@ -5354,7 +5354,7 @@
           <p:cNvPr id="9" name="">
             <a:extLst xmlns:a="http://schemas.openxmlformats.org/drawingml/2006/main">
               <a:ext uri="{FF2B5EF4-FFF2-40B4-BE49-F238E27FC236}">
-                <a16:creationId xmlns:a16="http://schemas.microsoft.com/office/drawing/2014/main" id="{B4701F09-7323-4595-84C9-83CBA9E3AD2B}"/>
+                <a16:creationId xmlns:a16="http://schemas.microsoft.com/office/drawing/2014/main" id="{6B5411CB-6924-4777-A1FA-FCB0BA33EBE8}"/>
               </a:ext>
             </a:extLst>
           </p:cNvPr>
@@ -5404,7 +5404,7 @@
           <p:cNvPr id="10" name="">
             <a:extLst xmlns:a="http://schemas.openxmlformats.org/drawingml/2006/main">
               <a:ext uri="{FF2B5EF4-FFF2-40B4-BE49-F238E27FC236}">
-                <a16:creationId xmlns:a16="http://schemas.microsoft.com/office/drawing/2014/main" id="{53698262-1093-48BD-8E5E-C06C55A1E557}"/>
+                <a16:creationId xmlns:a16="http://schemas.microsoft.com/office/drawing/2014/main" id="{14F66FDE-E50B-4074-A6E6-94A55F6ECFD4}"/>
               </a:ext>
             </a:extLst>
           </p:cNvPr>
@@ -5454,7 +5454,7 @@
           <p:cNvPr id="11" name="">
             <a:extLst xmlns:a="http://schemas.openxmlformats.org/drawingml/2006/main">
               <a:ext uri="{FF2B5EF4-FFF2-40B4-BE49-F238E27FC236}">
-                <a16:creationId xmlns:a16="http://schemas.microsoft.com/office/drawing/2014/main" id="{C8DB630B-D774-4E46-850F-A39FF47B4848}"/>
+                <a16:creationId xmlns:a16="http://schemas.microsoft.com/office/drawing/2014/main" id="{2FBED3C6-5552-426E-8F2A-26983349F27D}"/>
               </a:ext>
             </a:extLst>
           </p:cNvPr>
@@ -5504,7 +5504,7 @@
           <p:cNvPr id="12" name="">
             <a:extLst xmlns:a="http://schemas.openxmlformats.org/drawingml/2006/main">
               <a:ext uri="{FF2B5EF4-FFF2-40B4-BE49-F238E27FC236}">
-                <a16:creationId xmlns:a16="http://schemas.microsoft.com/office/drawing/2014/main" id="{920C624A-BACD-4328-AC16-A131EC362C5B}"/>
+                <a16:creationId xmlns:a16="http://schemas.microsoft.com/office/drawing/2014/main" id="{D8ED3933-32F8-41FD-A2D6-38ADE929A0A5}"/>
               </a:ext>
             </a:extLst>
           </p:cNvPr>
@@ -5554,7 +5554,7 @@
           <p:cNvPr id="13" name="">
             <a:extLst xmlns:a="http://schemas.openxmlformats.org/drawingml/2006/main">
               <a:ext uri="{FF2B5EF4-FFF2-40B4-BE49-F238E27FC236}">
-                <a16:creationId xmlns:a16="http://schemas.microsoft.com/office/drawing/2014/main" id="{5C29353E-36D1-4883-BC6F-0BC30F1581D8}"/>
+                <a16:creationId xmlns:a16="http://schemas.microsoft.com/office/drawing/2014/main" id="{E1DAEEE8-FF95-4139-A174-EC962A4C5F32}"/>
               </a:ext>
             </a:extLst>
           </p:cNvPr>
@@ -5604,7 +5604,7 @@
           <p:cNvPr id="14" name="">
             <a:extLst xmlns:a="http://schemas.openxmlformats.org/drawingml/2006/main">
               <a:ext uri="{FF2B5EF4-FFF2-40B4-BE49-F238E27FC236}">
-                <a16:creationId xmlns:a16="http://schemas.microsoft.com/office/drawing/2014/main" id="{69B286C0-9C99-4B9B-AC74-A5B641208773}"/>
+                <a16:creationId xmlns:a16="http://schemas.microsoft.com/office/drawing/2014/main" id="{44ABBD13-020F-4A1E-AFD3-0D04BBB21143}"/>
               </a:ext>
             </a:extLst>
           </p:cNvPr>
@@ -5654,7 +5654,7 @@
           <p:cNvPr id="15" name="">
             <a:extLst xmlns:a="http://schemas.openxmlformats.org/drawingml/2006/main">
               <a:ext uri="{FF2B5EF4-FFF2-40B4-BE49-F238E27FC236}">
-                <a16:creationId xmlns:a16="http://schemas.microsoft.com/office/drawing/2014/main" id="{0CCD2249-24D6-4E26-87F6-556D8FA29158}"/>
+                <a16:creationId xmlns:a16="http://schemas.microsoft.com/office/drawing/2014/main" id="{3CE70639-6E89-4EFB-B1F7-0455A6215DC7}"/>
               </a:ext>
             </a:extLst>
           </p:cNvPr>
@@ -5693,7 +5693,7 @@
           <p:nvPr/>
         </p:nvPicPr>
         <p:blipFill>
-          <a:blip xmlns:r="http://schemas.openxmlformats.org/officeDocument/2006/relationships" xmlns:a="http://schemas.openxmlformats.org/drawingml/2006/main" r:embed="Ra291db3d90914cb0"/>
+          <a:blip xmlns:r="http://schemas.openxmlformats.org/officeDocument/2006/relationships" xmlns:a="http://schemas.openxmlformats.org/drawingml/2006/main" r:embed="Rbe7dd9bce8c44ee4"/>
           <a:stretch xmlns:a="http://schemas.openxmlformats.org/drawingml/2006/main"/>
         </p:blipFill>
         <p:spPr>
@@ -5711,7 +5711,7 @@
     </p:spTree>
     <p:extLst>
       <p:ext uri="{BB962C8B-B14F-4D97-AF65-F5344CB8AC3E}">
-        <p14:creationId xmlns:p14="http://schemas.microsoft.com/office/powerpoint/2010/main" val="1166347321"/>
+        <p14:creationId xmlns:p14="http://schemas.microsoft.com/office/powerpoint/2010/main" val="1374685804"/>
       </p:ext>
     </p:extLst>
   </p:cSld>
@@ -5742,7 +5742,7 @@
           <p:cNvPr id="1" name="">
             <a:extLst xmlns:a="http://schemas.openxmlformats.org/drawingml/2006/main">
               <a:ext uri="{FF2B5EF4-FFF2-40B4-BE49-F238E27FC236}">
-                <a16:creationId xmlns:a16="http://schemas.microsoft.com/office/drawing/2014/main" id="{30F9F8CE-E24A-4C33-A5AB-D04BC8C777AF}"/>
+                <a16:creationId xmlns:a16="http://schemas.microsoft.com/office/drawing/2014/main" id="{3A88DAC8-C90E-40F7-A3DE-DD92FC83448E}"/>
               </a:ext>
             </a:extLst>
           </p:cNvPr>
@@ -5773,7 +5773,7 @@
           <p:cNvPr id="2" name="">
             <a:extLst xmlns:a="http://schemas.openxmlformats.org/drawingml/2006/main">
               <a:ext uri="{FF2B5EF4-FFF2-40B4-BE49-F238E27FC236}">
-                <a16:creationId xmlns:a16="http://schemas.microsoft.com/office/drawing/2014/main" id="{AFC70ABD-8106-4465-B46C-7594DFD01E30}"/>
+                <a16:creationId xmlns:a16="http://schemas.microsoft.com/office/drawing/2014/main" id="{E2B49FE4-9C95-4B9E-B6D4-4427DE5CF72C}"/>
               </a:ext>
             </a:extLst>
           </p:cNvPr>
@@ -5823,7 +5823,7 @@
           <p:cNvPr id="3" name="">
             <a:extLst xmlns:a="http://schemas.openxmlformats.org/drawingml/2006/main">
               <a:ext uri="{FF2B5EF4-FFF2-40B4-BE49-F238E27FC236}">
-                <a16:creationId xmlns:a16="http://schemas.microsoft.com/office/drawing/2014/main" id="{A2951B9F-D421-4216-B149-5741FCB2C8EB}"/>
+                <a16:creationId xmlns:a16="http://schemas.microsoft.com/office/drawing/2014/main" id="{E242E19C-CEDB-4C04-8168-40E4895A869C}"/>
               </a:ext>
             </a:extLst>
           </p:cNvPr>
@@ -5873,7 +5873,7 @@
           <p:cNvPr id="4" name="">
             <a:extLst xmlns:a="http://schemas.openxmlformats.org/drawingml/2006/main">
               <a:ext uri="{FF2B5EF4-FFF2-40B4-BE49-F238E27FC236}">
-                <a16:creationId xmlns:a16="http://schemas.microsoft.com/office/drawing/2014/main" id="{6C6278C6-16A1-42D1-B5EE-5E4D3E129481}"/>
+                <a16:creationId xmlns:a16="http://schemas.microsoft.com/office/drawing/2014/main" id="{C6E731D1-616F-45D5-8A8D-8E95F765B606}"/>
               </a:ext>
             </a:extLst>
           </p:cNvPr>
@@ -5904,7 +5904,7 @@
           <p:cNvPr id="5" name="">
             <a:extLst xmlns:a="http://schemas.openxmlformats.org/drawingml/2006/main">
               <a:ext uri="{FF2B5EF4-FFF2-40B4-BE49-F238E27FC236}">
-                <a16:creationId xmlns:a16="http://schemas.microsoft.com/office/drawing/2014/main" id="{E05014C0-D560-44F2-A200-E355EA7E5C1E}"/>
+                <a16:creationId xmlns:a16="http://schemas.microsoft.com/office/drawing/2014/main" id="{C99BBF8A-D96A-4B3C-8B86-F0ACB1A6B40E}"/>
               </a:ext>
             </a:extLst>
           </p:cNvPr>
@@ -5954,7 +5954,7 @@
           <p:cNvPr id="6" name="">
             <a:extLst xmlns:a="http://schemas.openxmlformats.org/drawingml/2006/main">
               <a:ext uri="{FF2B5EF4-FFF2-40B4-BE49-F238E27FC236}">
-                <a16:creationId xmlns:a16="http://schemas.microsoft.com/office/drawing/2014/main" id="{0B03F9CD-4106-4BB0-900E-F68E77B5302D}"/>
+                <a16:creationId xmlns:a16="http://schemas.microsoft.com/office/drawing/2014/main" id="{E30637CC-1E52-419A-94C1-8AD7814A9F11}"/>
               </a:ext>
             </a:extLst>
           </p:cNvPr>
@@ -6004,7 +6004,7 @@
           <p:cNvPr id="7" name="">
             <a:extLst xmlns:a="http://schemas.openxmlformats.org/drawingml/2006/main">
               <a:ext uri="{FF2B5EF4-FFF2-40B4-BE49-F238E27FC236}">
-                <a16:creationId xmlns:a16="http://schemas.microsoft.com/office/drawing/2014/main" id="{20F071B3-C00F-4CB5-A533-50F491465D2E}"/>
+                <a16:creationId xmlns:a16="http://schemas.microsoft.com/office/drawing/2014/main" id="{E098F2C1-67D6-4213-8413-67D3140FDE99}"/>
               </a:ext>
             </a:extLst>
           </p:cNvPr>
@@ -6043,7 +6043,7 @@
           <p:nvPr/>
         </p:nvPicPr>
         <p:blipFill>
-          <a:blip xmlns:r="http://schemas.openxmlformats.org/officeDocument/2006/relationships" xmlns:a="http://schemas.openxmlformats.org/drawingml/2006/main" r:embed="Rf8be720f030146c8"/>
+          <a:blip xmlns:r="http://schemas.openxmlformats.org/officeDocument/2006/relationships" xmlns:a="http://schemas.openxmlformats.org/drawingml/2006/main" r:embed="R80b828adea4c4f86"/>
           <a:stretch xmlns:a="http://schemas.openxmlformats.org/drawingml/2006/main"/>
         </p:blipFill>
         <p:spPr>
@@ -6063,7 +6063,7 @@
           <p:cNvPr id="9" name="">
             <a:extLst xmlns:a="http://schemas.openxmlformats.org/drawingml/2006/main">
               <a:ext uri="{FF2B5EF4-FFF2-40B4-BE49-F238E27FC236}">
-                <a16:creationId xmlns:a16="http://schemas.microsoft.com/office/drawing/2014/main" id="{15D21C4D-7ACA-46DC-89FD-B46824C8DA73}"/>
+                <a16:creationId xmlns:a16="http://schemas.microsoft.com/office/drawing/2014/main" id="{396BAFDB-CBE3-4A80-B6E7-71F0CE967EF0}"/>
               </a:ext>
             </a:extLst>
           </p:cNvPr>
@@ -6113,7 +6113,7 @@
           <p:cNvPr id="10" name="">
             <a:extLst xmlns:a="http://schemas.openxmlformats.org/drawingml/2006/main">
               <a:ext uri="{FF2B5EF4-FFF2-40B4-BE49-F238E27FC236}">
-                <a16:creationId xmlns:a16="http://schemas.microsoft.com/office/drawing/2014/main" id="{702CC90A-BB8D-4546-B2D9-A319DE479F51}"/>
+                <a16:creationId xmlns:a16="http://schemas.microsoft.com/office/drawing/2014/main" id="{DF44D021-3313-450C-9C53-B2C7A4D84076}"/>
               </a:ext>
             </a:extLst>
           </p:cNvPr>
@@ -6163,7 +6163,7 @@
           <p:cNvPr id="11" name="">
             <a:extLst xmlns:a="http://schemas.openxmlformats.org/drawingml/2006/main">
               <a:ext uri="{FF2B5EF4-FFF2-40B4-BE49-F238E27FC236}">
-                <a16:creationId xmlns:a16="http://schemas.microsoft.com/office/drawing/2014/main" id="{504AC125-FC2C-4134-8773-EDAAEB0B076F}"/>
+                <a16:creationId xmlns:a16="http://schemas.microsoft.com/office/drawing/2014/main" id="{0E0A1269-0E2F-4297-9EE5-45C6A987788D}"/>
               </a:ext>
             </a:extLst>
           </p:cNvPr>
@@ -6213,7 +6213,7 @@
           <p:cNvPr id="12" name="">
             <a:extLst xmlns:a="http://schemas.openxmlformats.org/drawingml/2006/main">
               <a:ext uri="{FF2B5EF4-FFF2-40B4-BE49-F238E27FC236}">
-                <a16:creationId xmlns:a16="http://schemas.microsoft.com/office/drawing/2014/main" id="{3117E657-8E27-4F9E-ADC1-3DDC226C8B7E}"/>
+                <a16:creationId xmlns:a16="http://schemas.microsoft.com/office/drawing/2014/main" id="{70F19F30-DC39-4427-B4B6-7D25276EB227}"/>
               </a:ext>
             </a:extLst>
           </p:cNvPr>
@@ -6263,7 +6263,7 @@
           <p:cNvPr id="13" name="">
             <a:extLst xmlns:a="http://schemas.openxmlformats.org/drawingml/2006/main">
               <a:ext uri="{FF2B5EF4-FFF2-40B4-BE49-F238E27FC236}">
-                <a16:creationId xmlns:a16="http://schemas.microsoft.com/office/drawing/2014/main" id="{9C34D3B3-F6A0-470D-BDDC-D77ACC386BBA}"/>
+                <a16:creationId xmlns:a16="http://schemas.microsoft.com/office/drawing/2014/main" id="{6B8CF5E0-18E2-4ED9-8874-2C2D83D748FF}"/>
               </a:ext>
             </a:extLst>
           </p:cNvPr>
@@ -6313,7 +6313,7 @@
           <p:cNvPr id="14" name="">
             <a:extLst xmlns:a="http://schemas.openxmlformats.org/drawingml/2006/main">
               <a:ext uri="{FF2B5EF4-FFF2-40B4-BE49-F238E27FC236}">
-                <a16:creationId xmlns:a16="http://schemas.microsoft.com/office/drawing/2014/main" id="{F23945FA-6B73-4FD2-A11D-1F4A2CC90B70}"/>
+                <a16:creationId xmlns:a16="http://schemas.microsoft.com/office/drawing/2014/main" id="{5228B877-F5C1-42E5-B539-4CEB9EF0D060}"/>
               </a:ext>
             </a:extLst>
           </p:cNvPr>
@@ -6363,7 +6363,7 @@
           <p:cNvPr id="15" name="">
             <a:extLst xmlns:a="http://schemas.openxmlformats.org/drawingml/2006/main">
               <a:ext uri="{FF2B5EF4-FFF2-40B4-BE49-F238E27FC236}">
-                <a16:creationId xmlns:a16="http://schemas.microsoft.com/office/drawing/2014/main" id="{45DB2DFB-EE5A-4485-AC91-0B3833EDF967}"/>
+                <a16:creationId xmlns:a16="http://schemas.microsoft.com/office/drawing/2014/main" id="{B57A2A5A-C6B4-4CC0-8EBD-B12F8C10F2A0}"/>
               </a:ext>
             </a:extLst>
           </p:cNvPr>
@@ -6413,7 +6413,7 @@
           <p:cNvPr id="16" name="">
             <a:extLst xmlns:a="http://schemas.openxmlformats.org/drawingml/2006/main">
               <a:ext uri="{FF2B5EF4-FFF2-40B4-BE49-F238E27FC236}">
-                <a16:creationId xmlns:a16="http://schemas.microsoft.com/office/drawing/2014/main" id="{A3F7A36D-2191-4938-8046-766196AB0184}"/>
+                <a16:creationId xmlns:a16="http://schemas.microsoft.com/office/drawing/2014/main" id="{4F47F77E-F1CC-4906-8CDB-DBB4BA73F616}"/>
               </a:ext>
             </a:extLst>
           </p:cNvPr>
@@ -6453,7 +6453,7 @@
                   <a:srgbClr val="18242E"/>
                 </a:solidFill>
               </a:rPr>
-              <a:t>ConceptMap</a:t>
+              <a:t>ConceptMap + local $translate</a:t>
             </a:r>
           </a:p>
         </p:txBody>
@@ -6463,7 +6463,7 @@
           <p:cNvPr id="17" name="">
             <a:extLst xmlns:a="http://schemas.openxmlformats.org/drawingml/2006/main">
               <a:ext uri="{FF2B5EF4-FFF2-40B4-BE49-F238E27FC236}">
-                <a16:creationId xmlns:a16="http://schemas.microsoft.com/office/drawing/2014/main" id="{DE8F1D2D-DE8F-487F-BE33-564E655C5154}"/>
+                <a16:creationId xmlns:a16="http://schemas.microsoft.com/office/drawing/2014/main" id="{9C2438A4-42B8-496F-A958-99F3CEABA51B}"/>
               </a:ext>
             </a:extLst>
           </p:cNvPr>
@@ -6513,7 +6513,7 @@
           <p:cNvPr id="18" name="">
             <a:extLst xmlns:a="http://schemas.openxmlformats.org/drawingml/2006/main">
               <a:ext uri="{FF2B5EF4-FFF2-40B4-BE49-F238E27FC236}">
-                <a16:creationId xmlns:a16="http://schemas.microsoft.com/office/drawing/2014/main" id="{1A9EDD3B-3D0D-44B3-95A7-AC3B8BD7F171}"/>
+                <a16:creationId xmlns:a16="http://schemas.microsoft.com/office/drawing/2014/main" id="{37DCD45D-F9E5-4099-A80D-DD34108156D3}"/>
               </a:ext>
             </a:extLst>
           </p:cNvPr>
@@ -6563,7 +6563,7 @@
           <p:cNvPr id="19" name="">
             <a:extLst xmlns:a="http://schemas.openxmlformats.org/drawingml/2006/main">
               <a:ext uri="{FF2B5EF4-FFF2-40B4-BE49-F238E27FC236}">
-                <a16:creationId xmlns:a16="http://schemas.microsoft.com/office/drawing/2014/main" id="{54466CFB-E9C6-4B9B-99E5-0CDC3C01BB08}"/>
+                <a16:creationId xmlns:a16="http://schemas.microsoft.com/office/drawing/2014/main" id="{EA763E16-63BF-4446-AA32-6961815847F0}"/>
               </a:ext>
             </a:extLst>
           </p:cNvPr>
@@ -6603,7 +6603,7 @@
                   <a:srgbClr val="18242E"/>
                 </a:solidFill>
               </a:rPr>
-              <a:t>$translate / $lookup / $validate-code</a:t>
+              <a:t>External $lookup / $validate-code</a:t>
             </a:r>
           </a:p>
         </p:txBody>
@@ -6613,7 +6613,7 @@
           <p:cNvPr id="20" name="">
             <a:extLst xmlns:a="http://schemas.openxmlformats.org/drawingml/2006/main">
               <a:ext uri="{FF2B5EF4-FFF2-40B4-BE49-F238E27FC236}">
-                <a16:creationId xmlns:a16="http://schemas.microsoft.com/office/drawing/2014/main" id="{2EEFD8DB-0A56-4A42-BD71-BBEA4CDE8DCB}"/>
+                <a16:creationId xmlns:a16="http://schemas.microsoft.com/office/drawing/2014/main" id="{FDFDFD36-94BF-409F-BE03-881A4F822CE9}"/>
               </a:ext>
             </a:extLst>
           </p:cNvPr>
@@ -6653,7 +6653,7 @@
                   <a:srgbClr val="607283"/>
                 </a:solidFill>
               </a:rPr>
-              <a:t>records validation evidence</a:t>
+              <a:t>tx.fhir.org accepted 4/4 representative codes</a:t>
             </a:r>
           </a:p>
         </p:txBody>
@@ -6663,47 +6663,47 @@
           <p:cNvPr id="21" name="">
             <a:extLst xmlns:a="http://schemas.openxmlformats.org/drawingml/2006/main">
               <a:ext uri="{FF2B5EF4-FFF2-40B4-BE49-F238E27FC236}">
-                <a16:creationId xmlns:a16="http://schemas.microsoft.com/office/drawing/2014/main" id="{62034A06-526A-49A4-B8E0-5C3102FFCA9A}"/>
-              </a:ext>
-            </a:extLst>
-          </p:cNvPr>
-          <p:cNvSpPr>
-            <a:spLocks xmlns:a="http://schemas.openxmlformats.org/drawingml/2006/main" noGrp="1"/>
-          </p:cNvSpPr>
-          <p:nvPr/>
-        </p:nvSpPr>
-        <p:spPr>
-          <a:xfrm xmlns:a="http://schemas.openxmlformats.org/drawingml/2006/main">
-            <a:off x="8058150" y="5743575"/>
-            <a:ext cx="3333750" cy="323850"/>
-          </a:xfrm>
-          <a:prstGeom xmlns:a="http://schemas.openxmlformats.org/drawingml/2006/main" prst="rect">
-            <a:avLst/>
-          </a:prstGeom>
-          <a:noFill xmlns:a="http://schemas.openxmlformats.org/drawingml/2006/main"/>
-          <a:ln xmlns:a="http://schemas.openxmlformats.org/drawingml/2006/main" w="0">
-            <a:noFill/>
-            <a:prstDash val="solid"/>
-          </a:ln>
-        </p:spPr>
-        <p:txBody>
-          <a:bodyPr xmlns:a="http://schemas.openxmlformats.org/drawingml/2006/main"/>
-          <a:lstStyle xmlns:a="http://schemas.openxmlformats.org/drawingml/2006/main"/>
-          <a:p xmlns:a="http://schemas.openxmlformats.org/drawingml/2006/main">
-            <a:pPr algn="l">
-              <a:defRPr sz="1125" b="1">
+                <a16:creationId xmlns:a16="http://schemas.microsoft.com/office/drawing/2014/main" id="{FBE548AC-8FB8-48FE-A3EC-62CD42ABD42B}"/>
+              </a:ext>
+            </a:extLst>
+          </p:cNvPr>
+          <p:cNvSpPr>
+            <a:spLocks xmlns:a="http://schemas.openxmlformats.org/drawingml/2006/main" noGrp="1"/>
+          </p:cNvSpPr>
+          <p:nvPr/>
+        </p:nvSpPr>
+        <p:spPr>
+          <a:xfrm xmlns:a="http://schemas.openxmlformats.org/drawingml/2006/main">
+            <a:off x="8058150" y="5686425"/>
+            <a:ext cx="3333750" cy="457200"/>
+          </a:xfrm>
+          <a:prstGeom xmlns:a="http://schemas.openxmlformats.org/drawingml/2006/main" prst="rect">
+            <a:avLst/>
+          </a:prstGeom>
+          <a:noFill xmlns:a="http://schemas.openxmlformats.org/drawingml/2006/main"/>
+          <a:ln xmlns:a="http://schemas.openxmlformats.org/drawingml/2006/main" w="0">
+            <a:noFill/>
+            <a:prstDash val="solid"/>
+          </a:ln>
+        </p:spPr>
+        <p:txBody>
+          <a:bodyPr xmlns:a="http://schemas.openxmlformats.org/drawingml/2006/main"/>
+          <a:lstStyle xmlns:a="http://schemas.openxmlformats.org/drawingml/2006/main"/>
+          <a:p xmlns:a="http://schemas.openxmlformats.org/drawingml/2006/main">
+            <a:pPr algn="l">
+              <a:defRPr sz="1050" b="1">
                 <a:solidFill>
                   <a:srgbClr val="B66B00"/>
                 </a:solidFill>
               </a:defRPr>
             </a:pPr>
             <a:r>
-              <a:rPr sz="1125" b="1">
+              <a:rPr sz="1050" b="1">
                 <a:solidFill>
                   <a:srgbClr val="B66B00"/>
                 </a:solidFill>
               </a:rPr>
-              <a:t>Below 0.70 confidence → unresolved + human review</a:t>
+              <a:t>External code validity does not prove phrase mapping; low confidence → human review</a:t>
             </a:r>
           </a:p>
         </p:txBody>
@@ -6711,7 +6711,7 @@
     </p:spTree>
     <p:extLst>
       <p:ext uri="{BB962C8B-B14F-4D97-AF65-F5344CB8AC3E}">
-        <p14:creationId xmlns:p14="http://schemas.microsoft.com/office/powerpoint/2010/main" val="1635104799"/>
+        <p14:creationId xmlns:p14="http://schemas.microsoft.com/office/powerpoint/2010/main" val="760647591"/>
       </p:ext>
     </p:extLst>
   </p:cSld>
@@ -6742,7 +6742,7 @@
           <p:cNvPr id="1" name="">
             <a:extLst xmlns:a="http://schemas.openxmlformats.org/drawingml/2006/main">
               <a:ext uri="{FF2B5EF4-FFF2-40B4-BE49-F238E27FC236}">
-                <a16:creationId xmlns:a16="http://schemas.microsoft.com/office/drawing/2014/main" id="{A6AA347A-FBC1-41B7-9348-10D9EDF567DA}"/>
+                <a16:creationId xmlns:a16="http://schemas.microsoft.com/office/drawing/2014/main" id="{5494DB47-85EB-440C-B685-77E21465E0A9}"/>
               </a:ext>
             </a:extLst>
           </p:cNvPr>
@@ -6773,7 +6773,7 @@
           <p:cNvPr id="2" name="">
             <a:extLst xmlns:a="http://schemas.openxmlformats.org/drawingml/2006/main">
               <a:ext uri="{FF2B5EF4-FFF2-40B4-BE49-F238E27FC236}">
-                <a16:creationId xmlns:a16="http://schemas.microsoft.com/office/drawing/2014/main" id="{00DD3931-F9F1-4665-B023-967B06A9CFE2}"/>
+                <a16:creationId xmlns:a16="http://schemas.microsoft.com/office/drawing/2014/main" id="{770F5F28-DBD9-4CE2-A3DF-5D1D3FE3892E}"/>
               </a:ext>
             </a:extLst>
           </p:cNvPr>
@@ -6823,7 +6823,7 @@
           <p:cNvPr id="3" name="">
             <a:extLst xmlns:a="http://schemas.openxmlformats.org/drawingml/2006/main">
               <a:ext uri="{FF2B5EF4-FFF2-40B4-BE49-F238E27FC236}">
-                <a16:creationId xmlns:a16="http://schemas.microsoft.com/office/drawing/2014/main" id="{7D20CA40-D7E3-45B3-9BC7-192B18970CCA}"/>
+                <a16:creationId xmlns:a16="http://schemas.microsoft.com/office/drawing/2014/main" id="{E00CD7DF-11D2-4FC1-86A3-4E959D0F892C}"/>
               </a:ext>
             </a:extLst>
           </p:cNvPr>
@@ -6873,7 +6873,7 @@
           <p:cNvPr id="4" name="">
             <a:extLst xmlns:a="http://schemas.openxmlformats.org/drawingml/2006/main">
               <a:ext uri="{FF2B5EF4-FFF2-40B4-BE49-F238E27FC236}">
-                <a16:creationId xmlns:a16="http://schemas.microsoft.com/office/drawing/2014/main" id="{11690F04-3710-48CD-B488-6097A73C8DB4}"/>
+                <a16:creationId xmlns:a16="http://schemas.microsoft.com/office/drawing/2014/main" id="{CA89B50D-602A-418D-8DE2-1ECB97B678BC}"/>
               </a:ext>
             </a:extLst>
           </p:cNvPr>
@@ -6904,7 +6904,7 @@
           <p:cNvPr id="5" name="">
             <a:extLst xmlns:a="http://schemas.openxmlformats.org/drawingml/2006/main">
               <a:ext uri="{FF2B5EF4-FFF2-40B4-BE49-F238E27FC236}">
-                <a16:creationId xmlns:a16="http://schemas.microsoft.com/office/drawing/2014/main" id="{2336C3B6-CFA1-4B43-8953-AF426F7330D9}"/>
+                <a16:creationId xmlns:a16="http://schemas.microsoft.com/office/drawing/2014/main" id="{28FB0699-A55D-4E36-BB8A-A2197609673A}"/>
               </a:ext>
             </a:extLst>
           </p:cNvPr>
@@ -6954,7 +6954,7 @@
           <p:cNvPr id="6" name="">
             <a:extLst xmlns:a="http://schemas.openxmlformats.org/drawingml/2006/main">
               <a:ext uri="{FF2B5EF4-FFF2-40B4-BE49-F238E27FC236}">
-                <a16:creationId xmlns:a16="http://schemas.microsoft.com/office/drawing/2014/main" id="{7F3A685E-72A6-4CFC-8B88-D4F2350EEEEB}"/>
+                <a16:creationId xmlns:a16="http://schemas.microsoft.com/office/drawing/2014/main" id="{1C87968D-EBB1-432B-9719-542D88A4CAE6}"/>
               </a:ext>
             </a:extLst>
           </p:cNvPr>
@@ -7004,7 +7004,7 @@
           <p:cNvPr id="7" name="">
             <a:extLst xmlns:a="http://schemas.openxmlformats.org/drawingml/2006/main">
               <a:ext uri="{FF2B5EF4-FFF2-40B4-BE49-F238E27FC236}">
-                <a16:creationId xmlns:a16="http://schemas.microsoft.com/office/drawing/2014/main" id="{ADD3CF1A-BC30-4C18-8D31-3601A1394E66}"/>
+                <a16:creationId xmlns:a16="http://schemas.microsoft.com/office/drawing/2014/main" id="{37DE0FBD-01B6-48ED-BC78-AE5A3664FE91}"/>
               </a:ext>
             </a:extLst>
           </p:cNvPr>
@@ -7054,7 +7054,7 @@
           <p:cNvPr id="8" name="">
             <a:extLst xmlns:a="http://schemas.openxmlformats.org/drawingml/2006/main">
               <a:ext uri="{FF2B5EF4-FFF2-40B4-BE49-F238E27FC236}">
-                <a16:creationId xmlns:a16="http://schemas.microsoft.com/office/drawing/2014/main" id="{D7AC36BD-8807-49D2-AA35-4A99550E4880}"/>
+                <a16:creationId xmlns:a16="http://schemas.microsoft.com/office/drawing/2014/main" id="{0837E089-1D88-4A92-9D67-85474B3D0962}"/>
               </a:ext>
             </a:extLst>
           </p:cNvPr>
@@ -7104,7 +7104,7 @@
           <p:cNvPr id="9" name="">
             <a:extLst xmlns:a="http://schemas.openxmlformats.org/drawingml/2006/main">
               <a:ext uri="{FF2B5EF4-FFF2-40B4-BE49-F238E27FC236}">
-                <a16:creationId xmlns:a16="http://schemas.microsoft.com/office/drawing/2014/main" id="{C0F8D04C-7F76-44E1-8136-679FAB8ED3A5}"/>
+                <a16:creationId xmlns:a16="http://schemas.microsoft.com/office/drawing/2014/main" id="{ADAE38D9-85EA-4AD0-A158-EF2360692503}"/>
               </a:ext>
             </a:extLst>
           </p:cNvPr>
@@ -7154,7 +7154,7 @@
           <p:cNvPr id="10" name="">
             <a:extLst xmlns:a="http://schemas.openxmlformats.org/drawingml/2006/main">
               <a:ext uri="{FF2B5EF4-FFF2-40B4-BE49-F238E27FC236}">
-                <a16:creationId xmlns:a16="http://schemas.microsoft.com/office/drawing/2014/main" id="{7880EFD1-90E9-4B45-8184-66E8D2C3A992}"/>
+                <a16:creationId xmlns:a16="http://schemas.microsoft.com/office/drawing/2014/main" id="{5E629739-290D-48A5-816F-5489735B0812}"/>
               </a:ext>
             </a:extLst>
           </p:cNvPr>
@@ -7204,7 +7204,7 @@
           <p:cNvPr id="11" name="">
             <a:extLst xmlns:a="http://schemas.openxmlformats.org/drawingml/2006/main">
               <a:ext uri="{FF2B5EF4-FFF2-40B4-BE49-F238E27FC236}">
-                <a16:creationId xmlns:a16="http://schemas.microsoft.com/office/drawing/2014/main" id="{4C257644-7E0D-46AF-ADA8-2B8C0D7BA095}"/>
+                <a16:creationId xmlns:a16="http://schemas.microsoft.com/office/drawing/2014/main" id="{B48A1498-4271-463E-B581-1E0097D5430E}"/>
               </a:ext>
             </a:extLst>
           </p:cNvPr>
@@ -7254,7 +7254,7 @@
           <p:cNvPr id="12" name="">
             <a:extLst xmlns:a="http://schemas.openxmlformats.org/drawingml/2006/main">
               <a:ext uri="{FF2B5EF4-FFF2-40B4-BE49-F238E27FC236}">
-                <a16:creationId xmlns:a16="http://schemas.microsoft.com/office/drawing/2014/main" id="{5767BEF2-3CCC-416A-9757-93E2C7B2320B}"/>
+                <a16:creationId xmlns:a16="http://schemas.microsoft.com/office/drawing/2014/main" id="{4F3CFDD2-C819-43F4-A7D7-AE0061DD77EC}"/>
               </a:ext>
             </a:extLst>
           </p:cNvPr>
@@ -7304,7 +7304,7 @@
           <p:cNvPr id="13" name="">
             <a:extLst xmlns:a="http://schemas.openxmlformats.org/drawingml/2006/main">
               <a:ext uri="{FF2B5EF4-FFF2-40B4-BE49-F238E27FC236}">
-                <a16:creationId xmlns:a16="http://schemas.microsoft.com/office/drawing/2014/main" id="{862892D2-BD50-42F4-A1FC-83DB9BC3D0C8}"/>
+                <a16:creationId xmlns:a16="http://schemas.microsoft.com/office/drawing/2014/main" id="{6D2010CC-BDA6-4FD7-986F-918BAAEB6DEB}"/>
               </a:ext>
             </a:extLst>
           </p:cNvPr>
@@ -7354,7 +7354,7 @@
           <p:cNvPr id="14" name="">
             <a:extLst xmlns:a="http://schemas.openxmlformats.org/drawingml/2006/main">
               <a:ext uri="{FF2B5EF4-FFF2-40B4-BE49-F238E27FC236}">
-                <a16:creationId xmlns:a16="http://schemas.microsoft.com/office/drawing/2014/main" id="{9E36B759-EC10-4B6B-8F45-E726B50D42C9}"/>
+                <a16:creationId xmlns:a16="http://schemas.microsoft.com/office/drawing/2014/main" id="{820C7C8D-D684-4D48-9327-97CC0653D983}"/>
               </a:ext>
             </a:extLst>
           </p:cNvPr>
@@ -7404,7 +7404,7 @@
           <p:cNvPr id="15" name="">
             <a:extLst xmlns:a="http://schemas.openxmlformats.org/drawingml/2006/main">
               <a:ext uri="{FF2B5EF4-FFF2-40B4-BE49-F238E27FC236}">
-                <a16:creationId xmlns:a16="http://schemas.microsoft.com/office/drawing/2014/main" id="{2377F403-BABB-40A0-859A-81FFD703C7B5}"/>
+                <a16:creationId xmlns:a16="http://schemas.microsoft.com/office/drawing/2014/main" id="{E9F6676D-B5D3-42EB-91E8-EDF62238D023}"/>
               </a:ext>
             </a:extLst>
           </p:cNvPr>
@@ -7443,7 +7443,7 @@
           <p:nvPr/>
         </p:nvPicPr>
         <p:blipFill>
-          <a:blip xmlns:r="http://schemas.openxmlformats.org/officeDocument/2006/relationships" xmlns:a="http://schemas.openxmlformats.org/drawingml/2006/main" r:embed="Ra4318a5d63bd4c85"/>
+          <a:blip xmlns:r="http://schemas.openxmlformats.org/officeDocument/2006/relationships" xmlns:a="http://schemas.openxmlformats.org/drawingml/2006/main" r:embed="R208549ec34dd4ff2"/>
           <a:stretch xmlns:a="http://schemas.openxmlformats.org/drawingml/2006/main"/>
         </p:blipFill>
         <p:spPr>
@@ -7463,7 +7463,7 @@
           <p:cNvPr id="17" name="">
             <a:extLst xmlns:a="http://schemas.openxmlformats.org/drawingml/2006/main">
               <a:ext uri="{FF2B5EF4-FFF2-40B4-BE49-F238E27FC236}">
-                <a16:creationId xmlns:a16="http://schemas.microsoft.com/office/drawing/2014/main" id="{C5F739A0-4509-4009-9A8A-70751AC356E0}"/>
+                <a16:creationId xmlns:a16="http://schemas.microsoft.com/office/drawing/2014/main" id="{7851E69C-D14F-47D7-901E-691BC94BD4D1}"/>
               </a:ext>
             </a:extLst>
           </p:cNvPr>
@@ -7511,7 +7511,7 @@
     </p:spTree>
     <p:extLst>
       <p:ext uri="{BB962C8B-B14F-4D97-AF65-F5344CB8AC3E}">
-        <p14:creationId xmlns:p14="http://schemas.microsoft.com/office/powerpoint/2010/main" val="239124053"/>
+        <p14:creationId xmlns:p14="http://schemas.microsoft.com/office/powerpoint/2010/main" val="432975050"/>
       </p:ext>
     </p:extLst>
   </p:cSld>
@@ -7542,7 +7542,7 @@
           <p:cNvPr id="1" name="">
             <a:extLst xmlns:a="http://schemas.openxmlformats.org/drawingml/2006/main">
               <a:ext uri="{FF2B5EF4-FFF2-40B4-BE49-F238E27FC236}">
-                <a16:creationId xmlns:a16="http://schemas.microsoft.com/office/drawing/2014/main" id="{026D46DD-0D01-46E8-B5C4-7B23DFC33551}"/>
+                <a16:creationId xmlns:a16="http://schemas.microsoft.com/office/drawing/2014/main" id="{B661EC13-4814-4A89-9D09-7783BA434EE5}"/>
               </a:ext>
             </a:extLst>
           </p:cNvPr>
@@ -7573,7 +7573,7 @@
           <p:cNvPr id="2" name="">
             <a:extLst xmlns:a="http://schemas.openxmlformats.org/drawingml/2006/main">
               <a:ext uri="{FF2B5EF4-FFF2-40B4-BE49-F238E27FC236}">
-                <a16:creationId xmlns:a16="http://schemas.microsoft.com/office/drawing/2014/main" id="{29F13E8D-19EA-4795-AE05-2BE38B66E8EA}"/>
+                <a16:creationId xmlns:a16="http://schemas.microsoft.com/office/drawing/2014/main" id="{E680D126-A7EA-46B7-91A3-7A4FAA04F648}"/>
               </a:ext>
             </a:extLst>
           </p:cNvPr>
@@ -7623,7 +7623,7 @@
           <p:cNvPr id="3" name="">
             <a:extLst xmlns:a="http://schemas.openxmlformats.org/drawingml/2006/main">
               <a:ext uri="{FF2B5EF4-FFF2-40B4-BE49-F238E27FC236}">
-                <a16:creationId xmlns:a16="http://schemas.microsoft.com/office/drawing/2014/main" id="{BE788E69-2DB4-406E-B487-00F96A53A5EB}"/>
+                <a16:creationId xmlns:a16="http://schemas.microsoft.com/office/drawing/2014/main" id="{D38F293B-3A1C-4C7A-A505-A0F6599D27E3}"/>
               </a:ext>
             </a:extLst>
           </p:cNvPr>
@@ -7673,7 +7673,7 @@
           <p:cNvPr id="4" name="">
             <a:extLst xmlns:a="http://schemas.openxmlformats.org/drawingml/2006/main">
               <a:ext uri="{FF2B5EF4-FFF2-40B4-BE49-F238E27FC236}">
-                <a16:creationId xmlns:a16="http://schemas.microsoft.com/office/drawing/2014/main" id="{CA15E57B-9179-4AB8-8C88-9FBB2436E840}"/>
+                <a16:creationId xmlns:a16="http://schemas.microsoft.com/office/drawing/2014/main" id="{1DB1C95B-2694-4AFE-BFEF-8B850EEFA924}"/>
               </a:ext>
             </a:extLst>
           </p:cNvPr>
@@ -7704,7 +7704,7 @@
           <p:cNvPr id="5" name="">
             <a:extLst xmlns:a="http://schemas.openxmlformats.org/drawingml/2006/main">
               <a:ext uri="{FF2B5EF4-FFF2-40B4-BE49-F238E27FC236}">
-                <a16:creationId xmlns:a16="http://schemas.microsoft.com/office/drawing/2014/main" id="{2D9F6794-E406-4725-8A49-39219474F08C}"/>
+                <a16:creationId xmlns:a16="http://schemas.microsoft.com/office/drawing/2014/main" id="{250E6AED-C81B-4B9A-909B-3A15F3F31A41}"/>
               </a:ext>
             </a:extLst>
           </p:cNvPr>
@@ -7754,7 +7754,7 @@
           <p:cNvPr id="6" name="">
             <a:extLst xmlns:a="http://schemas.openxmlformats.org/drawingml/2006/main">
               <a:ext uri="{FF2B5EF4-FFF2-40B4-BE49-F238E27FC236}">
-                <a16:creationId xmlns:a16="http://schemas.microsoft.com/office/drawing/2014/main" id="{3B49C7BA-E81F-43AB-9B03-F7242AEBF679}"/>
+                <a16:creationId xmlns:a16="http://schemas.microsoft.com/office/drawing/2014/main" id="{951D46E4-69B3-4E47-85CF-4A7221EC7336}"/>
               </a:ext>
             </a:extLst>
           </p:cNvPr>
@@ -7804,7 +7804,7 @@
           <p:cNvPr id="7" name="">
             <a:extLst xmlns:a="http://schemas.openxmlformats.org/drawingml/2006/main">
               <a:ext uri="{FF2B5EF4-FFF2-40B4-BE49-F238E27FC236}">
-                <a16:creationId xmlns:a16="http://schemas.microsoft.com/office/drawing/2014/main" id="{F9D54D8E-9E08-4AB2-ACBD-3FD17AAA47EB}"/>
+                <a16:creationId xmlns:a16="http://schemas.microsoft.com/office/drawing/2014/main" id="{F95D6B8B-2728-4591-B320-DA8BF1DA47A9}"/>
               </a:ext>
             </a:extLst>
           </p:cNvPr>
@@ -7858,7 +7858,7 @@
           <p:nvPr/>
         </p:nvPicPr>
         <p:blipFill>
-          <a:blip xmlns:r="http://schemas.openxmlformats.org/officeDocument/2006/relationships" xmlns:a="http://schemas.openxmlformats.org/drawingml/2006/main" r:embed="R54c5c16395ef4d49"/>
+          <a:blip xmlns:r="http://schemas.openxmlformats.org/officeDocument/2006/relationships" xmlns:a="http://schemas.openxmlformats.org/drawingml/2006/main" r:embed="Rb52757cdb3c445f0"/>
           <a:stretch xmlns:a="http://schemas.openxmlformats.org/drawingml/2006/main"/>
         </p:blipFill>
         <p:spPr>
@@ -7878,7 +7878,7 @@
           <p:cNvPr id="9" name="">
             <a:extLst xmlns:a="http://schemas.openxmlformats.org/drawingml/2006/main">
               <a:ext uri="{FF2B5EF4-FFF2-40B4-BE49-F238E27FC236}">
-                <a16:creationId xmlns:a16="http://schemas.microsoft.com/office/drawing/2014/main" id="{0A001E9F-9E69-4315-B504-3FF507301097}"/>
+                <a16:creationId xmlns:a16="http://schemas.microsoft.com/office/drawing/2014/main" id="{E81A114B-1BCF-4A66-AFCA-3D7BEC523FAE}"/>
               </a:ext>
             </a:extLst>
           </p:cNvPr>
@@ -7926,7 +7926,7 @@
     </p:spTree>
     <p:extLst>
       <p:ext uri="{BB962C8B-B14F-4D97-AF65-F5344CB8AC3E}">
-        <p14:creationId xmlns:p14="http://schemas.microsoft.com/office/powerpoint/2010/main" val="881195958"/>
+        <p14:creationId xmlns:p14="http://schemas.microsoft.com/office/powerpoint/2010/main" val="1875332533"/>
       </p:ext>
     </p:extLst>
   </p:cSld>
@@ -7957,7 +7957,7 @@
           <p:cNvPr id="1" name="">
             <a:extLst xmlns:a="http://schemas.openxmlformats.org/drawingml/2006/main">
               <a:ext uri="{FF2B5EF4-FFF2-40B4-BE49-F238E27FC236}">
-                <a16:creationId xmlns:a16="http://schemas.microsoft.com/office/drawing/2014/main" id="{49A82FD8-0540-4033-A070-950EC4807AE9}"/>
+                <a16:creationId xmlns:a16="http://schemas.microsoft.com/office/drawing/2014/main" id="{61C4B3BD-B2F6-4F3C-82B0-F7DED8E0D87D}"/>
               </a:ext>
             </a:extLst>
           </p:cNvPr>
@@ -7988,7 +7988,7 @@
           <p:cNvPr id="2" name="">
             <a:extLst xmlns:a="http://schemas.openxmlformats.org/drawingml/2006/main">
               <a:ext uri="{FF2B5EF4-FFF2-40B4-BE49-F238E27FC236}">
-                <a16:creationId xmlns:a16="http://schemas.microsoft.com/office/drawing/2014/main" id="{905192A6-02AE-4F50-BCB1-C672959782CE}"/>
+                <a16:creationId xmlns:a16="http://schemas.microsoft.com/office/drawing/2014/main" id="{1F0FAC79-3C70-42B9-9A6E-DB774E8386CA}"/>
               </a:ext>
             </a:extLst>
           </p:cNvPr>
@@ -8038,7 +8038,7 @@
           <p:cNvPr id="3" name="">
             <a:extLst xmlns:a="http://schemas.openxmlformats.org/drawingml/2006/main">
               <a:ext uri="{FF2B5EF4-FFF2-40B4-BE49-F238E27FC236}">
-                <a16:creationId xmlns:a16="http://schemas.microsoft.com/office/drawing/2014/main" id="{F3B4F65E-9E07-4083-AF68-B62802772E76}"/>
+                <a16:creationId xmlns:a16="http://schemas.microsoft.com/office/drawing/2014/main" id="{E7DD38D4-E35F-4064-B6DE-EF694116AF51}"/>
               </a:ext>
             </a:extLst>
           </p:cNvPr>
@@ -8088,7 +8088,7 @@
           <p:cNvPr id="4" name="">
             <a:extLst xmlns:a="http://schemas.openxmlformats.org/drawingml/2006/main">
               <a:ext uri="{FF2B5EF4-FFF2-40B4-BE49-F238E27FC236}">
-                <a16:creationId xmlns:a16="http://schemas.microsoft.com/office/drawing/2014/main" id="{6B49DCDA-2048-4CFE-9151-CF3B1139343B}"/>
+                <a16:creationId xmlns:a16="http://schemas.microsoft.com/office/drawing/2014/main" id="{09C15524-8BAF-4AC0-87DA-F45A81161BAA}"/>
               </a:ext>
             </a:extLst>
           </p:cNvPr>
@@ -8119,7 +8119,7 @@
           <p:cNvPr id="5" name="">
             <a:extLst xmlns:a="http://schemas.openxmlformats.org/drawingml/2006/main">
               <a:ext uri="{FF2B5EF4-FFF2-40B4-BE49-F238E27FC236}">
-                <a16:creationId xmlns:a16="http://schemas.microsoft.com/office/drawing/2014/main" id="{F9B1662E-F4C8-4489-8B43-6688332342B8}"/>
+                <a16:creationId xmlns:a16="http://schemas.microsoft.com/office/drawing/2014/main" id="{3414F01A-A611-405B-BD10-D1E8C65F4BE6}"/>
               </a:ext>
             </a:extLst>
           </p:cNvPr>
@@ -8169,7 +8169,7 @@
           <p:cNvPr id="6" name="">
             <a:extLst xmlns:a="http://schemas.openxmlformats.org/drawingml/2006/main">
               <a:ext uri="{FF2B5EF4-FFF2-40B4-BE49-F238E27FC236}">
-                <a16:creationId xmlns:a16="http://schemas.microsoft.com/office/drawing/2014/main" id="{09B27E55-8357-41B2-BB91-E1424BF5DFCF}"/>
+                <a16:creationId xmlns:a16="http://schemas.microsoft.com/office/drawing/2014/main" id="{E9271B9D-5CCE-4BE2-BCE1-1D4481282F74}"/>
               </a:ext>
             </a:extLst>
           </p:cNvPr>
@@ -8219,7 +8219,7 @@
           <p:cNvPr id="7" name="">
             <a:extLst xmlns:a="http://schemas.openxmlformats.org/drawingml/2006/main">
               <a:ext uri="{FF2B5EF4-FFF2-40B4-BE49-F238E27FC236}">
-                <a16:creationId xmlns:a16="http://schemas.microsoft.com/office/drawing/2014/main" id="{B0F8612B-BC77-443B-A5F3-4394DED706FF}"/>
+                <a16:creationId xmlns:a16="http://schemas.microsoft.com/office/drawing/2014/main" id="{AD8CFE37-80E2-41E4-B8B0-A60F2DEAA1B6}"/>
               </a:ext>
             </a:extLst>
           </p:cNvPr>
@@ -8259,7 +8259,7 @@
                   <a:srgbClr val="27865C"/>
                 </a:solidFill>
               </a:rPr>
-              <a:t>15/15</a:t>
+              <a:t>16/16</a:t>
             </a:r>
           </a:p>
         </p:txBody>
@@ -8269,7 +8269,7 @@
           <p:cNvPr id="8" name="">
             <a:extLst xmlns:a="http://schemas.openxmlformats.org/drawingml/2006/main">
               <a:ext uri="{FF2B5EF4-FFF2-40B4-BE49-F238E27FC236}">
-                <a16:creationId xmlns:a16="http://schemas.microsoft.com/office/drawing/2014/main" id="{ECC17618-19C5-4161-8619-3D01D882DCD0}"/>
+                <a16:creationId xmlns:a16="http://schemas.microsoft.com/office/drawing/2014/main" id="{4954D6D9-E294-4D9F-8E55-98665164FBEA}"/>
               </a:ext>
             </a:extLst>
           </p:cNvPr>
@@ -8319,7 +8319,7 @@
           <p:cNvPr id="9" name="">
             <a:extLst xmlns:a="http://schemas.openxmlformats.org/drawingml/2006/main">
               <a:ext uri="{FF2B5EF4-FFF2-40B4-BE49-F238E27FC236}">
-                <a16:creationId xmlns:a16="http://schemas.microsoft.com/office/drawing/2014/main" id="{5313CCDA-8A32-468D-B253-DDCC89671C82}"/>
+                <a16:creationId xmlns:a16="http://schemas.microsoft.com/office/drawing/2014/main" id="{0AABA060-393F-4972-A130-8F40CE23E567}"/>
               </a:ext>
             </a:extLst>
           </p:cNvPr>
@@ -8369,7 +8369,7 @@
           <p:cNvPr id="10" name="">
             <a:extLst xmlns:a="http://schemas.openxmlformats.org/drawingml/2006/main">
               <a:ext uri="{FF2B5EF4-FFF2-40B4-BE49-F238E27FC236}">
-                <a16:creationId xmlns:a16="http://schemas.microsoft.com/office/drawing/2014/main" id="{C00625AF-FFBB-447B-832C-BF28099748F8}"/>
+                <a16:creationId xmlns:a16="http://schemas.microsoft.com/office/drawing/2014/main" id="{B871C638-552B-4F78-B99E-0A597350A091}"/>
               </a:ext>
             </a:extLst>
           </p:cNvPr>
@@ -8419,7 +8419,7 @@
           <p:cNvPr id="11" name="">
             <a:extLst xmlns:a="http://schemas.openxmlformats.org/drawingml/2006/main">
               <a:ext uri="{FF2B5EF4-FFF2-40B4-BE49-F238E27FC236}">
-                <a16:creationId xmlns:a16="http://schemas.microsoft.com/office/drawing/2014/main" id="{74E0ED53-ACA7-4E38-899D-78BE6BF756C4}"/>
+                <a16:creationId xmlns:a16="http://schemas.microsoft.com/office/drawing/2014/main" id="{C08BDB5F-68A0-47B2-AB9F-AF83C76BA202}"/>
               </a:ext>
             </a:extLst>
           </p:cNvPr>
@@ -8469,7 +8469,7 @@
           <p:cNvPr id="12" name="">
             <a:extLst xmlns:a="http://schemas.openxmlformats.org/drawingml/2006/main">
               <a:ext uri="{FF2B5EF4-FFF2-40B4-BE49-F238E27FC236}">
-                <a16:creationId xmlns:a16="http://schemas.microsoft.com/office/drawing/2014/main" id="{8EDEA068-E3E3-4E21-9AA9-3800E8586265}"/>
+                <a16:creationId xmlns:a16="http://schemas.microsoft.com/office/drawing/2014/main" id="{D448785E-0C4F-4337-A1C0-2C0E4EFDDADF}"/>
               </a:ext>
             </a:extLst>
           </p:cNvPr>
@@ -8519,7 +8519,7 @@
           <p:cNvPr id="13" name="">
             <a:extLst xmlns:a="http://schemas.openxmlformats.org/drawingml/2006/main">
               <a:ext uri="{FF2B5EF4-FFF2-40B4-BE49-F238E27FC236}">
-                <a16:creationId xmlns:a16="http://schemas.microsoft.com/office/drawing/2014/main" id="{51B5ECD5-8EC5-4976-9252-0EED461661E2}"/>
+                <a16:creationId xmlns:a16="http://schemas.microsoft.com/office/drawing/2014/main" id="{F520D868-D6C5-4888-ABE4-971DA80391E7}"/>
               </a:ext>
             </a:extLst>
           </p:cNvPr>
@@ -8554,42 +8554,42 @@
           <p:cNvPr id="14" name="">
             <a:extLst xmlns:a="http://schemas.openxmlformats.org/drawingml/2006/main">
               <a:ext uri="{FF2B5EF4-FFF2-40B4-BE49-F238E27FC236}">
-                <a16:creationId xmlns:a16="http://schemas.microsoft.com/office/drawing/2014/main" id="{3F97D87B-AA4A-497F-98CF-46EBE61528B0}"/>
-              </a:ext>
-            </a:extLst>
-          </p:cNvPr>
-          <p:cNvSpPr>
-            <a:spLocks xmlns:a="http://schemas.openxmlformats.org/drawingml/2006/main" noGrp="1"/>
-          </p:cNvSpPr>
-          <p:nvPr/>
-        </p:nvSpPr>
-        <p:spPr>
-          <a:xfrm xmlns:a="http://schemas.openxmlformats.org/drawingml/2006/main">
-            <a:off x="4648200" y="1952625"/>
-            <a:ext cx="6286500" cy="3048000"/>
-          </a:xfrm>
-          <a:prstGeom xmlns:a="http://schemas.openxmlformats.org/drawingml/2006/main" prst="rect">
-            <a:avLst/>
-          </a:prstGeom>
-          <a:noFill xmlns:a="http://schemas.openxmlformats.org/drawingml/2006/main"/>
-          <a:ln xmlns:a="http://schemas.openxmlformats.org/drawingml/2006/main" w="0">
-            <a:noFill/>
-            <a:prstDash val="solid"/>
-          </a:ln>
-        </p:spPr>
-        <p:txBody>
-          <a:bodyPr xmlns:a="http://schemas.openxmlformats.org/drawingml/2006/main"/>
-          <a:lstStyle xmlns:a="http://schemas.openxmlformats.org/drawingml/2006/main"/>
-          <a:p xmlns:a="http://schemas.openxmlformats.org/drawingml/2006/main">
-            <a:pPr algn="l">
-              <a:defRPr sz="1650" b="0">
+                <a16:creationId xmlns:a16="http://schemas.microsoft.com/office/drawing/2014/main" id="{9544C46B-23F0-4766-9754-DDE1FACD815C}"/>
+              </a:ext>
+            </a:extLst>
+          </p:cNvPr>
+          <p:cNvSpPr>
+            <a:spLocks xmlns:a="http://schemas.openxmlformats.org/drawingml/2006/main" noGrp="1"/>
+          </p:cNvSpPr>
+          <p:nvPr/>
+        </p:nvSpPr>
+        <p:spPr>
+          <a:xfrm xmlns:a="http://schemas.openxmlformats.org/drawingml/2006/main">
+            <a:off x="4648200" y="1847850"/>
+            <a:ext cx="6286500" cy="3333750"/>
+          </a:xfrm>
+          <a:prstGeom xmlns:a="http://schemas.openxmlformats.org/drawingml/2006/main" prst="rect">
+            <a:avLst/>
+          </a:prstGeom>
+          <a:noFill xmlns:a="http://schemas.openxmlformats.org/drawingml/2006/main"/>
+          <a:ln xmlns:a="http://schemas.openxmlformats.org/drawingml/2006/main" w="0">
+            <a:noFill/>
+            <a:prstDash val="solid"/>
+          </a:ln>
+        </p:spPr>
+        <p:txBody>
+          <a:bodyPr xmlns:a="http://schemas.openxmlformats.org/drawingml/2006/main"/>
+          <a:lstStyle xmlns:a="http://schemas.openxmlformats.org/drawingml/2006/main"/>
+          <a:p xmlns:a="http://schemas.openxmlformats.org/drawingml/2006/main">
+            <a:pPr algn="l">
+              <a:defRPr sz="1425" b="0">
                 <a:solidFill>
                   <a:srgbClr val="DDF7EC"/>
                 </a:solidFill>
               </a:defRPr>
             </a:pPr>
             <a:r>
-              <a:rPr sz="1650" b="0">
+              <a:rPr sz="1425" b="0">
                 <a:solidFill>
                   <a:srgbClr val="DDF7EC"/>
                 </a:solidFill>
@@ -8599,19 +8599,19 @@
           </a:p>
           <a:p xmlns:a="http://schemas.openxmlformats.org/drawingml/2006/main">
             <a:pPr algn="l">
-              <a:defRPr sz="1650" b="0">
+              <a:defRPr sz="1425" b="0">
                 <a:solidFill>
                   <a:srgbClr val="DDF7EC"/>
                 </a:solidFill>
               </a:defRPr>
             </a:pPr>
             <a:r>
-              <a:rPr sz="1650" b="0">
+              <a:rPr sz="1425" b="0">
                 <a:solidFill>
                   <a:srgbClr val="DDF7EC"/>
                 </a:solidFill>
               </a:rPr>
-              <a:t>✓ 15 tests passed</a:t>
+              <a:t>✓ 16 tests passed</a:t>
             </a:r>
           </a:p>
           <a:p xmlns:a="http://schemas.openxmlformats.org/drawingml/2006/main">
@@ -8621,14 +8621,14 @@
           </a:p>
           <a:p xmlns:a="http://schemas.openxmlformats.org/drawingml/2006/main">
             <a:pPr algn="l">
-              <a:defRPr sz="1650" b="0">
+              <a:defRPr sz="1425" b="0">
                 <a:solidFill>
                   <a:srgbClr val="DDF7EC"/>
                 </a:solidFill>
               </a:defRPr>
             </a:pPr>
             <a:r>
-              <a:rPr sz="1650" b="0">
+              <a:rPr sz="1425" b="0">
                 <a:solidFill>
                   <a:srgbClr val="DDF7EC"/>
                 </a:solidFill>
@@ -8638,14 +8638,14 @@
           </a:p>
           <a:p xmlns:a="http://schemas.openxmlformats.org/drawingml/2006/main">
             <a:pPr algn="l">
-              <a:defRPr sz="1650" b="0">
+              <a:defRPr sz="1425" b="0">
                 <a:solidFill>
                   <a:srgbClr val="DDF7EC"/>
                 </a:solidFill>
               </a:defRPr>
             </a:pPr>
             <a:r>
-              <a:rPr sz="1650" b="0">
+              <a:rPr sz="1425" b="0">
                 <a:solidFill>
                   <a:srgbClr val="DDF7EC"/>
                 </a:solidFill>
@@ -8660,14 +8660,14 @@
           </a:p>
           <a:p xmlns:a="http://schemas.openxmlformats.org/drawingml/2006/main">
             <a:pPr algn="l">
-              <a:defRPr sz="1650" b="0">
+              <a:defRPr sz="1425" b="0">
                 <a:solidFill>
                   <a:srgbClr val="DDF7EC"/>
                 </a:solidFill>
               </a:defRPr>
             </a:pPr>
             <a:r>
-              <a:rPr sz="1650" b="0">
+              <a:rPr sz="1425" b="0">
                 <a:solidFill>
                   <a:srgbClr val="DDF7EC"/>
                 </a:solidFill>
@@ -8677,14 +8677,14 @@
           </a:p>
           <a:p xmlns:a="http://schemas.openxmlformats.org/drawingml/2006/main">
             <a:pPr algn="l">
-              <a:defRPr sz="1650" b="0">
+              <a:defRPr sz="1425" b="0">
                 <a:solidFill>
                   <a:srgbClr val="DDF7EC"/>
                 </a:solidFill>
               </a:defRPr>
             </a:pPr>
             <a:r>
-              <a:rPr sz="1650" b="0">
+              <a:rPr sz="1425" b="0">
                 <a:solidFill>
                   <a:srgbClr val="DDF7EC"/>
                 </a:solidFill>
@@ -8692,6 +8692,45 @@
               <a:t>✓ 4 Bundles · 0 errors · 0 warnings</a:t>
             </a:r>
           </a:p>
+          <a:p xmlns:a="http://schemas.openxmlformats.org/drawingml/2006/main">
+            <a:r>
+              <a:t/>
+            </a:r>
+          </a:p>
+          <a:p xmlns:a="http://schemas.openxmlformats.org/drawingml/2006/main">
+            <a:pPr algn="l">
+              <a:defRPr sz="1425" b="0">
+                <a:solidFill>
+                  <a:srgbClr val="DDF7EC"/>
+                </a:solidFill>
+              </a:defRPr>
+            </a:pPr>
+            <a:r>
+              <a:rPr sz="1425" b="0">
+                <a:solidFill>
+                  <a:srgbClr val="DDF7EC"/>
+                </a:solidFill>
+              </a:rPr>
+              <a:t>$ tx.fhir.org terminology snapshot</a:t>
+            </a:r>
+          </a:p>
+          <a:p xmlns:a="http://schemas.openxmlformats.org/drawingml/2006/main">
+            <a:pPr algn="l">
+              <a:defRPr sz="1425" b="0">
+                <a:solidFill>
+                  <a:srgbClr val="DDF7EC"/>
+                </a:solidFill>
+              </a:defRPr>
+            </a:pPr>
+            <a:r>
+              <a:rPr sz="1425" b="0">
+                <a:solidFill>
+                  <a:srgbClr val="DDF7EC"/>
+                </a:solidFill>
+              </a:rPr>
+              <a:t>✓ 4/4 lookup + validate-code</a:t>
+            </a:r>
+          </a:p>
         </p:txBody>
       </p:sp>
       <p:sp>
@@ -8699,19 +8738,19 @@
           <p:cNvPr id="15" name="">
             <a:extLst xmlns:a="http://schemas.openxmlformats.org/drawingml/2006/main">
               <a:ext uri="{FF2B5EF4-FFF2-40B4-BE49-F238E27FC236}">
-                <a16:creationId xmlns:a16="http://schemas.microsoft.com/office/drawing/2014/main" id="{BF29268C-B87E-4E71-8C3E-057EDE74B8A9}"/>
-              </a:ext>
-            </a:extLst>
-          </p:cNvPr>
-          <p:cNvSpPr>
-            <a:spLocks xmlns:a="http://schemas.openxmlformats.org/drawingml/2006/main" noGrp="1"/>
-          </p:cNvSpPr>
-          <p:nvPr/>
-        </p:nvSpPr>
-        <p:spPr>
-          <a:xfrm xmlns:a="http://schemas.openxmlformats.org/drawingml/2006/main">
-            <a:off x="4648200" y="5219700"/>
-            <a:ext cx="6191250" cy="495300"/>
+                <a16:creationId xmlns:a16="http://schemas.microsoft.com/office/drawing/2014/main" id="{2E66E9CC-813C-440E-9431-00CCC82ADAB4}"/>
+              </a:ext>
+            </a:extLst>
+          </p:cNvPr>
+          <p:cNvSpPr>
+            <a:spLocks xmlns:a="http://schemas.openxmlformats.org/drawingml/2006/main" noGrp="1"/>
+          </p:cNvSpPr>
+          <p:nvPr/>
+        </p:nvSpPr>
+        <p:spPr>
+          <a:xfrm xmlns:a="http://schemas.openxmlformats.org/drawingml/2006/main">
+            <a:off x="4648200" y="5314950"/>
+            <a:ext cx="6191250" cy="438150"/>
           </a:xfrm>
           <a:prstGeom xmlns:a="http://schemas.openxmlformats.org/drawingml/2006/main" prst="rect">
             <a:avLst/>
@@ -8739,7 +8778,7 @@
                   <a:srgbClr val="FFFFFF"/>
                 </a:solidFill>
               </a:rPr>
-              <a:t>GitHub includes the real PyTorch clients, FedAvg coordinator, benchmark JSON, Bundles, PDFs, screenshots, and unedited validator logs.</a:t>
+              <a:t>GitHub includes the PyTorch clients, FedAvg coordinator, external terminology snapshot, Bundles, review packet, and unedited validator logs.</a:t>
             </a:r>
           </a:p>
         </p:txBody>
@@ -8747,7 +8786,7 @@
     </p:spTree>
     <p:extLst>
       <p:ext uri="{BB962C8B-B14F-4D97-AF65-F5344CB8AC3E}">
-        <p14:creationId xmlns:p14="http://schemas.microsoft.com/office/powerpoint/2010/main" val="1295120111"/>
+        <p14:creationId xmlns:p14="http://schemas.microsoft.com/office/powerpoint/2010/main" val="376785088"/>
       </p:ext>
     </p:extLst>
   </p:cSld>

</xml_diff>